<commit_message>
Fix SSC deck layout, align bibliography numbering, and tighten clinical wording
Co-authored-by: arena-agent <297053741+arena-agent@users.noreply.github.com>
</commit_message>
<xml_diff>
--- a/deliverables/ssc-pedodonsia/ssc-pedodonsia.pptx
+++ b/deliverables/ssc-pedodonsia/ssc-pedodonsia.pptx
@@ -589,7 +589,7 @@
           <a:lstStyle/>
           <a:p>
             <a:r>
-              <a:t>Enam penyulit ini hampir semuanya bisa dilacak ke preparasi atau pemilihan ukuran. Crown longgar berarti crimping kurang, bukan semen kurang. Crown tidak duduk hampir selalu karena ledge atau kontak yang belum putus. Perdarahan saat try-in berarti margin terlalu panjang. Soal alergi nikel, angkanya sering ditakutkan berlebihan: sensitisasi pada anak Eropa sekitar delapan sampai sepuluh persen, tetapi reaksi klinis terhadap SSC jarang. Yang perlu diingat: jangan menambal masalah adaptasi dengan semen lebih banyak, dan jangan recement gigi yang sudah tidak restorable.</a:t>
+              <a:t>Enam penyulit ini hampir semuanya bisa dilacak ke preparasi atau pemilihan ukuran. Crown longgar berarti crimping kurang, bukan semen kurang. Crown tidak duduk hampir selalu karena ledge atau kontak yang belum putus. Perdarahan saat try-in berarti margin terlalu panjang. Soal alergi nikel, angkanya sering ditakutkan berlebihan: sensitisasi pada anak Eropa sekitar delapan sampai sepuluh persen, tetapi reaksi klinis terhadap SSC jarang. Yang perlu diingat: jangan menambal masalah adaptasi dengan semen lebih banyak, dan jangan recement gigi yang sudah tidak restorable. Pencegahan paling murah ada di preparasi: putuskan kontak sepenuhnya, haluskan ledge, dan verifikasi dengan probe sebelum crown dicoba. Pada tiap kontrol, periksa margin, oklusi, kontak, gingiva, mobilitas, dan tanda perforasi oklusal.</a:t>
             </a:r>
           </a:p>
         </p:txBody>
@@ -1079,7 +1079,7 @@
           <a:lstStyle/>
           <a:p>
             <a:r>
-              <a:t>Referensi 16 sampai 30 melengkapi bagian kasus khusus, alternatif estetik, perilaku, dan epidemiologi Indonesia. Bila ada pertanyaan tentang satu angka, saya bisa tunjukkan halaman atau abstrak sumbernya.</a:t>
+              <a:t>Referensi 16 sampai 33 melengkapi bagian kasus khusus, alternatif estetik, perilaku, dan epidemiologi Indonesia. Bila ada pertanyaan tentang satu angka, saya bisa tunjukkan halaman atau abstrak sumbernya.</a:t>
             </a:r>
           </a:p>
         </p:txBody>
@@ -1289,7 +1289,7 @@
           <a:lstStyle/>
           <a:p>
             <a:r>
-              <a:t>Mulai dari pola yang kita semua lihat. Gigi susu ditambal, beberapa bulan kemudian tepinya terbuka, ditambal lagi, dan akhirnya pulpanya terlibat. Setiap kali kita mengulang, dinding gigi makin tipis. Pada gigi desidui, enamelnya hanya sekitar satu milimeter dan tanduk pulpanya tinggi. Jadi pertanyaannya bukan tambalan mana yang lebih baik, tetapi kapan kita berhenti menambal sebagian dan mulai menutup seluruh gigi.</a:t>
+              <a:t>Mulai dari pola yang kita semua lihat. Gigi desidui ditambal, beberapa bulan kemudian tepinya terbuka, ditambal lagi, dan akhirnya pulpanya terlibat. Setiap kali kita mengulang, dinding gigi makin tipis. Pada gigi desidui, enamelnya hanya sekitar satu milimeter dan tanduk pulpanya tinggi. Jadi pertanyaannya bergeser: kapan kita berhenti menambal sebagian dan mulai menutup seluruh gigi.</a:t>
             </a:r>
           </a:p>
         </p:txBody>
@@ -1429,7 +1429,7 @@
           <a:lstStyle/>
           <a:p>
             <a:r>
-              <a:t>Alur ini yang saya pakai di klinik. Kalau karies sudah lebih dari dua permukaan atau melewati line angle, restorasi langsung mulai sulit dipertahankan, jadi arahnya ke SSC. Sebelum memilih Hall, periksa tanda pulpa ireversibel: nyeri spontan, abses, fistula. Kalau ada, Hall berhenti di situ, dan gigi perlu pulpotomi atau pulpektomi lebih dulu. Kontraindikasi yang sering terlupa adalah resorpsi akar lebih dari setengah dan alergi nikel.</a:t>
+              <a:t>Alur ini dipakai untuk memilih teknik. Kalau karies sudah lebih dari dua permukaan atau melewati line angle, restorasi langsung mulai sulit dipertahankan, jadi arahnya ke SSC. Sebelum memilih Hall, periksa tanda pulpa ireversibel: nyeri spontan, abses, fistula. Kalau ada, Hall berhenti di situ, dan gigi perlu pulpektomi atau ekstraksi lebih dulu. Kontraindikasi yang sering terlupa adalah resorpsi akar lebih dari setengah dan alergi nikel.</a:t>
             </a:r>
           </a:p>
         </p:txBody>
@@ -4840,7 +4840,7 @@
                 </a:solidFill>
                 <a:latin typeface="Calibri"/>
               </a:rPr>
-              <a:t>IIK BHAKTIWIYATA  ·  PROGRAM STUDI KEDOKTERAN GIGI</a:t>
+              <a:t>IIK BHAKTIWIYATA, PROGRAM STUDI KEDOKTERAN GIGI</a:t>
             </a:r>
           </a:p>
         </p:txBody>
@@ -6781,7 +6781,7 @@
                 </a:solidFill>
                 <a:latin typeface="Calibri"/>
               </a:rPr>
-              <a:t>Kontraindikasi. Pilih zirkonia atau komposit.</a:t>
+              <a:t>Sensitisasi 8–10% pada anak Eropa, reaksi klinis jarang. Kontraindikasi bila ada riwayat reaksi.</a:t>
             </a:r>
           </a:p>
         </p:txBody>
@@ -7131,7 +7131,7 @@
                 </a:solidFill>
                 <a:latin typeface="Calibri"/>
               </a:rPr>
-              <a:t>Kindelan 2008 · Randall 2002 · Farias 2022 · Ahlström 2019</a:t>
+              <a:t>Kindelan 2008; Randall 2002; Farias 2022; Ahlström 2019</a:t>
             </a:r>
           </a:p>
         </p:txBody>
@@ -7363,7 +7363,7 @@
                 </a:solidFill>
                 <a:latin typeface="Georgia"/>
               </a:rPr>
-              <a:t>Bukti terkuat ada pada kegagalan mayor, bukan pada estetika</a:t>
+              <a:t>Angka retensi dan angka kegagalan tidak bisa dibandingkan langsung</a:t>
             </a:r>
           </a:p>
         </p:txBody>
@@ -9304,7 +9304,7 @@
                 </a:solidFill>
                 <a:latin typeface="Calibri"/>
               </a:rPr>
-              <a:t>Innes 2011 · Lampl 2025 · Chisini 2018 · Innes 2015 Cochrane</a:t>
+              <a:t>Innes 2011; Lampl 2025; Chisini 2018; Innes 2015 Cochrane</a:t>
             </a:r>
           </a:p>
         </p:txBody>
@@ -11071,7 +11071,7 @@
                 </a:solidFill>
                 <a:latin typeface="Calibri"/>
               </a:rPr>
-              <a:t>Patnana 2022 · Pei &amp; Chen 2023 · Aiem 2017 · Walia 2014</a:t>
+              <a:t>Patnana 2022; Pei &amp; Chen 2023; Aiem 2017; Walia 2014</a:t>
             </a:r>
           </a:p>
         </p:txBody>
@@ -12632,7 +12632,7 @@
                 </a:solidFill>
                 <a:latin typeface="Calibri"/>
               </a:rPr>
-              <a:t>Kindelan 2008 · SDCEP 2025 · Randall 2002</a:t>
+              <a:t>Kindelan 2008; SDCEP 2025; Randall 2002</a:t>
             </a:r>
           </a:p>
         </p:txBody>
@@ -12864,7 +12864,7 @@
                 </a:solidFill>
                 <a:latin typeface="Georgia"/>
               </a:rPr>
-              <a:t>Lima pertanyaan untuk diskusi</a:t>
+              <a:t>Lima soal menguji keputusan pada penyulit umum</a:t>
             </a:r>
           </a:p>
         </p:txBody>
@@ -13541,7 +13541,7 @@
                 </a:solidFill>
                 <a:latin typeface="Calibri"/>
               </a:rPr>
-              <a:t>Kindelan 2008 · AAPD 2024 · Farias 2022 · Randall 2002</a:t>
+              <a:t>Kindelan 2008; AAPD 2024; Farias 2022; Randall 2002</a:t>
             </a:r>
           </a:p>
         </p:txBody>
@@ -14522,7 +14522,7 @@
                 </a:solidFill>
                 <a:latin typeface="Calibri"/>
               </a:rPr>
-              <a:t>Kindelan 2008 · AAPD 2025 · Innes 2015 Cochrane · Lampl 2025</a:t>
+              <a:t>Kindelan 2008; AAPD 2025; Innes 2015 Cochrane; Lampl 2025</a:t>
             </a:r>
           </a:p>
         </p:txBody>
@@ -14895,7 +14895,7 @@
                 </a:solidFill>
                 <a:latin typeface="Calibri"/>
               </a:rPr>
-              <a:t>1. American Academy of Pediatric Dentistry. Pediatric restorative dentistry. Reference Manual. Chicago: AAPD; 2025. p. 473-486.</a:t>
+              <a:t>1. American Academy of Pediatric Dentistry. Pediatric restorative dentistry. Reference Manual. Chicago: AAPD; 2025.</a:t>
             </a:r>
           </a:p>
           <a:p>
@@ -15009,7 +15009,7 @@
                 </a:solidFill>
                 <a:latin typeface="Calibri"/>
               </a:rPr>
-              <a:t>7. Mohamed HA, Abdalla EM, HagOmer NA, Philip N. Conventional versus Hall technique for preformed metal crown restorations of carious primary molars: a randomised controlled trial. Eur Arch Paediatr Dent. 2026;27(2):599-606. doi:10.1007/s40368-025-01128-0</a:t>
+              <a:t>7. Seale NS. The use of stainless steel crowns. Pediatr Dent. 2002;24(5):501-505. PMID 12412965.</a:t>
             </a:r>
           </a:p>
           <a:p>
@@ -15028,7 +15028,7 @@
                 </a:solidFill>
                 <a:latin typeface="Calibri"/>
               </a:rPr>
-              <a:t>8. Chisini LA, Collares K, Cademartori MG, et al. Restorations in primary teeth: a systematic review on survival and reasons for failures. Int J Paediatr Dent. 2018;28(2):123-139. doi:10.1111/ipd.12346</a:t>
+              <a:t>8. Randall RC. Preformed metal crowns for primary and permanent molar teeth: review of the literature. Pediatr Dent. 2002;24(5):489-500. PMID 12412964.</a:t>
             </a:r>
           </a:p>
         </p:txBody>
@@ -15070,7 +15070,7 @@
                 </a:solidFill>
                 <a:latin typeface="Calibri"/>
               </a:rPr>
-              <a:t>9. Joshi RS, Gokhale NS, Hugar SM, et al. Longevity of stainless steel crowns on primary molars: systematic review and meta-analysis. J Sci Soc. 2023;50(1):28-38. doi:10.4103/jss.jss_164_22</a:t>
+              <a:t>9. Seale NS, Randall R. The use of stainless steel crowns: a systematic literature review. Pediatr Dent. 2015;37(2):145-160. PMID 25905656.</a:t>
             </a:r>
           </a:p>
           <a:p>
@@ -15089,7 +15089,7 @@
                 </a:solidFill>
                 <a:latin typeface="Calibri"/>
               </a:rPr>
-              <a:t>10. Lampl S, Gurunathan D, Mehta D, Jogikalmat K. Reasons for crown failures in primary teeth: systematic review and meta-analysis. Interact J Med Res. 2025;14:e57958. doi:10.2196/57958</a:t>
+              <a:t>10. Chisini LA, Collares K, Cademartori MG, et al. Restorations in primary teeth: a systematic review on survival and reasons for failures. Int J Paediatr Dent. 2018;28(2):123-139. doi:10.1111/ipd.12346</a:t>
             </a:r>
           </a:p>
           <a:p>
@@ -15108,7 +15108,7 @@
                 </a:solidFill>
                 <a:latin typeface="Calibri"/>
               </a:rPr>
-              <a:t>11. Randall RC. Preformed metal crowns for primary and permanent molar teeth: review of the literature. Pediatr Dent. 2002;24(5):489-500. PMID 12412964.</a:t>
+              <a:t>11. Joshi RS, Gokhale NS, Hugar SM, et al. Longevity of stainless steel crowns on primary molars: systematic review and meta-analysis. J Sci Soc. 2023;50(1):28-38. doi:10.4103/jss.jss_164_22</a:t>
             </a:r>
           </a:p>
           <a:p>
@@ -15127,7 +15127,7 @@
                 </a:solidFill>
                 <a:latin typeface="Calibri"/>
               </a:rPr>
-              <a:t>12. Amlani DV, Brizuela M. Stainless steel crowns in primary dentition. StatPearls. Treasure Island: StatPearls Publishing; 2023. PMID 34662061.</a:t>
+              <a:t>12. Lampl S, Gurunathan D, Mehta D, Jogikalmat K. Reasons for crown failures in primary teeth: systematic review and meta-analysis. Interact J Med Res. 2025;14:e57958. doi:10.2196/57958</a:t>
             </a:r>
           </a:p>
           <a:p>
@@ -15146,7 +15146,7 @@
                 </a:solidFill>
                 <a:latin typeface="Calibri"/>
               </a:rPr>
-              <a:t>13. AAPD. Use of vital pulp therapies in primary teeth with deep caries lesions. Reference Manual. Chicago: AAPD; 2025.</a:t>
+              <a:t>13. Farias L, Campos MS, Dantas L, et al. Survival of stainless-steel crowns and composite resin restorations in molars affected by MIH. Int J Paediatr Dent. 2022;32(2):240-250. doi:10.1111/ipd.12849</a:t>
             </a:r>
           </a:p>
           <a:p>
@@ -15165,7 +15165,7 @@
                 </a:solidFill>
                 <a:latin typeface="Calibri"/>
               </a:rPr>
-              <a:t>14. AAPD. Molar-incisor hypomineralization. Reference Manual. Chicago: AAPD; 2025.</a:t>
+              <a:t>14. Chaipattanawan N, et al. Longevity of stainless steel crowns as interim restorations on young permanent first molars after vital pulp therapy. Int J Paediatr Dent. 2022;32(6):925-937. doi:10.1111/ipd.12971</a:t>
             </a:r>
           </a:p>
           <a:p>
@@ -15184,7 +15184,7 @@
                 </a:solidFill>
                 <a:latin typeface="Calibri"/>
               </a:rPr>
-              <a:t>15. Farias L, Campos MS, Dantas L, et al. Survival of stainless-steel crowns and composite resin restorations in molars affected by MIH. Int J Paediatr Dent. 2022;32(2):240-250. doi:10.1111/ipd.12849</a:t>
+              <a:t>15. AAPD. Molar-incisor hypomineralization. Reference Manual. Chicago: AAPD; 2025.</a:t>
             </a:r>
           </a:p>
         </p:txBody>
@@ -15643,7 +15643,7 @@
                 </a:solidFill>
                 <a:latin typeface="Calibri"/>
               </a:rPr>
-              <a:t>16. Chaipattanawan N, et al. Longevity of stainless steel crowns as interim restorations on young permanent first molars after vital pulp therapy. Int J Paediatr Dent. 2022. doi:10.1111/ipd.12971</a:t>
+              <a:t>16. AAPD. Use of local anesthesia for pediatric dental patients. Reference Manual. Chicago: AAPD; 2025.</a:t>
             </a:r>
           </a:p>
           <a:p>
@@ -15662,7 +15662,7 @@
                 </a:solidFill>
                 <a:latin typeface="Calibri"/>
               </a:rPr>
-              <a:t>17. Patnana AK, Chugh VK, Chugh A, Vanga NRV, Kumar P. Effectiveness of zirconia crowns compared with stainless steel crowns in primary posterior teeth: systematic review and meta-analysis. J Am Dent Assoc. 2022;153(2):158-166.e5. doi:10.1016/j.adaj.2021.08.005</a:t>
+              <a:t>17. AAPD. Behavior guidance for the pediatric dental patient. Reference Manual. Chicago: AAPD; 2025.</a:t>
             </a:r>
           </a:p>
           <a:p>
@@ -15681,7 +15681,7 @@
                 </a:solidFill>
                 <a:latin typeface="Calibri"/>
               </a:rPr>
-              <a:t>18. Pei SL, Chen MH. Comparison of periodontal health of primary teeth restored with zirconia and stainless steel crowns: systematic review and meta-analysis. J Formos Med Assoc. 2023;122(2):148-156. doi:10.1016/j.jfma.2022.08.015</a:t>
+              <a:t>18. AAPD. Informed consent. Reference Manual. Chicago: AAPD; 2025.</a:t>
             </a:r>
           </a:p>
           <a:p>
@@ -15700,7 +15700,7 @@
                 </a:solidFill>
                 <a:latin typeface="Calibri"/>
               </a:rPr>
-              <a:t>19. Aiem E, Smaïl-Faugeron V, Muller-Bolla M. Aesthetic preformed paediatric crowns: systematic review. Int J Paediatr Dent. 2017;27(4):273-282. doi:10.1111/ipd.12260</a:t>
+              <a:t>19. American Academy of Pediatric Dentistry. Caries-risk assessment and management for infants, children, and adolescents. Reference Manual. Chicago: AAPD; 2025.</a:t>
             </a:r>
           </a:p>
           <a:p>
@@ -15719,7 +15719,7 @@
                 </a:solidFill>
                 <a:latin typeface="Calibri"/>
               </a:rPr>
-              <a:t>20. Walia T, Salami AA, Bashiri R, Hamoodi OM, Rashid F. A randomised controlled trial of three aesthetic full-coronal restorations in primary maxillary teeth. Eur J Paediatr Dent. 2014;15(2):113-118. PMID 25102458.</a:t>
+              <a:t>20. Scottish Dental Clinical Effectiveness Programme. Prevention and management of dental caries in children. 3rd ed. Dundee: SDCEP; 2025.</a:t>
             </a:r>
           </a:p>
           <a:p>
@@ -15738,7 +15738,7 @@
                 </a:solidFill>
                 <a:latin typeface="Calibri"/>
               </a:rPr>
-              <a:t>21. Virupaxi S, Pai R, Mandroli P. Retentive strength of luting cements for stainless steel crowns: a systematic review. J Indian Soc Pedod Prev Dent. 2020;38(1):2-7. doi:10.4103/JISPPD.JISPPD_313_19</a:t>
+              <a:t>21. Innes N, Evans D, Hall N. The Hall Technique. 4th ed. Dundee: University of Dundee; 2015.</a:t>
             </a:r>
           </a:p>
           <a:p>
@@ -15757,7 +15757,7 @@
                 </a:solidFill>
                 <a:latin typeface="Calibri"/>
               </a:rPr>
-              <a:t>22. Scottish Dental Clinical Effectiveness Programme. Prevention and management of dental caries in children. 3rd ed. Dundee: SDCEP; 2025.</a:t>
+              <a:t>22. Amlani DV, Brizuela M. Stainless steel crowns in primary dentition. StatPearls. Treasure Island: StatPearls Publishing; 2023. PMID 34662061.</a:t>
             </a:r>
           </a:p>
           <a:p>
@@ -15776,7 +15776,7 @@
                 </a:solidFill>
                 <a:latin typeface="Calibri"/>
               </a:rPr>
-              <a:t>23. Innes N, Evans D, Hall N. The Hall Technique. 4th ed. Dundee: University of Dundee; 2015.</a:t>
+              <a:t>23. Virupaxi S, Pai R, Mandroli P. Retentive strength of luting cements for stainless steel crowns: a systematic review. J Indian Soc Pedod Prev Dent. 2020;38(1):2-7. doi:10.4103/JISPPD.JISPPD_313_19</a:t>
             </a:r>
           </a:p>
         </p:txBody>
@@ -15818,7 +15818,7 @@
                 </a:solidFill>
                 <a:latin typeface="Calibri"/>
               </a:rPr>
-              <a:t>24. AAPD. Behavior guidance for the pediatric dental patient. Reference Manual. Chicago: AAPD; 2025.</a:t>
+              <a:t>24. Patnana AK, Chugh VK, Chugh A, Vanga NRV, Kumar P. Effectiveness of zirconia crowns compared with stainless steel crowns in primary posterior teeth: systematic review and meta-analysis. J Am Dent Assoc. 2022;153(2):158-166.e5. doi:10.1016/j.adaj.2021.08.005</a:t>
             </a:r>
           </a:p>
           <a:p>
@@ -15837,7 +15837,7 @@
                 </a:solidFill>
                 <a:latin typeface="Calibri"/>
               </a:rPr>
-              <a:t>25. AAPD. Use of local anesthesia for pediatric dental patients. Reference Manual. Chicago: AAPD; 2025.</a:t>
+              <a:t>25. Pei SL, Chen MH. Comparison of periodontal health of primary teeth restored with zirconia and stainless steel crowns: systematic review and meta-analysis. J Formos Med Assoc. 2023;122(2):148-156. doi:10.1016/j.jfma.2022.08.015</a:t>
             </a:r>
           </a:p>
           <a:p>
@@ -15856,7 +15856,7 @@
                 </a:solidFill>
                 <a:latin typeface="Calibri"/>
               </a:rPr>
-              <a:t>26. AAPD. Informed consent. Reference Manual. Chicago: AAPD; 2025.</a:t>
+              <a:t>26. Aiem E, Smaïl-Faugeron V, Muller-Bolla M. Aesthetic preformed paediatric crowns: systematic review. Int J Paediatr Dent. 2017;27(4):273-282. doi:10.1111/ipd.12260</a:t>
             </a:r>
           </a:p>
           <a:p>
@@ -15875,7 +15875,7 @@
                 </a:solidFill>
                 <a:latin typeface="Calibri"/>
               </a:rPr>
-              <a:t>27. Ahlström MG, Thyssen JP, Wennervaldt M, Menné T, Johansen JD. Nickel allergy and allergic contact dermatitis. Contact Dermatitis. 2019;81(4):227-241. doi:10.1111/cod.13327</a:t>
+              <a:t>27. Walia T, Salami AA, Bashiri R, Hamoodi OM, Rashid F. A randomised controlled trial of three aesthetic full-coronal restorations in primary maxillary teeth. Eur J Paediatr Dent. 2014;15(2):113-118. PMID 25102458.</a:t>
             </a:r>
           </a:p>
           <a:p>
@@ -15894,7 +15894,7 @@
                 </a:solidFill>
                 <a:latin typeface="Calibri"/>
               </a:rPr>
-              <a:t>28. Kementerian Kesehatan RI. Laporan Nasional Riskesdas 2018. Jakarta: Badan Litbangkes; 2019.</a:t>
+              <a:t>28. Mohamed HA, Abdalla EM, HagOmer NA, Philip N. Conventional versus Hall technique for preformed metal crown restorations of carious primary molars: a randomised controlled trial. Eur Arch Paediatr Dent. 2026;27(2):599-606. doi:10.1007/s40368-025-01128-0</a:t>
             </a:r>
           </a:p>
           <a:p>
@@ -15913,7 +15913,7 @@
                 </a:solidFill>
                 <a:latin typeface="Calibri"/>
               </a:rPr>
-              <a:t>29. Kementerian Kesehatan RI. Survei Kesehatan Indonesia 2023. Jakarta: Kemenkes RI; 2024.</a:t>
+              <a:t>29. Ahlström MG, Thyssen JP, Wennervaldt M, Menné T, Johansen JD. Nickel allergy and allergic contact dermatitis. Contact Dermatitis. 2019;81(4):227-241. doi:10.1111/cod.13327</a:t>
             </a:r>
           </a:p>
           <a:p>
@@ -15932,7 +15932,7 @@
                 </a:solidFill>
                 <a:latin typeface="Calibri"/>
               </a:rPr>
-              <a:t>30. Miao C, Yang J, Zhu H, et al. Rubber dam isolation for restorative treatment in dental patients. Cochrane Database Syst Rev. 2021;5:CD009858. doi:10.1002/14651858.CD009858.pub3</a:t>
+              <a:t>30. Kementerian Kesehatan RI. Laporan Nasional Riskesdas 2018. Jakarta: Badan Litbangkes; 2019.</a:t>
             </a:r>
           </a:p>
           <a:p>
@@ -15951,7 +15951,7 @@
                 </a:solidFill>
                 <a:latin typeface="Calibri"/>
               </a:rPr>
-              <a:t>31. Seale NS. The use of stainless steel crowns. Pediatr Dent. 2002;24(5):501-505. PMID 12412965.</a:t>
+              <a:t>31. Kementerian Kesehatan RI. Survei Kesehatan Indonesia 2023. Jakarta: Kemenkes RI; 2024.</a:t>
             </a:r>
           </a:p>
         </p:txBody>
@@ -15993,7 +15993,7 @@
                 </a:solidFill>
                 <a:latin typeface="Calibri"/>
               </a:rPr>
-              <a:t>32. Seale NS, Randall R. The use of stainless steel crowns: a systematic literature review. Pediatr Dent. 2015;37(2):145-160. PMID 25905656.</a:t>
+              <a:t>32. AAPD. Use of vital pulp therapies in primary teeth with deep caries lesions. Reference Manual. Chicago: AAPD; 2025.</a:t>
             </a:r>
           </a:p>
           <a:p>
@@ -16012,7 +16012,7 @@
                 </a:solidFill>
                 <a:latin typeface="Calibri"/>
               </a:rPr>
-              <a:t>33. American Academy of Pediatric Dentistry. Caries-risk assessment and management for infants, children, and adolescents. Reference Manual. Chicago: AAPD; 2025.</a:t>
+              <a:t>33. Miao C, Yang J, Zhu H, et al. Rubber dam isolation for restorative treatment in dental patients. Cochrane Database Syst Rev. 2021;5:CD009858. doi:10.1002/14651858.CD009858.pub3</a:t>
             </a:r>
           </a:p>
         </p:txBody>
@@ -18207,7 +18207,7 @@
                 </a:solidFill>
                 <a:latin typeface="Calibri"/>
               </a:rPr>
-              <a:t>Kindelan 2008 · Randall 2002 · Hall Technique Guide 2015 · AAPD 2025 · SDCEP 2025</a:t>
+              <a:t>Kindelan 2008; Randall 2002; Hall Technique Guide 2015; AAPD 2025; SDCEP 2025</a:t>
             </a:r>
           </a:p>
         </p:txBody>
@@ -21744,7 +21744,7 @@
                 </a:solidFill>
                 <a:latin typeface="Calibri"/>
               </a:rPr>
-              <a:t>Kindelan 2008 · AAPD 2025 · Cochrane 2015 · Innes 2011 · Riskesdas 2018</a:t>
+              <a:t>Kindelan 2008; AAPD 2025; Cochrane 2015; Innes 2011; Riskesdas 2018</a:t>
             </a:r>
           </a:p>
         </p:txBody>
@@ -22249,7 +22249,7 @@
                 </a:solidFill>
                 <a:latin typeface="Calibri"/>
               </a:rPr>
-              <a:t>Chisini 2018 · SR/MA, I</a:t>
+              <a:t>Chisini 2018; SR/MA, I</a:t>
             </a:r>
           </a:p>
         </p:txBody>
@@ -22423,7 +22423,7 @@
                 </a:solidFill>
                 <a:latin typeface="Calibri"/>
               </a:rPr>
-              <a:t>Cochrane 2015 · I</a:t>
+              <a:t>Cochrane 2015; I</a:t>
             </a:r>
           </a:p>
         </p:txBody>
@@ -22597,7 +22597,7 @@
                 </a:solidFill>
                 <a:latin typeface="Calibri"/>
               </a:rPr>
-              <a:t>Innes 2011 · RCT, II</a:t>
+              <a:t>Innes 2011; RCT, II</a:t>
             </a:r>
           </a:p>
         </p:txBody>
@@ -23121,7 +23121,7 @@
                 </a:solidFill>
                 <a:latin typeface="Calibri"/>
               </a:rPr>
-              <a:t>Chisini 2018 · Innes 2015 Cochrane · Innes 2011 · AAPD 2025</a:t>
+              <a:t>Chisini 2018; Innes 2015 Cochrane; Innes 2011; AAPD 2025</a:t>
             </a:r>
           </a:p>
         </p:txBody>
@@ -24077,7 +24077,7 @@
                 </a:solidFill>
                 <a:latin typeface="Calibri"/>
               </a:rPr>
-              <a:t>Tanda pulpa ireversibel?  Ya: pulpotomi atau pulpektomi, lalu SSC konvensional.</a:t>
+              <a:t>Tanda pulpa ireversibel?  Ya: pulpektomi atau ekstraksi, lalu SSC bila gigi dipertahankan.</a:t>
             </a:r>
           </a:p>
         </p:txBody>
@@ -24431,7 +24431,7 @@
                 </a:solidFill>
                 <a:latin typeface="Calibri"/>
               </a:rPr>
-              <a:t>Kindelan 2008 · AAPD 2025 · SDCEP 2025 · Hall Technique Guide 2015</a:t>
+              <a:t>Kindelan 2008; AAPD 2025; SDCEP 2025; Hall Technique Guide 2015</a:t>
             </a:r>
           </a:p>
         </p:txBody>
@@ -25925,7 +25925,7 @@
                 </a:solidFill>
                 <a:latin typeface="Calibri"/>
               </a:rPr>
-              <a:t>Kindelan 2008 · Randall 2002 · Amlani &amp; Brizuela 2023</a:t>
+              <a:t>Kindelan 2008; Randall 2002; Amlani &amp; Brizuela 2023</a:t>
             </a:r>
           </a:p>
         </p:txBody>
@@ -26157,7 +26157,7 @@
                 </a:solidFill>
                 <a:latin typeface="Georgia"/>
               </a:rPr>
-              <a:t>Sepuluh langkah, satu per satu</a:t>
+              <a:t>Urutan sepuluh langkah menentukan adaptasi akhir</a:t>
             </a:r>
           </a:p>
         </p:txBody>
@@ -27704,7 +27704,7 @@
                 </a:solidFill>
                 <a:latin typeface="Calibri"/>
               </a:rPr>
-              <a:t>Kindelan 2008 · Randall 2002 · AAPD VPT 2024 · AAPD 2023 anestesi</a:t>
+              <a:t>Kindelan 2008; Randall 2002; AAPD VPT 2024; AAPD 2023 anestesi</a:t>
             </a:r>
           </a:p>
         </p:txBody>
@@ -29379,7 +29379,7 @@
                 </a:solidFill>
                 <a:latin typeface="Calibri"/>
               </a:rPr>
-              <a:t>Innes 2007 · Hall Technique Guide 2015 · SDCEP 2025</a:t>
+              <a:t>Innes 2007; Hall Technique Guide 2015; SDCEP 2025</a:t>
             </a:r>
           </a:p>
         </p:txBody>
@@ -31042,7 +31042,7 @@
                 </a:solidFill>
                 <a:latin typeface="Calibri"/>
               </a:rPr>
-              <a:t>Mohamed 2026 · Innes 2007 · Innes 2015 Cochrane</a:t>
+              <a:t>Mohamed 2026; Innes 2007; Innes 2015 Cochrane</a:t>
             </a:r>
           </a:p>
         </p:txBody>

</xml_diff>

<commit_message>
Ilustrasi: ganti sketsa vektor dengan anatomi bergambar beranotasi
- Sampul, prinsip SSC, preparasi, Hall, alternatif estetik, dan panel langkah memakai ilustrasi anatomi berlabel
- assets/art: SVG anotasi + JPEG deck; assets/src: berkas asli
- tools/build_art.py, tools/render_svg.js, tools/print_pdf.js untuk regenerasi
- PPTX dan PDF dibangun ulang dari sumber yang sama

Co-authored-by: arena-agent <297053741+arena-agent@users.noreply.github.com>
</commit_message>
<xml_diff>
--- a/deliverables/ssc-pedodonsia/ssc-pedodonsia.pptx
+++ b/deliverables/ssc-pedodonsia/ssc-pedodonsia.pptx
@@ -5285,169 +5285,33 @@
           </a:p>
         </p:txBody>
       </p:sp>
-      <p:sp>
-        <p:nvSpPr>
-          <p:cNvPr id="15" name="Freeform 14"/>
-          <p:cNvSpPr/>
-          <p:nvPr/>
-        </p:nvSpPr>
-        <p:spPr>
-          <a:xfrm>
-            <a:off x="8732520" y="1143000"/>
-            <a:ext cx="2436876" cy="2118207"/>
-          </a:xfrm>
-          <a:custGeom>
-            <a:avLst/>
-            <a:gdLst/>
-            <a:ahLst/>
-            <a:cxnLst/>
-            <a:rect l="l" t="t" r="r" b="b"/>
-            <a:pathLst>
-              <a:path w="2436876" h="2118207">
-                <a:moveTo>
-                  <a:pt x="0" y="0"/>
-                </a:moveTo>
-                <a:lnTo>
-                  <a:pt x="0" y="562355"/>
-                </a:lnTo>
-                <a:lnTo>
-                  <a:pt x="243687" y="187452"/>
-                </a:lnTo>
-                <a:lnTo>
-                  <a:pt x="599846" y="299923"/>
-                </a:lnTo>
-                <a:lnTo>
-                  <a:pt x="862279" y="37490"/>
-                </a:lnTo>
-                <a:lnTo>
-                  <a:pt x="1162202" y="299923"/>
-                </a:lnTo>
-                <a:lnTo>
-                  <a:pt x="1499616" y="37490"/>
-                </a:lnTo>
-                <a:lnTo>
-                  <a:pt x="1799539" y="299923"/>
-                </a:lnTo>
-                <a:lnTo>
-                  <a:pt x="2174443" y="187452"/>
-                </a:lnTo>
-                <a:lnTo>
-                  <a:pt x="2436876" y="562355"/>
-                </a:lnTo>
-                <a:lnTo>
-                  <a:pt x="2436876" y="1780794"/>
-                </a:lnTo>
-                <a:lnTo>
-                  <a:pt x="2286914" y="1930755"/>
-                </a:lnTo>
-                <a:lnTo>
-                  <a:pt x="2061972" y="1837029"/>
-                </a:lnTo>
-                <a:lnTo>
-                  <a:pt x="2061972" y="2118207"/>
-                </a:lnTo>
-                <a:lnTo>
-                  <a:pt x="1799539" y="2118207"/>
-                </a:lnTo>
-                <a:lnTo>
-                  <a:pt x="1799539" y="1837029"/>
-                </a:lnTo>
-                <a:lnTo>
-                  <a:pt x="637336" y="1837029"/>
-                </a:lnTo>
-                <a:lnTo>
-                  <a:pt x="637336" y="2118207"/>
-                </a:lnTo>
-                <a:lnTo>
-                  <a:pt x="374904" y="2118207"/>
-                </a:lnTo>
-                <a:lnTo>
-                  <a:pt x="374904" y="1837029"/>
-                </a:lnTo>
-                <a:lnTo>
-                  <a:pt x="149961" y="1930755"/>
-                </a:lnTo>
-                <a:close/>
-              </a:path>
-            </a:pathLst>
-          </a:custGeom>
-          <a:solidFill>
-            <a:srgbClr val="F6DFD7"/>
-          </a:solidFill>
-          <a:ln w="25400">
-            <a:solidFill>
-              <a:srgbClr val="15323A"/>
-            </a:solidFill>
-          </a:ln>
-          <a:effectLst/>
-        </p:spPr>
-        <p:style>
-          <a:lnRef idx="1">
-            <a:schemeClr val="accent1"/>
-          </a:lnRef>
-          <a:fillRef idx="3">
-            <a:schemeClr val="accent1"/>
-          </a:fillRef>
-          <a:effectRef idx="2">
-            <a:schemeClr val="accent1"/>
-          </a:effectRef>
-          <a:fontRef idx="minor">
-            <a:schemeClr val="lt1"/>
-          </a:fontRef>
-        </p:style>
-        <p:txBody>
-          <a:bodyPr rtlCol="0" anchor="ctr"/>
-          <a:lstStyle/>
-          <a:p>
-            <a:pPr algn="ctr"/>
-          </a:p>
-        </p:txBody>
-      </p:sp>
-      <p:sp>
-        <p:nvSpPr>
-          <p:cNvPr id="16" name="TextBox 15"/>
-          <p:cNvSpPr txBox="1"/>
-          <p:nvPr/>
-        </p:nvSpPr>
-        <p:spPr>
-          <a:xfrm>
-            <a:off x="9052560" y="3749039"/>
-            <a:ext cx="2743200" cy="274320"/>
-          </a:xfrm>
-          <a:prstGeom prst="rect">
-            <a:avLst/>
-          </a:prstGeom>
-          <a:noFill/>
-        </p:spPr>
-        <p:txBody>
-          <a:bodyPr wrap="square" lIns="0" rIns="0" tIns="0" bIns="0" anchor="t">
-            <a:spAutoFit/>
-          </a:bodyPr>
-          <a:lstStyle/>
-          <a:p>
-            <a:pPr algn="ctr">
-              <a:lnSpc>
-                <a:spcPct val="112000"/>
-              </a:lnSpc>
-              <a:spcAft>
-                <a:spcPts val="0"/>
-              </a:spcAft>
-            </a:pPr>
-            <a:r>
-              <a:rPr sz="950" b="0" i="0">
-                <a:solidFill>
-                  <a:srgbClr val="7D8F93"/>
-                </a:solidFill>
-                <a:latin typeface="Calibri"/>
-              </a:rPr>
-              <a:t>SSC: coverage koronal penuh</a:t>
-            </a:r>
-          </a:p>
-        </p:txBody>
-      </p:sp>
-      <p:sp>
-        <p:nvSpPr>
-          <p:cNvPr id="17" name="Rectangle 16"/>
+      <p:pic>
+        <p:nvPicPr>
+          <p:cNvPr id="15" name="Picture 14" descr="fig-cover.jpg"/>
+          <p:cNvPicPr>
+            <a:picLocks noChangeAspect="1"/>
+          </p:cNvPicPr>
+          <p:nvPr/>
+        </p:nvPicPr>
+        <p:blipFill>
+          <a:blip r:embed="rId2"/>
+          <a:stretch>
+            <a:fillRect/>
+          </a:stretch>
+        </p:blipFill>
+        <p:spPr>
+          <a:xfrm>
+            <a:off x="8458200" y="868680"/>
+            <a:ext cx="3200400" cy="3635022"/>
+          </a:xfrm>
+          <a:prstGeom prst="rect">
+            <a:avLst/>
+          </a:prstGeom>
+        </p:spPr>
+      </p:pic>
+      <p:sp>
+        <p:nvSpPr>
+          <p:cNvPr id="16" name="Rectangle 15"/>
           <p:cNvSpPr/>
           <p:nvPr/>
         </p:nvSpPr>
@@ -5491,7 +5355,7 @@
       </p:sp>
       <p:sp>
         <p:nvSpPr>
-          <p:cNvPr id="18" name="TextBox 17"/>
+          <p:cNvPr id="17" name="TextBox 16"/>
           <p:cNvSpPr txBox="1"/>
           <p:nvPr/>
         </p:nvSpPr>
@@ -5533,7 +5397,7 @@
       </p:sp>
       <p:sp>
         <p:nvSpPr>
-          <p:cNvPr id="19" name="TextBox 18"/>
+          <p:cNvPr id="18" name="TextBox 17"/>
           <p:cNvSpPr txBox="1"/>
           <p:nvPr/>
         </p:nvSpPr>
@@ -9586,7 +9450,7 @@
       <p:sp>
         <p:nvSpPr>
           <p:cNvPr id="7" name="Rounded Rectangle 6">
-            <a:hlinkClick action="ppaction://hlinksldjump" r:id="rId3"/>
+            <a:hlinkClick action="ppaction://hlinksldjump" r:id="rId4"/>
           </p:cNvPr>
           <p:cNvSpPr/>
           <p:nvPr/>
@@ -9649,7 +9513,7 @@
         <p:spPr>
           <a:xfrm>
             <a:off x="566928" y="1737360"/>
-            <a:ext cx="3401568" cy="2331720"/>
+            <a:ext cx="5349240" cy="1188720"/>
           </a:xfrm>
           <a:prstGeom prst="roundRect">
             <a:avLst>
@@ -9696,8 +9560,8 @@
         </p:nvSpPr>
         <p:spPr>
           <a:xfrm>
-            <a:off x="731520" y="1847088"/>
-            <a:ext cx="3108960" cy="274320"/>
+            <a:off x="749808" y="1856231"/>
+            <a:ext cx="4937760" cy="274320"/>
           </a:xfrm>
           <a:prstGeom prst="rect">
             <a:avLst/>
@@ -9738,8 +9602,8 @@
         </p:nvSpPr>
         <p:spPr>
           <a:xfrm>
-            <a:off x="731520" y="2212848"/>
-            <a:ext cx="3108960" cy="384048"/>
+            <a:off x="749808" y="2167128"/>
+            <a:ext cx="4983480" cy="658368"/>
           </a:xfrm>
           <a:prstGeom prst="rect">
             <a:avLst/>
@@ -9754,118 +9618,34 @@
           <a:p>
             <a:pPr algn="l">
               <a:lnSpc>
-                <a:spcPct val="112000"/>
-              </a:lnSpc>
-              <a:spcAft>
-                <a:spcPts val="0"/>
-              </a:spcAft>
-            </a:pPr>
-            <a:r>
-              <a:rPr sz="930" b="0" i="0">
+                <a:spcPct val="115000"/>
+              </a:lnSpc>
+              <a:spcAft>
+                <a:spcPts val="0"/>
+              </a:spcAft>
+            </a:pPr>
+            <a:r>
+              <a:rPr sz="980" b="0" i="0">
                 <a:solidFill>
                   <a:srgbClr val="47646C"/>
                 </a:solidFill>
                 <a:latin typeface="Calibri"/>
               </a:rPr>
-              <a:t>•  Kegagalan: RR 0,48 (0,15–1,52)</a:t>
-            </a:r>
-          </a:p>
-        </p:txBody>
-      </p:sp>
-      <p:sp>
-        <p:nvSpPr>
-          <p:cNvPr id="11" name="TextBox 10"/>
-          <p:cNvSpPr txBox="1"/>
-          <p:nvPr/>
-        </p:nvSpPr>
-        <p:spPr>
-          <a:xfrm>
-            <a:off x="731520" y="2688336"/>
-            <a:ext cx="3108960" cy="384048"/>
-          </a:xfrm>
-          <a:prstGeom prst="rect">
-            <a:avLst/>
-          </a:prstGeom>
-          <a:noFill/>
-        </p:spPr>
-        <p:txBody>
-          <a:bodyPr wrap="square" lIns="0" rIns="0" tIns="0" bIns="0" anchor="t">
-            <a:spAutoFit/>
-          </a:bodyPr>
-          <a:lstStyle/>
-          <a:p>
-            <a:pPr algn="l">
-              <a:lnSpc>
-                <a:spcPct val="112000"/>
-              </a:lnSpc>
-              <a:spcAft>
-                <a:spcPts val="0"/>
-              </a:spcAft>
-            </a:pPr>
-            <a:r>
-              <a:rPr sz="930" b="0" i="0">
-                <a:solidFill>
-                  <a:srgbClr val="47646C"/>
-                </a:solidFill>
-                <a:latin typeface="Calibri"/>
-              </a:rPr>
-              <a:t>•  Gingiva: MD −0,32 (−0,42 sampai −0,23)</a:t>
-            </a:r>
-          </a:p>
-        </p:txBody>
-      </p:sp>
-      <p:sp>
-        <p:nvSpPr>
-          <p:cNvPr id="12" name="TextBox 11"/>
-          <p:cNvSpPr txBox="1"/>
-          <p:nvPr/>
-        </p:nvSpPr>
-        <p:spPr>
-          <a:xfrm>
-            <a:off x="731520" y="3163824"/>
-            <a:ext cx="3108960" cy="384048"/>
-          </a:xfrm>
-          <a:prstGeom prst="rect">
-            <a:avLst/>
-          </a:prstGeom>
-          <a:noFill/>
-        </p:spPr>
-        <p:txBody>
-          <a:bodyPr wrap="square" lIns="0" rIns="0" tIns="0" bIns="0" anchor="t">
-            <a:spAutoFit/>
-          </a:bodyPr>
-          <a:lstStyle/>
-          <a:p>
-            <a:pPr algn="l">
-              <a:lnSpc>
-                <a:spcPct val="112000"/>
-              </a:lnSpc>
-              <a:spcAft>
-                <a:spcPts val="0"/>
-              </a:spcAft>
-            </a:pPr>
-            <a:r>
-              <a:rPr sz="930" b="0" i="0">
-                <a:solidFill>
-                  <a:srgbClr val="47646C"/>
-                </a:solidFill>
-                <a:latin typeface="Calibri"/>
-              </a:rPr>
-              <a:t>•  Biaya, wear antagonis, sulit direparasi</a:t>
-            </a:r>
-          </a:p>
-        </p:txBody>
-      </p:sp>
-      <p:sp>
-        <p:nvSpPr>
-          <p:cNvPr id="13" name="Rounded Rectangle 12"/>
+              <a:t>Kegagalan: RR 0,48 (0,15–1,52). Gingiva: MD −0,32 (−0,42 sampai −0,23). Biaya, wear antagonis, sulit direparasi.</a:t>
+            </a:r>
+          </a:p>
+        </p:txBody>
+      </p:sp>
+      <p:sp>
+        <p:nvSpPr>
+          <p:cNvPr id="11" name="Rounded Rectangle 10"/>
           <p:cNvSpPr/>
           <p:nvPr/>
         </p:nvSpPr>
         <p:spPr>
           <a:xfrm>
-            <a:off x="4151376" y="1737360"/>
-            <a:ext cx="3401568" cy="2331720"/>
+            <a:off x="566928" y="3063239"/>
+            <a:ext cx="5349240" cy="1188720"/>
           </a:xfrm>
           <a:prstGeom prst="roundRect">
             <a:avLst>
@@ -9906,14 +9686,14 @@
       </p:sp>
       <p:sp>
         <p:nvSpPr>
-          <p:cNvPr id="14" name="TextBox 13"/>
-          <p:cNvSpPr txBox="1"/>
-          <p:nvPr/>
-        </p:nvSpPr>
-        <p:spPr>
-          <a:xfrm>
-            <a:off x="4315968" y="1847088"/>
-            <a:ext cx="3108960" cy="274320"/>
+          <p:cNvPr id="12" name="TextBox 11"/>
+          <p:cNvSpPr txBox="1"/>
+          <p:nvPr/>
+        </p:nvSpPr>
+        <p:spPr>
+          <a:xfrm>
+            <a:off x="749808" y="3182111"/>
+            <a:ext cx="4937760" cy="274320"/>
           </a:xfrm>
           <a:prstGeom prst="rect">
             <a:avLst/>
@@ -9948,14 +9728,14 @@
       </p:sp>
       <p:sp>
         <p:nvSpPr>
-          <p:cNvPr id="15" name="TextBox 14"/>
-          <p:cNvSpPr txBox="1"/>
-          <p:nvPr/>
-        </p:nvSpPr>
-        <p:spPr>
-          <a:xfrm>
-            <a:off x="4315968" y="2212848"/>
-            <a:ext cx="3108960" cy="384048"/>
+          <p:cNvPr id="13" name="TextBox 12"/>
+          <p:cNvSpPr txBox="1"/>
+          <p:nvPr/>
+        </p:nvSpPr>
+        <p:spPr>
+          <a:xfrm>
+            <a:off x="749808" y="3493007"/>
+            <a:ext cx="4983480" cy="658368"/>
           </a:xfrm>
           <a:prstGeom prst="rect">
             <a:avLst/>
@@ -9970,118 +9750,34 @@
           <a:p>
             <a:pPr algn="l">
               <a:lnSpc>
-                <a:spcPct val="112000"/>
-              </a:lnSpc>
-              <a:spcAft>
-                <a:spcPts val="0"/>
-              </a:spcAft>
-            </a:pPr>
-            <a:r>
-              <a:rPr sz="930" b="0" i="0">
+                <a:spcPct val="115000"/>
+              </a:lnSpc>
+              <a:spcAft>
+                <a:spcPts val="0"/>
+              </a:spcAft>
+            </a:pPr>
+            <a:r>
+              <a:rPr sz="980" b="0" i="0">
                 <a:solidFill>
                   <a:srgbClr val="47646C"/>
                 </a:solidFill>
                 <a:latin typeface="Calibri"/>
               </a:rPr>
-              <a:t>•  Retensi 6 bulan: 95% (Walia 2014)</a:t>
-            </a:r>
-          </a:p>
-        </p:txBody>
-      </p:sp>
-      <p:sp>
-        <p:nvSpPr>
-          <p:cNvPr id="16" name="TextBox 15"/>
-          <p:cNvSpPr txBox="1"/>
-          <p:nvPr/>
-        </p:nvSpPr>
-        <p:spPr>
-          <a:xfrm>
-            <a:off x="4315968" y="2688336"/>
-            <a:ext cx="3108960" cy="384048"/>
-          </a:xfrm>
-          <a:prstGeom prst="rect">
-            <a:avLst/>
-          </a:prstGeom>
-          <a:noFill/>
-        </p:spPr>
-        <p:txBody>
-          <a:bodyPr wrap="square" lIns="0" rIns="0" tIns="0" bIns="0" anchor="t">
-            <a:spAutoFit/>
-          </a:bodyPr>
-          <a:lstStyle/>
-          <a:p>
-            <a:pPr algn="l">
-              <a:lnSpc>
-                <a:spcPct val="112000"/>
-              </a:lnSpc>
-              <a:spcAft>
-                <a:spcPts val="0"/>
-              </a:spcAft>
-            </a:pPr>
-            <a:r>
-              <a:rPr sz="930" b="0" i="0">
-                <a:solidFill>
-                  <a:srgbClr val="47646C"/>
-                </a:solidFill>
-                <a:latin typeface="Calibri"/>
-              </a:rPr>
-              <a:t>•  Veneer bisa fraktur</a:t>
-            </a:r>
-          </a:p>
-        </p:txBody>
-      </p:sp>
-      <p:sp>
-        <p:nvSpPr>
-          <p:cNvPr id="17" name="TextBox 16"/>
-          <p:cNvSpPr txBox="1"/>
-          <p:nvPr/>
-        </p:nvSpPr>
-        <p:spPr>
-          <a:xfrm>
-            <a:off x="4315968" y="3163824"/>
-            <a:ext cx="3108960" cy="384048"/>
-          </a:xfrm>
-          <a:prstGeom prst="rect">
-            <a:avLst/>
-          </a:prstGeom>
-          <a:noFill/>
-        </p:spPr>
-        <p:txBody>
-          <a:bodyPr wrap="square" lIns="0" rIns="0" tIns="0" bIns="0" anchor="t">
-            <a:spAutoFit/>
-          </a:bodyPr>
-          <a:lstStyle/>
-          <a:p>
-            <a:pPr algn="l">
-              <a:lnSpc>
-                <a:spcPct val="112000"/>
-              </a:lnSpc>
-              <a:spcAft>
-                <a:spcPts val="0"/>
-              </a:spcAft>
-            </a:pPr>
-            <a:r>
-              <a:rPr sz="930" b="0" i="0">
-                <a:solidFill>
-                  <a:srgbClr val="47646C"/>
-                </a:solidFill>
-                <a:latin typeface="Calibri"/>
-              </a:rPr>
-              <a:t>•  Bukti belum cukup menggantikan SSC</a:t>
-            </a:r>
-          </a:p>
-        </p:txBody>
-      </p:sp>
-      <p:sp>
-        <p:nvSpPr>
-          <p:cNvPr id="18" name="Rounded Rectangle 17"/>
+              <a:t>Retensi 6 bulan 95% (Walia 2014). Veneer bisa fraktur. Bukti belum cukup menggantikan SSC.</a:t>
+            </a:r>
+          </a:p>
+        </p:txBody>
+      </p:sp>
+      <p:sp>
+        <p:nvSpPr>
+          <p:cNvPr id="14" name="Rounded Rectangle 13"/>
           <p:cNvSpPr/>
           <p:nvPr/>
         </p:nvSpPr>
         <p:spPr>
           <a:xfrm>
-            <a:off x="7735823" y="1737360"/>
-            <a:ext cx="3401568" cy="2331720"/>
+            <a:off x="566928" y="4389120"/>
+            <a:ext cx="5349240" cy="1188720"/>
           </a:xfrm>
           <a:prstGeom prst="roundRect">
             <a:avLst>
@@ -10122,14 +9818,14 @@
       </p:sp>
       <p:sp>
         <p:nvSpPr>
-          <p:cNvPr id="19" name="TextBox 18"/>
-          <p:cNvSpPr txBox="1"/>
-          <p:nvPr/>
-        </p:nvSpPr>
-        <p:spPr>
-          <a:xfrm>
-            <a:off x="7900415" y="1847088"/>
-            <a:ext cx="3108960" cy="274320"/>
+          <p:cNvPr id="15" name="TextBox 14"/>
+          <p:cNvSpPr txBox="1"/>
+          <p:nvPr/>
+        </p:nvSpPr>
+        <p:spPr>
+          <a:xfrm>
+            <a:off x="749808" y="4507992"/>
+            <a:ext cx="4937760" cy="274320"/>
           </a:xfrm>
           <a:prstGeom prst="rect">
             <a:avLst/>
@@ -10164,14 +9860,14 @@
       </p:sp>
       <p:sp>
         <p:nvSpPr>
-          <p:cNvPr id="20" name="TextBox 19"/>
-          <p:cNvSpPr txBox="1"/>
-          <p:nvPr/>
-        </p:nvSpPr>
-        <p:spPr>
-          <a:xfrm>
-            <a:off x="7900415" y="2212848"/>
-            <a:ext cx="3108960" cy="384048"/>
+          <p:cNvPr id="16" name="TextBox 15"/>
+          <p:cNvSpPr txBox="1"/>
+          <p:nvPr/>
+        </p:nvSpPr>
+        <p:spPr>
+          <a:xfrm>
+            <a:off x="749808" y="4818888"/>
+            <a:ext cx="4983480" cy="658368"/>
           </a:xfrm>
           <a:prstGeom prst="rect">
             <a:avLst/>
@@ -10186,118 +9882,100 @@
           <a:p>
             <a:pPr algn="l">
               <a:lnSpc>
-                <a:spcPct val="112000"/>
-              </a:lnSpc>
-              <a:spcAft>
-                <a:spcPts val="0"/>
-              </a:spcAft>
-            </a:pPr>
-            <a:r>
-              <a:rPr sz="930" b="0" i="0">
+                <a:spcPct val="115000"/>
+              </a:lnSpc>
+              <a:spcAft>
+                <a:spcPts val="0"/>
+              </a:spcAft>
+            </a:pPr>
+            <a:r>
+              <a:rPr sz="980" b="0" i="0">
                 <a:solidFill>
                   <a:srgbClr val="47646C"/>
                 </a:solidFill>
                 <a:latin typeface="Calibri"/>
               </a:rPr>
-              <a:t>•  Retensi 6 bulan: 78% (Walia 2014)</a:t>
-            </a:r>
-          </a:p>
-        </p:txBody>
-      </p:sp>
-      <p:sp>
-        <p:nvSpPr>
-          <p:cNvPr id="21" name="TextBox 20"/>
-          <p:cNvSpPr txBox="1"/>
-          <p:nvPr/>
-        </p:nvSpPr>
-        <p:spPr>
-          <a:xfrm>
-            <a:off x="7900415" y="2688336"/>
-            <a:ext cx="3108960" cy="384048"/>
-          </a:xfrm>
-          <a:prstGeom prst="rect">
-            <a:avLst/>
-          </a:prstGeom>
-          <a:noFill/>
-        </p:spPr>
-        <p:txBody>
-          <a:bodyPr wrap="square" lIns="0" rIns="0" tIns="0" bIns="0" anchor="t">
-            <a:spAutoFit/>
-          </a:bodyPr>
-          <a:lstStyle/>
-          <a:p>
-            <a:pPr algn="l">
-              <a:lnSpc>
-                <a:spcPct val="112000"/>
-              </a:lnSpc>
-              <a:spcAft>
-                <a:spcPts val="0"/>
-              </a:spcAft>
-            </a:pPr>
-            <a:r>
-              <a:rPr sz="930" b="0" i="0">
-                <a:solidFill>
-                  <a:srgbClr val="47646C"/>
-                </a:solidFill>
-                <a:latin typeface="Calibri"/>
-              </a:rPr>
-              <a:t>•  Sensitif kelembapan</a:t>
-            </a:r>
-          </a:p>
-        </p:txBody>
-      </p:sp>
-      <p:sp>
-        <p:nvSpPr>
-          <p:cNvPr id="22" name="TextBox 21"/>
-          <p:cNvSpPr txBox="1"/>
-          <p:nvPr/>
-        </p:nvSpPr>
-        <p:spPr>
-          <a:xfrm>
-            <a:off x="7900415" y="3163824"/>
-            <a:ext cx="3108960" cy="384048"/>
-          </a:xfrm>
-          <a:prstGeom prst="rect">
-            <a:avLst/>
-          </a:prstGeom>
-          <a:noFill/>
-        </p:spPr>
-        <p:txBody>
-          <a:bodyPr wrap="square" lIns="0" rIns="0" tIns="0" bIns="0" anchor="t">
-            <a:spAutoFit/>
-          </a:bodyPr>
-          <a:lstStyle/>
-          <a:p>
-            <a:pPr algn="l">
-              <a:lnSpc>
-                <a:spcPct val="112000"/>
-              </a:lnSpc>
-              <a:spcAft>
-                <a:spcPts val="0"/>
-              </a:spcAft>
-            </a:pPr>
-            <a:r>
-              <a:rPr sz="930" b="0" i="0">
-                <a:solidFill>
-                  <a:srgbClr val="47646C"/>
-                </a:solidFill>
-                <a:latin typeface="Calibri"/>
-              </a:rPr>
-              <a:t>•  Bukan pilihan utama molar posterior</a:t>
-            </a:r>
-          </a:p>
-        </p:txBody>
-      </p:sp>
-      <p:sp>
-        <p:nvSpPr>
-          <p:cNvPr id="23" name="Rounded Rectangle 22"/>
+              <a:t>Retensi 6 bulan 78% (Walia 2014). Sensitif kelembapan. Bukan pilihan utama molar posterior.</a:t>
+            </a:r>
+          </a:p>
+        </p:txBody>
+      </p:sp>
+      <p:pic>
+        <p:nvPicPr>
+          <p:cNvPr id="17" name="Picture 16" descr="fig-alternatives.jpg"/>
+          <p:cNvPicPr>
+            <a:picLocks noChangeAspect="1"/>
+          </p:cNvPicPr>
+          <p:nvPr/>
+        </p:nvPicPr>
+        <p:blipFill>
+          <a:blip r:embed="rId2"/>
+          <a:stretch>
+            <a:fillRect/>
+          </a:stretch>
+        </p:blipFill>
+        <p:spPr>
+          <a:xfrm>
+            <a:off x="6172200" y="1719072"/>
+            <a:ext cx="5440680" cy="2365513"/>
+          </a:xfrm>
+          <a:prstGeom prst="rect">
+            <a:avLst/>
+          </a:prstGeom>
+        </p:spPr>
+      </p:pic>
+      <p:sp>
+        <p:nvSpPr>
+          <p:cNvPr id="18" name="TextBox 17"/>
+          <p:cNvSpPr txBox="1"/>
+          <p:nvPr/>
+        </p:nvSpPr>
+        <p:spPr>
+          <a:xfrm>
+            <a:off x="6172200" y="4157736"/>
+            <a:ext cx="5440680" cy="274320"/>
+          </a:xfrm>
+          <a:prstGeom prst="rect">
+            <a:avLst/>
+          </a:prstGeom>
+          <a:noFill/>
+        </p:spPr>
+        <p:txBody>
+          <a:bodyPr wrap="square" lIns="0" rIns="0" tIns="0" bIns="0" anchor="t">
+            <a:spAutoFit/>
+          </a:bodyPr>
+          <a:lstStyle/>
+          <a:p>
+            <a:pPr algn="ctr">
+              <a:lnSpc>
+                <a:spcPct val="112000"/>
+              </a:lnSpc>
+              <a:spcAft>
+                <a:spcPts val="0"/>
+              </a:spcAft>
+            </a:pPr>
+            <a:r>
+              <a:rPr sz="850" b="0" i="0">
+                <a:solidFill>
+                  <a:srgbClr val="7D8F93"/>
+                </a:solidFill>
+                <a:latin typeface="Calibri"/>
+              </a:rPr>
+              <a:t>Zirkonia, pre-veneered SSC, dan SSC logam penuh.</a:t>
+            </a:r>
+          </a:p>
+        </p:txBody>
+      </p:sp>
+      <p:sp>
+        <p:nvSpPr>
+          <p:cNvPr id="19" name="Rounded Rectangle 18"/>
           <p:cNvSpPr/>
           <p:nvPr/>
         </p:nvSpPr>
         <p:spPr>
           <a:xfrm>
-            <a:off x="566928" y="4251960"/>
-            <a:ext cx="10561320" cy="1417320"/>
+            <a:off x="6172200" y="4498848"/>
+            <a:ext cx="5440680" cy="1417320"/>
           </a:xfrm>
           <a:prstGeom prst="roundRect">
             <a:avLst>
@@ -10338,14 +10016,14 @@
       </p:sp>
       <p:sp>
         <p:nvSpPr>
-          <p:cNvPr id="24" name="TextBox 23"/>
-          <p:cNvSpPr txBox="1"/>
-          <p:nvPr/>
-        </p:nvSpPr>
-        <p:spPr>
-          <a:xfrm>
-            <a:off x="749808" y="4343400"/>
-            <a:ext cx="4572000" cy="274320"/>
+          <p:cNvPr id="20" name="TextBox 19"/>
+          <p:cNvSpPr txBox="1"/>
+          <p:nvPr/>
+        </p:nvSpPr>
+        <p:spPr>
+          <a:xfrm>
+            <a:off x="6355080" y="4590288"/>
+            <a:ext cx="5029200" cy="274320"/>
           </a:xfrm>
           <a:prstGeom prst="rect">
             <a:avLst/>
@@ -10380,14 +10058,14 @@
       </p:sp>
       <p:sp>
         <p:nvSpPr>
-          <p:cNvPr id="25" name="TextBox 24"/>
-          <p:cNvSpPr txBox="1"/>
-          <p:nvPr/>
-        </p:nvSpPr>
-        <p:spPr>
-          <a:xfrm>
-            <a:off x="749808" y="4590288"/>
-            <a:ext cx="5486400" cy="274320"/>
+          <p:cNvPr id="21" name="TextBox 20"/>
+          <p:cNvSpPr txBox="1"/>
+          <p:nvPr/>
+        </p:nvSpPr>
+        <p:spPr>
+          <a:xfrm>
+            <a:off x="6355080" y="4828032"/>
+            <a:ext cx="5029200" cy="274320"/>
           </a:xfrm>
           <a:prstGeom prst="rect">
             <a:avLst/>
@@ -10422,14 +10100,14 @@
       </p:sp>
       <p:sp>
         <p:nvSpPr>
-          <p:cNvPr id="26" name="TextBox 25"/>
-          <p:cNvSpPr txBox="1"/>
-          <p:nvPr/>
-        </p:nvSpPr>
-        <p:spPr>
-          <a:xfrm>
-            <a:off x="749808" y="4828032"/>
-            <a:ext cx="822960" cy="259080"/>
+          <p:cNvPr id="22" name="TextBox 21"/>
+          <p:cNvSpPr txBox="1"/>
+          <p:nvPr/>
+        </p:nvSpPr>
+        <p:spPr>
+          <a:xfrm>
+            <a:off x="6355080" y="5074920"/>
+            <a:ext cx="960120" cy="259080"/>
           </a:xfrm>
           <a:prstGeom prst="rect">
             <a:avLst/>
@@ -10464,14 +10142,14 @@
       </p:sp>
       <p:sp>
         <p:nvSpPr>
-          <p:cNvPr id="27" name="Rounded Rectangle 26"/>
+          <p:cNvPr id="23" name="Rounded Rectangle 22"/>
           <p:cNvSpPr/>
           <p:nvPr/>
         </p:nvSpPr>
         <p:spPr>
           <a:xfrm>
-            <a:off x="1572768" y="4900574"/>
-            <a:ext cx="4160520" cy="103632"/>
+            <a:off x="7315200" y="5147462"/>
+            <a:ext cx="3383280" cy="103632"/>
           </a:xfrm>
           <a:prstGeom prst="roundRect">
             <a:avLst>
@@ -10510,14 +10188,14 @@
       </p:sp>
       <p:sp>
         <p:nvSpPr>
-          <p:cNvPr id="28" name="Rounded Rectangle 27"/>
+          <p:cNvPr id="24" name="Rounded Rectangle 23"/>
           <p:cNvSpPr/>
           <p:nvPr/>
         </p:nvSpPr>
         <p:spPr>
           <a:xfrm>
-            <a:off x="1572768" y="4900574"/>
-            <a:ext cx="4160520" cy="103632"/>
+            <a:off x="7315200" y="5147462"/>
+            <a:ext cx="3383280" cy="103632"/>
           </a:xfrm>
           <a:prstGeom prst="roundRect">
             <a:avLst>
@@ -10556,13 +10234,13 @@
       </p:sp>
       <p:sp>
         <p:nvSpPr>
-          <p:cNvPr id="29" name="TextBox 28"/>
-          <p:cNvSpPr txBox="1"/>
-          <p:nvPr/>
-        </p:nvSpPr>
-        <p:spPr>
-          <a:xfrm>
-            <a:off x="5715000" y="4828032"/>
+          <p:cNvPr id="25" name="TextBox 24"/>
+          <p:cNvSpPr txBox="1"/>
+          <p:nvPr/>
+        </p:nvSpPr>
+        <p:spPr>
+          <a:xfrm>
+            <a:off x="10680192" y="5074920"/>
             <a:ext cx="658368" cy="259080"/>
           </a:xfrm>
           <a:prstGeom prst="rect">
@@ -10598,14 +10276,14 @@
       </p:sp>
       <p:sp>
         <p:nvSpPr>
-          <p:cNvPr id="30" name="TextBox 29"/>
-          <p:cNvSpPr txBox="1"/>
-          <p:nvPr/>
-        </p:nvSpPr>
-        <p:spPr>
-          <a:xfrm>
-            <a:off x="749808" y="5087112"/>
-            <a:ext cx="822960" cy="259080"/>
+          <p:cNvPr id="26" name="TextBox 25"/>
+          <p:cNvSpPr txBox="1"/>
+          <p:nvPr/>
+        </p:nvSpPr>
+        <p:spPr>
+          <a:xfrm>
+            <a:off x="6355080" y="5334000"/>
+            <a:ext cx="960120" cy="259080"/>
           </a:xfrm>
           <a:prstGeom prst="rect">
             <a:avLst/>
@@ -10640,14 +10318,14 @@
       </p:sp>
       <p:sp>
         <p:nvSpPr>
-          <p:cNvPr id="31" name="Rounded Rectangle 30"/>
+          <p:cNvPr id="27" name="Rounded Rectangle 26"/>
           <p:cNvSpPr/>
           <p:nvPr/>
         </p:nvSpPr>
         <p:spPr>
           <a:xfrm>
-            <a:off x="1572768" y="5159654"/>
-            <a:ext cx="4160520" cy="103632"/>
+            <a:off x="7315200" y="5406542"/>
+            <a:ext cx="3383280" cy="103632"/>
           </a:xfrm>
           <a:prstGeom prst="roundRect">
             <a:avLst>
@@ -10686,14 +10364,14 @@
       </p:sp>
       <p:sp>
         <p:nvSpPr>
-          <p:cNvPr id="32" name="Rounded Rectangle 31"/>
+          <p:cNvPr id="28" name="Rounded Rectangle 27"/>
           <p:cNvSpPr/>
           <p:nvPr/>
         </p:nvSpPr>
         <p:spPr>
           <a:xfrm>
-            <a:off x="1572768" y="5159654"/>
-            <a:ext cx="3952494" cy="103632"/>
+            <a:off x="7315200" y="5406542"/>
+            <a:ext cx="3214116" cy="103632"/>
           </a:xfrm>
           <a:prstGeom prst="roundRect">
             <a:avLst>
@@ -10732,13 +10410,13 @@
       </p:sp>
       <p:sp>
         <p:nvSpPr>
-          <p:cNvPr id="33" name="TextBox 32"/>
-          <p:cNvSpPr txBox="1"/>
-          <p:nvPr/>
-        </p:nvSpPr>
-        <p:spPr>
-          <a:xfrm>
-            <a:off x="5506974" y="5087112"/>
+          <p:cNvPr id="29" name="TextBox 28"/>
+          <p:cNvSpPr txBox="1"/>
+          <p:nvPr/>
+        </p:nvSpPr>
+        <p:spPr>
+          <a:xfrm>
+            <a:off x="10511028" y="5334000"/>
             <a:ext cx="658368" cy="259080"/>
           </a:xfrm>
           <a:prstGeom prst="rect">
@@ -10774,14 +10452,14 @@
       </p:sp>
       <p:sp>
         <p:nvSpPr>
-          <p:cNvPr id="34" name="TextBox 33"/>
-          <p:cNvSpPr txBox="1"/>
-          <p:nvPr/>
-        </p:nvSpPr>
-        <p:spPr>
-          <a:xfrm>
-            <a:off x="749808" y="5346192"/>
-            <a:ext cx="822960" cy="259080"/>
+          <p:cNvPr id="30" name="TextBox 29"/>
+          <p:cNvSpPr txBox="1"/>
+          <p:nvPr/>
+        </p:nvSpPr>
+        <p:spPr>
+          <a:xfrm>
+            <a:off x="6355080" y="5593080"/>
+            <a:ext cx="960120" cy="259080"/>
           </a:xfrm>
           <a:prstGeom prst="rect">
             <a:avLst/>
@@ -10816,14 +10494,14 @@
       </p:sp>
       <p:sp>
         <p:nvSpPr>
-          <p:cNvPr id="35" name="Rounded Rectangle 34"/>
+          <p:cNvPr id="31" name="Rounded Rectangle 30"/>
           <p:cNvSpPr/>
           <p:nvPr/>
         </p:nvSpPr>
         <p:spPr>
           <a:xfrm>
-            <a:off x="1572768" y="5418734"/>
-            <a:ext cx="4160520" cy="103632"/>
+            <a:off x="7315200" y="5665622"/>
+            <a:ext cx="3383280" cy="103632"/>
           </a:xfrm>
           <a:prstGeom prst="roundRect">
             <a:avLst>
@@ -10862,14 +10540,14 @@
       </p:sp>
       <p:sp>
         <p:nvSpPr>
-          <p:cNvPr id="36" name="Rounded Rectangle 35"/>
+          <p:cNvPr id="32" name="Rounded Rectangle 31"/>
           <p:cNvSpPr/>
           <p:nvPr/>
         </p:nvSpPr>
         <p:spPr>
           <a:xfrm>
-            <a:off x="1572768" y="5418734"/>
-            <a:ext cx="3245205" cy="103632"/>
+            <a:off x="7315200" y="5665622"/>
+            <a:ext cx="2638958" cy="103632"/>
           </a:xfrm>
           <a:prstGeom prst="roundRect">
             <a:avLst>
@@ -10908,13 +10586,13 @@
       </p:sp>
       <p:sp>
         <p:nvSpPr>
-          <p:cNvPr id="37" name="TextBox 36"/>
-          <p:cNvSpPr txBox="1"/>
-          <p:nvPr/>
-        </p:nvSpPr>
-        <p:spPr>
-          <a:xfrm>
-            <a:off x="4799685" y="5346192"/>
+          <p:cNvPr id="33" name="TextBox 32"/>
+          <p:cNvSpPr txBox="1"/>
+          <p:nvPr/>
+        </p:nvSpPr>
+        <p:spPr>
+          <a:xfrm>
+            <a:off x="9935870" y="5593080"/>
             <a:ext cx="658368" cy="259080"/>
           </a:xfrm>
           <a:prstGeom prst="rect">
@@ -10950,49 +10628,7 @@
       </p:sp>
       <p:sp>
         <p:nvSpPr>
-          <p:cNvPr id="38" name="TextBox 37"/>
-          <p:cNvSpPr txBox="1"/>
-          <p:nvPr/>
-        </p:nvSpPr>
-        <p:spPr>
-          <a:xfrm>
-            <a:off x="6647688" y="4572000"/>
-            <a:ext cx="4297680" cy="822960"/>
-          </a:xfrm>
-          <a:prstGeom prst="rect">
-            <a:avLst/>
-          </a:prstGeom>
-          <a:noFill/>
-        </p:spPr>
-        <p:txBody>
-          <a:bodyPr wrap="square" lIns="0" rIns="0" tIns="0" bIns="0" anchor="t">
-            <a:spAutoFit/>
-          </a:bodyPr>
-          <a:lstStyle/>
-          <a:p>
-            <a:pPr algn="l">
-              <a:lnSpc>
-                <a:spcPct val="112000"/>
-              </a:lnSpc>
-              <a:spcAft>
-                <a:spcPts val="0"/>
-              </a:spcAft>
-            </a:pPr>
-            <a:r>
-              <a:rPr sz="950" b="0" i="0">
-                <a:solidFill>
-                  <a:srgbClr val="47646C"/>
-                </a:solidFill>
-                <a:latin typeface="Calibri"/>
-              </a:rPr>
-              <a:t>Untuk molar posterior desidui, SSC tetap menjadi pembanding utama dalam SR dan meta-analisis.</a:t>
-            </a:r>
-          </a:p>
-        </p:txBody>
-      </p:sp>
-      <p:sp>
-        <p:nvSpPr>
-          <p:cNvPr id="39" name="Rectangle 38"/>
+          <p:cNvPr id="34" name="Rectangle 33"/>
           <p:cNvSpPr/>
           <p:nvPr/>
         </p:nvSpPr>
@@ -11036,7 +10672,7 @@
       </p:sp>
       <p:sp>
         <p:nvSpPr>
-          <p:cNvPr id="40" name="TextBox 39"/>
+          <p:cNvPr id="35" name="TextBox 34"/>
           <p:cNvSpPr txBox="1"/>
           <p:nvPr/>
         </p:nvSpPr>
@@ -11078,7 +10714,7 @@
       </p:sp>
       <p:sp>
         <p:nvSpPr>
-          <p:cNvPr id="41" name="TextBox 40"/>
+          <p:cNvPr id="36" name="TextBox 35"/>
           <p:cNvSpPr txBox="1"/>
           <p:nvPr/>
         </p:nvSpPr>
@@ -22026,7 +21662,7 @@
       <p:sp>
         <p:nvSpPr>
           <p:cNvPr id="7" name="Rounded Rectangle 6">
-            <a:hlinkClick action="ppaction://hlinksldjump" r:id="rId3"/>
+            <a:hlinkClick action="ppaction://hlinksldjump" r:id="rId4"/>
           </p:cNvPr>
           <p:cNvSpPr/>
           <p:nvPr/>
@@ -22602,16 +22238,82 @@
           </a:p>
         </p:txBody>
       </p:sp>
-      <p:sp>
-        <p:nvSpPr>
-          <p:cNvPr id="20" name="Rounded Rectangle 19"/>
+      <p:pic>
+        <p:nvPicPr>
+          <p:cNvPr id="20" name="Picture 19" descr="fig-why.jpg"/>
+          <p:cNvPicPr>
+            <a:picLocks noChangeAspect="1"/>
+          </p:cNvPicPr>
+          <p:nvPr/>
+        </p:nvPicPr>
+        <p:blipFill>
+          <a:blip r:embed="rId2"/>
+          <a:stretch>
+            <a:fillRect/>
+          </a:stretch>
+        </p:blipFill>
+        <p:spPr>
+          <a:xfrm>
+            <a:off x="566928" y="3108960"/>
+            <a:ext cx="4297680" cy="2817368"/>
+          </a:xfrm>
+          <a:prstGeom prst="rect">
+            <a:avLst/>
+          </a:prstGeom>
+        </p:spPr>
+      </p:pic>
+      <p:sp>
+        <p:nvSpPr>
+          <p:cNvPr id="21" name="TextBox 20"/>
+          <p:cNvSpPr txBox="1"/>
+          <p:nvPr/>
+        </p:nvSpPr>
+        <p:spPr>
+          <a:xfrm>
+            <a:off x="566928" y="5999480"/>
+            <a:ext cx="4297680" cy="274320"/>
+          </a:xfrm>
+          <a:prstGeom prst="rect">
+            <a:avLst/>
+          </a:prstGeom>
+          <a:noFill/>
+        </p:spPr>
+        <p:txBody>
+          <a:bodyPr wrap="square" lIns="0" rIns="0" tIns="0" bIns="0" anchor="t">
+            <a:spAutoFit/>
+          </a:bodyPr>
+          <a:lstStyle/>
+          <a:p>
+            <a:pPr algn="ctr">
+              <a:lnSpc>
+                <a:spcPct val="112000"/>
+              </a:lnSpc>
+              <a:spcAft>
+                <a:spcPts val="0"/>
+              </a:spcAft>
+            </a:pPr>
+            <a:r>
+              <a:rPr sz="850" b="0" i="0">
+                <a:solidFill>
+                  <a:srgbClr val="7D8F93"/>
+                </a:solidFill>
+                <a:latin typeface="Calibri"/>
+              </a:rPr>
+              <a:t>Penampang molar desidui dengan crown terpasang.</a:t>
+            </a:r>
+          </a:p>
+        </p:txBody>
+      </p:sp>
+      <p:sp>
+        <p:nvSpPr>
+          <p:cNvPr id="22" name="Rounded Rectangle 21"/>
           <p:cNvSpPr/>
           <p:nvPr/>
         </p:nvSpPr>
         <p:spPr>
           <a:xfrm>
-            <a:off x="566928" y="3246120"/>
-            <a:ext cx="3520440" cy="1170432"/>
+            <a:off x="5623560" y="3127248"/>
+            <a:ext cx="5532120" cy="914400"/>
           </a:xfrm>
           <a:prstGeom prst="roundRect">
             <a:avLst>
@@ -22652,14 +22354,14 @@
       </p:sp>
       <p:sp>
         <p:nvSpPr>
-          <p:cNvPr id="21" name="TextBox 20"/>
-          <p:cNvSpPr txBox="1"/>
-          <p:nvPr/>
-        </p:nvSpPr>
-        <p:spPr>
-          <a:xfrm>
-            <a:off x="749808" y="3401568"/>
-            <a:ext cx="3154680" cy="274320"/>
+          <p:cNvPr id="23" name="TextBox 22"/>
+          <p:cNvSpPr txBox="1"/>
+          <p:nvPr/>
+        </p:nvSpPr>
+        <p:spPr>
+          <a:xfrm>
+            <a:off x="5806440" y="3255264"/>
+            <a:ext cx="5120640" cy="274320"/>
           </a:xfrm>
           <a:prstGeom prst="rect">
             <a:avLst/>
@@ -22681,27 +22383,27 @@
               </a:spcAft>
             </a:pPr>
             <a:r>
-              <a:rPr sz="1200" b="1" i="0">
+              <a:rPr sz="1300" b="1" i="0">
                 <a:solidFill>
                   <a:srgbClr val="15323A"/>
                 </a:solidFill>
                 <a:latin typeface="Calibri"/>
               </a:rPr>
-              <a:t>Menutup seluruh korona</a:t>
-            </a:r>
-          </a:p>
-        </p:txBody>
-      </p:sp>
-      <p:sp>
-        <p:nvSpPr>
-          <p:cNvPr id="22" name="TextBox 21"/>
-          <p:cNvSpPr txBox="1"/>
-          <p:nvPr/>
-        </p:nvSpPr>
-        <p:spPr>
-          <a:xfrm>
-            <a:off x="749808" y="3712463"/>
-            <a:ext cx="3154680" cy="566928"/>
+              <a:t>Retensi dari servikal</a:t>
+            </a:r>
+          </a:p>
+        </p:txBody>
+      </p:sp>
+      <p:sp>
+        <p:nvSpPr>
+          <p:cNvPr id="24" name="TextBox 23"/>
+          <p:cNvSpPr txBox="1"/>
+          <p:nvPr/>
+        </p:nvSpPr>
+        <p:spPr>
+          <a:xfrm>
+            <a:off x="5806440" y="3566160"/>
+            <a:ext cx="5166360" cy="402336"/>
           </a:xfrm>
           <a:prstGeom prst="rect">
             <a:avLst/>
@@ -22729,21 +22431,21 @@
                 </a:solidFill>
                 <a:latin typeface="Calibri"/>
               </a:rPr>
-              <a:t>Tidak ada tepi restorasi.</a:t>
-            </a:r>
-          </a:p>
-        </p:txBody>
-      </p:sp>
-      <p:sp>
-        <p:nvSpPr>
-          <p:cNvPr id="23" name="Rounded Rectangle 22"/>
+              <a:t>Undercut di bawah bulbositas menahan crown, bukan semen.</a:t>
+            </a:r>
+          </a:p>
+        </p:txBody>
+      </p:sp>
+      <p:sp>
+        <p:nvSpPr>
+          <p:cNvPr id="25" name="Rounded Rectangle 24"/>
           <p:cNvSpPr/>
           <p:nvPr/>
         </p:nvSpPr>
         <p:spPr>
           <a:xfrm>
-            <a:off x="4334256" y="3246120"/>
-            <a:ext cx="3520440" cy="1170432"/>
+            <a:off x="5623560" y="4160520"/>
+            <a:ext cx="5532120" cy="914400"/>
           </a:xfrm>
           <a:prstGeom prst="roundRect">
             <a:avLst>
@@ -22784,14 +22486,14 @@
       </p:sp>
       <p:sp>
         <p:nvSpPr>
-          <p:cNvPr id="24" name="TextBox 23"/>
-          <p:cNvSpPr txBox="1"/>
-          <p:nvPr/>
-        </p:nvSpPr>
-        <p:spPr>
-          <a:xfrm>
-            <a:off x="4517136" y="3401568"/>
-            <a:ext cx="3154680" cy="274320"/>
+          <p:cNvPr id="26" name="TextBox 25"/>
+          <p:cNvSpPr txBox="1"/>
+          <p:nvPr/>
+        </p:nvSpPr>
+        <p:spPr>
+          <a:xfrm>
+            <a:off x="5806440" y="4288536"/>
+            <a:ext cx="5120640" cy="274320"/>
           </a:xfrm>
           <a:prstGeom prst="rect">
             <a:avLst/>
@@ -22813,7 +22515,7 @@
               </a:spcAft>
             </a:pPr>
             <a:r>
-              <a:rPr sz="1200" b="1" i="0">
+              <a:rPr sz="1300" b="1" i="0">
                 <a:solidFill>
                   <a:srgbClr val="15323A"/>
                 </a:solidFill>
@@ -22826,14 +22528,14 @@
       </p:sp>
       <p:sp>
         <p:nvSpPr>
-          <p:cNvPr id="25" name="TextBox 24"/>
-          <p:cNvSpPr txBox="1"/>
-          <p:nvPr/>
-        </p:nvSpPr>
-        <p:spPr>
-          <a:xfrm>
-            <a:off x="4517136" y="3712463"/>
-            <a:ext cx="3154680" cy="566928"/>
+          <p:cNvPr id="27" name="TextBox 26"/>
+          <p:cNvSpPr txBox="1"/>
+          <p:nvPr/>
+        </p:nvSpPr>
+        <p:spPr>
+          <a:xfrm>
+            <a:off x="5806440" y="4599431"/>
+            <a:ext cx="5166360" cy="402336"/>
           </a:xfrm>
           <a:prstGeom prst="rect">
             <a:avLst/>
@@ -22868,14 +22570,14 @@
       </p:sp>
       <p:sp>
         <p:nvSpPr>
-          <p:cNvPr id="26" name="Rounded Rectangle 25"/>
+          <p:cNvPr id="28" name="Rounded Rectangle 27"/>
           <p:cNvSpPr/>
           <p:nvPr/>
         </p:nvSpPr>
         <p:spPr>
           <a:xfrm>
-            <a:off x="8101583" y="3246120"/>
-            <a:ext cx="3520440" cy="1170432"/>
+            <a:off x="5623560" y="5193792"/>
+            <a:ext cx="5532120" cy="914400"/>
           </a:xfrm>
           <a:prstGeom prst="roundRect">
             <a:avLst>
@@ -22916,14 +22618,14 @@
       </p:sp>
       <p:sp>
         <p:nvSpPr>
-          <p:cNvPr id="27" name="TextBox 26"/>
-          <p:cNvSpPr txBox="1"/>
-          <p:nvPr/>
-        </p:nvSpPr>
-        <p:spPr>
-          <a:xfrm>
-            <a:off x="8284463" y="3401568"/>
-            <a:ext cx="3154680" cy="274320"/>
+          <p:cNvPr id="29" name="TextBox 28"/>
+          <p:cNvSpPr txBox="1"/>
+          <p:nvPr/>
+        </p:nvSpPr>
+        <p:spPr>
+          <a:xfrm>
+            <a:off x="5806440" y="5321807"/>
+            <a:ext cx="5120640" cy="274320"/>
           </a:xfrm>
           <a:prstGeom prst="rect">
             <a:avLst/>
@@ -22945,7 +22647,7 @@
               </a:spcAft>
             </a:pPr>
             <a:r>
-              <a:rPr sz="1200" b="1" i="0">
+              <a:rPr sz="1300" b="1" i="0">
                 <a:solidFill>
                   <a:srgbClr val="15323A"/>
                 </a:solidFill>
@@ -22958,14 +22660,14 @@
       </p:sp>
       <p:sp>
         <p:nvSpPr>
-          <p:cNvPr id="28" name="TextBox 27"/>
-          <p:cNvSpPr txBox="1"/>
-          <p:nvPr/>
-        </p:nvSpPr>
-        <p:spPr>
-          <a:xfrm>
-            <a:off x="8284463" y="3712463"/>
-            <a:ext cx="3154680" cy="566928"/>
+          <p:cNvPr id="30" name="TextBox 29"/>
+          <p:cNvSpPr txBox="1"/>
+          <p:nvPr/>
+        </p:nvSpPr>
+        <p:spPr>
+          <a:xfrm>
+            <a:off x="5806440" y="5632704"/>
+            <a:ext cx="5166360" cy="402336"/>
           </a:xfrm>
           <a:prstGeom prst="rect">
             <a:avLst/>
@@ -23000,49 +22702,7 @@
       </p:sp>
       <p:sp>
         <p:nvSpPr>
-          <p:cNvPr id="29" name="TextBox 28"/>
-          <p:cNvSpPr txBox="1"/>
-          <p:nvPr/>
-        </p:nvSpPr>
-        <p:spPr>
-          <a:xfrm>
-            <a:off x="566928" y="4709160"/>
-            <a:ext cx="10789920" cy="640080"/>
-          </a:xfrm>
-          <a:prstGeom prst="rect">
-            <a:avLst/>
-          </a:prstGeom>
-          <a:noFill/>
-        </p:spPr>
-        <p:txBody>
-          <a:bodyPr wrap="square" lIns="0" rIns="0" tIns="0" bIns="0" anchor="t">
-            <a:spAutoFit/>
-          </a:bodyPr>
-          <a:lstStyle/>
-          <a:p>
-            <a:pPr algn="l">
-              <a:lnSpc>
-                <a:spcPct val="112000"/>
-              </a:lnSpc>
-              <a:spcAft>
-                <a:spcPts val="0"/>
-              </a:spcAft>
-            </a:pPr>
-            <a:r>
-              <a:rPr sz="1200" b="0" i="0">
-                <a:solidFill>
-                  <a:srgbClr val="47646C"/>
-                </a:solidFill>
-                <a:latin typeface="Calibri"/>
-              </a:rPr>
-              <a:t>Retensi berasal dari undercut servikal dan adaptasi margin. Semen membantu seal, bukan menggantikan adaptasi.</a:t>
-            </a:r>
-          </a:p>
-        </p:txBody>
-      </p:sp>
-      <p:sp>
-        <p:nvSpPr>
-          <p:cNvPr id="30" name="Rectangle 29"/>
+          <p:cNvPr id="31" name="Rectangle 30"/>
           <p:cNvSpPr/>
           <p:nvPr/>
         </p:nvSpPr>
@@ -23086,7 +22746,7 @@
       </p:sp>
       <p:sp>
         <p:nvSpPr>
-          <p:cNvPr id="31" name="TextBox 30"/>
+          <p:cNvPr id="32" name="TextBox 31"/>
           <p:cNvSpPr txBox="1"/>
           <p:nvPr/>
         </p:nvSpPr>
@@ -23128,7 +22788,7 @@
       </p:sp>
       <p:sp>
         <p:nvSpPr>
-          <p:cNvPr id="32" name="TextBox 31"/>
+          <p:cNvPr id="33" name="TextBox 32"/>
           <p:cNvSpPr txBox="1"/>
           <p:nvPr/>
         </p:nvSpPr>
@@ -24713,7 +24373,7 @@
       <p:sp>
         <p:nvSpPr>
           <p:cNvPr id="7" name="Rounded Rectangle 6">
-            <a:hlinkClick action="ppaction://hlinksldjump" r:id="rId3"/>
+            <a:hlinkClick action="ppaction://hlinksldjump" r:id="rId4"/>
           </p:cNvPr>
           <p:cNvSpPr/>
           <p:nvPr/>
@@ -25295,292 +24955,53 @@
           </a:p>
         </p:txBody>
       </p:sp>
-      <p:sp>
-        <p:nvSpPr>
-          <p:cNvPr id="20" name="Rounded Rectangle 19"/>
-          <p:cNvSpPr/>
-          <p:nvPr/>
-        </p:nvSpPr>
-        <p:spPr>
-          <a:xfrm>
-            <a:off x="6355080" y="1737360"/>
-            <a:ext cx="5257800" cy="4023360"/>
-          </a:xfrm>
-          <a:prstGeom prst="roundRect">
-            <a:avLst>
-              <a:gd name="adj" fmla="val 9000"/>
-            </a:avLst>
-          </a:prstGeom>
-          <a:solidFill>
-            <a:srgbClr val="FDFAF4"/>
-          </a:solidFill>
-          <a:ln w="12700">
-            <a:solidFill>
-              <a:srgbClr val="E3D9C8"/>
-            </a:solidFill>
-          </a:ln>
-          <a:effectLst/>
-        </p:spPr>
-        <p:style>
-          <a:lnRef idx="1">
-            <a:schemeClr val="accent1"/>
-          </a:lnRef>
-          <a:fillRef idx="3">
-            <a:schemeClr val="accent1"/>
-          </a:fillRef>
-          <a:effectRef idx="2">
-            <a:schemeClr val="accent1"/>
-          </a:effectRef>
-          <a:fontRef idx="minor">
-            <a:schemeClr val="lt1"/>
-          </a:fontRef>
-        </p:style>
-        <p:txBody>
-          <a:bodyPr rtlCol="0" anchor="ctr"/>
-          <a:lstStyle/>
-          <a:p>
-            <a:pPr algn="ctr"/>
-          </a:p>
-        </p:txBody>
-      </p:sp>
-      <p:sp>
-        <p:nvSpPr>
-          <p:cNvPr id="21" name="Rounded Rectangle 20"/>
-          <p:cNvSpPr/>
-          <p:nvPr/>
-        </p:nvSpPr>
-        <p:spPr>
-          <a:xfrm>
-            <a:off x="7818120" y="2331720"/>
-            <a:ext cx="2286000" cy="2651760"/>
-          </a:xfrm>
-          <a:prstGeom prst="roundRect">
-            <a:avLst>
-              <a:gd name="adj" fmla="val 16000"/>
-            </a:avLst>
-          </a:prstGeom>
-          <a:solidFill>
-            <a:srgbClr val="FAF1DE"/>
-          </a:solidFill>
-          <a:ln w="15240">
-            <a:solidFill>
-              <a:srgbClr val="D8C6A8"/>
-            </a:solidFill>
-          </a:ln>
-          <a:effectLst/>
-        </p:spPr>
-        <p:style>
-          <a:lnRef idx="1">
-            <a:schemeClr val="accent1"/>
-          </a:lnRef>
-          <a:fillRef idx="3">
-            <a:schemeClr val="accent1"/>
-          </a:fillRef>
-          <a:effectRef idx="2">
-            <a:schemeClr val="accent1"/>
-          </a:effectRef>
-          <a:fontRef idx="minor">
-            <a:schemeClr val="lt1"/>
-          </a:fontRef>
-        </p:style>
-        <p:txBody>
-          <a:bodyPr rtlCol="0" anchor="ctr"/>
-          <a:lstStyle/>
-          <a:p>
-            <a:pPr algn="ctr"/>
-          </a:p>
-        </p:txBody>
-      </p:sp>
-      <p:sp>
-        <p:nvSpPr>
-          <p:cNvPr id="22" name="Rounded Rectangle 21"/>
-          <p:cNvSpPr/>
-          <p:nvPr/>
-        </p:nvSpPr>
-        <p:spPr>
-          <a:xfrm>
-            <a:off x="8028431" y="2606040"/>
-            <a:ext cx="1865376" cy="2103120"/>
-          </a:xfrm>
-          <a:prstGeom prst="roundRect">
-            <a:avLst>
-              <a:gd name="adj" fmla="val 16000"/>
-            </a:avLst>
-          </a:prstGeom>
-          <a:solidFill>
-            <a:srgbClr val="F3CDC1"/>
-          </a:solidFill>
-          <a:ln w="17780">
-            <a:solidFill>
-              <a:srgbClr val="C65B45"/>
-            </a:solidFill>
-            <a:prstDash val="dash"/>
-          </a:ln>
-          <a:effectLst/>
-        </p:spPr>
-        <p:style>
-          <a:lnRef idx="1">
-            <a:schemeClr val="accent1"/>
-          </a:lnRef>
-          <a:fillRef idx="3">
-            <a:schemeClr val="accent1"/>
-          </a:fillRef>
-          <a:effectRef idx="2">
-            <a:schemeClr val="accent1"/>
-          </a:effectRef>
-          <a:fontRef idx="minor">
-            <a:schemeClr val="lt1"/>
-          </a:fontRef>
-        </p:style>
-        <p:txBody>
-          <a:bodyPr rtlCol="0" anchor="ctr"/>
-          <a:lstStyle/>
-          <a:p>
-            <a:pPr algn="ctr"/>
-          </a:p>
-        </p:txBody>
-      </p:sp>
-      <p:sp>
-        <p:nvSpPr>
-          <p:cNvPr id="23" name="Freeform 22"/>
-          <p:cNvSpPr/>
-          <p:nvPr/>
-        </p:nvSpPr>
-        <p:spPr>
-          <a:xfrm>
-            <a:off x="8010144" y="2011680"/>
-            <a:ext cx="1901952" cy="1653235"/>
-          </a:xfrm>
-          <a:custGeom>
-            <a:avLst/>
-            <a:gdLst/>
-            <a:ahLst/>
-            <a:cxnLst/>
-            <a:rect l="l" t="t" r="r" b="b"/>
-            <a:pathLst>
-              <a:path w="1901952" h="1653235">
-                <a:moveTo>
-                  <a:pt x="0" y="0"/>
-                </a:moveTo>
-                <a:lnTo>
-                  <a:pt x="0" y="438912"/>
-                </a:lnTo>
-                <a:lnTo>
-                  <a:pt x="190195" y="146304"/>
-                </a:lnTo>
-                <a:lnTo>
-                  <a:pt x="468172" y="234086"/>
-                </a:lnTo>
-                <a:lnTo>
-                  <a:pt x="672998" y="29260"/>
-                </a:lnTo>
-                <a:lnTo>
-                  <a:pt x="907084" y="234086"/>
-                </a:lnTo>
-                <a:lnTo>
-                  <a:pt x="1170432" y="29260"/>
-                </a:lnTo>
-                <a:lnTo>
-                  <a:pt x="1404518" y="234086"/>
-                </a:lnTo>
-                <a:lnTo>
-                  <a:pt x="1697126" y="146304"/>
-                </a:lnTo>
-                <a:lnTo>
-                  <a:pt x="1901952" y="438912"/>
-                </a:lnTo>
-                <a:lnTo>
-                  <a:pt x="1901952" y="1389888"/>
-                </a:lnTo>
-                <a:lnTo>
-                  <a:pt x="1784908" y="1506931"/>
-                </a:lnTo>
-                <a:lnTo>
-                  <a:pt x="1609344" y="1433779"/>
-                </a:lnTo>
-                <a:lnTo>
-                  <a:pt x="1609344" y="1653235"/>
-                </a:lnTo>
-                <a:lnTo>
-                  <a:pt x="1404518" y="1653235"/>
-                </a:lnTo>
-                <a:lnTo>
-                  <a:pt x="1404518" y="1433779"/>
-                </a:lnTo>
-                <a:lnTo>
-                  <a:pt x="497433" y="1433779"/>
-                </a:lnTo>
-                <a:lnTo>
-                  <a:pt x="497433" y="1653235"/>
-                </a:lnTo>
-                <a:lnTo>
-                  <a:pt x="292608" y="1653235"/>
-                </a:lnTo>
-                <a:lnTo>
-                  <a:pt x="292608" y="1433779"/>
-                </a:lnTo>
-                <a:lnTo>
-                  <a:pt x="117043" y="1506931"/>
-                </a:lnTo>
-                <a:close/>
-              </a:path>
-            </a:pathLst>
-          </a:custGeom>
-          <a:solidFill>
-            <a:srgbClr val="F6DFD7"/>
-          </a:solidFill>
-          <a:ln w="25400">
-            <a:solidFill>
-              <a:srgbClr val="15323A"/>
-            </a:solidFill>
-          </a:ln>
-          <a:effectLst/>
-        </p:spPr>
-        <p:style>
-          <a:lnRef idx="1">
-            <a:schemeClr val="accent1"/>
-          </a:lnRef>
-          <a:fillRef idx="3">
-            <a:schemeClr val="accent1"/>
-          </a:fillRef>
-          <a:effectRef idx="2">
-            <a:schemeClr val="accent1"/>
-          </a:effectRef>
-          <a:fontRef idx="minor">
-            <a:schemeClr val="lt1"/>
-          </a:fontRef>
-        </p:style>
-        <p:txBody>
-          <a:bodyPr rtlCol="0" anchor="ctr"/>
-          <a:lstStyle/>
-          <a:p>
-            <a:pPr algn="ctr"/>
-          </a:p>
-        </p:txBody>
-      </p:sp>
-      <p:sp>
-        <p:nvSpPr>
-          <p:cNvPr id="24" name="TextBox 23"/>
-          <p:cNvSpPr txBox="1"/>
-          <p:nvPr/>
-        </p:nvSpPr>
-        <p:spPr>
-          <a:xfrm>
-            <a:off x="6382512" y="2212848"/>
-            <a:ext cx="1371600" cy="457200"/>
-          </a:xfrm>
-          <a:prstGeom prst="rect">
-            <a:avLst/>
-          </a:prstGeom>
-          <a:noFill/>
-        </p:spPr>
-        <p:txBody>
-          <a:bodyPr wrap="square" lIns="0" rIns="0" tIns="0" bIns="0" anchor="t">
-            <a:spAutoFit/>
-          </a:bodyPr>
-          <a:lstStyle/>
-          <a:p>
-            <a:pPr algn="l">
+      <p:pic>
+        <p:nvPicPr>
+          <p:cNvPr id="20" name="Picture 19" descr="fig-prep.jpg"/>
+          <p:cNvPicPr>
+            <a:picLocks noChangeAspect="1"/>
+          </p:cNvPicPr>
+          <p:nvPr/>
+        </p:nvPicPr>
+        <p:blipFill>
+          <a:blip r:embed="rId2"/>
+          <a:stretch>
+            <a:fillRect/>
+          </a:stretch>
+        </p:blipFill>
+        <p:spPr>
+          <a:xfrm>
+            <a:off x="5989320" y="1719072"/>
+            <a:ext cx="5623560" cy="3929374"/>
+          </a:xfrm>
+          <a:prstGeom prst="rect">
+            <a:avLst/>
+          </a:prstGeom>
+        </p:spPr>
+      </p:pic>
+      <p:sp>
+        <p:nvSpPr>
+          <p:cNvPr id="21" name="TextBox 20"/>
+          <p:cNvSpPr txBox="1"/>
+          <p:nvPr/>
+        </p:nvSpPr>
+        <p:spPr>
+          <a:xfrm>
+            <a:off x="5989320" y="5721598"/>
+            <a:ext cx="5623560" cy="274320"/>
+          </a:xfrm>
+          <a:prstGeom prst="rect">
+            <a:avLst/>
+          </a:prstGeom>
+          <a:noFill/>
+        </p:spPr>
+        <p:txBody>
+          <a:bodyPr wrap="square" lIns="0" rIns="0" tIns="0" bIns="0" anchor="t">
+            <a:spAutoFit/>
+          </a:bodyPr>
+          <a:lstStyle/>
+          <a:p>
+            <a:pPr algn="ctr">
               <a:lnSpc>
                 <a:spcPct val="112000"/>
               </a:lnSpc>
@@ -25591,262 +25012,18 @@
             <a:r>
               <a:rPr sz="850" b="0" i="0">
                 <a:solidFill>
-                  <a:srgbClr val="15323A"/>
-                </a:solidFill>
-                <a:latin typeface="Calibri"/>
-              </a:rPr>
-              <a:t>1,0–1,5 mm</a:t>
-            </a:r>
-          </a:p>
-          <a:p>
-            <a:pPr algn="l">
-              <a:lnSpc>
-                <a:spcPct val="112000"/>
-              </a:lnSpc>
-              <a:spcAft>
-                <a:spcPts val="0"/>
-              </a:spcAft>
-            </a:pPr>
-            <a:r>
-              <a:rPr sz="850" b="0" i="0">
-                <a:solidFill>
-                  <a:srgbClr val="15323A"/>
-                </a:solidFill>
-                <a:latin typeface="Calibri"/>
-              </a:rPr>
-              <a:t>reduksi oklusal</a:t>
-            </a:r>
-          </a:p>
-        </p:txBody>
-      </p:sp>
-      <p:sp>
-        <p:nvSpPr>
-          <p:cNvPr id="25" name="TextBox 24"/>
-          <p:cNvSpPr txBox="1"/>
-          <p:nvPr/>
-        </p:nvSpPr>
-        <p:spPr>
-          <a:xfrm>
-            <a:off x="6382512" y="3840480"/>
-            <a:ext cx="1325880" cy="457200"/>
-          </a:xfrm>
-          <a:prstGeom prst="rect">
-            <a:avLst/>
-          </a:prstGeom>
-          <a:noFill/>
-        </p:spPr>
-        <p:txBody>
-          <a:bodyPr wrap="square" lIns="0" rIns="0" tIns="0" bIns="0" anchor="t">
-            <a:spAutoFit/>
-          </a:bodyPr>
-          <a:lstStyle/>
-          <a:p>
-            <a:pPr algn="l">
-              <a:lnSpc>
-                <a:spcPct val="112000"/>
-              </a:lnSpc>
-              <a:spcAft>
-                <a:spcPts val="0"/>
-              </a:spcAft>
-            </a:pPr>
-            <a:r>
-              <a:rPr sz="850" b="0" i="0">
-                <a:solidFill>
-                  <a:srgbClr val="15323A"/>
-                </a:solidFill>
-                <a:latin typeface="Calibri"/>
-              </a:rPr>
-              <a:t>bulbositas</a:t>
-            </a:r>
-          </a:p>
-          <a:p>
-            <a:pPr algn="l">
-              <a:lnSpc>
-                <a:spcPct val="112000"/>
-              </a:lnSpc>
-              <a:spcAft>
-                <a:spcPts val="0"/>
-              </a:spcAft>
-            </a:pPr>
-            <a:r>
-              <a:rPr sz="850" b="0" i="0">
-                <a:solidFill>
-                  <a:srgbClr val="15323A"/>
-                </a:solidFill>
-                <a:latin typeface="Calibri"/>
-              </a:rPr>
-              <a:t>servikal</a:t>
-            </a:r>
-          </a:p>
-        </p:txBody>
-      </p:sp>
-      <p:sp>
-        <p:nvSpPr>
-          <p:cNvPr id="26" name="TextBox 25"/>
-          <p:cNvSpPr txBox="1"/>
-          <p:nvPr/>
-        </p:nvSpPr>
-        <p:spPr>
-          <a:xfrm>
-            <a:off x="9893808" y="4160520"/>
-            <a:ext cx="1554480" cy="457200"/>
-          </a:xfrm>
-          <a:prstGeom prst="rect">
-            <a:avLst/>
-          </a:prstGeom>
-          <a:noFill/>
-        </p:spPr>
-        <p:txBody>
-          <a:bodyPr wrap="square" lIns="0" rIns="0" tIns="0" bIns="0" anchor="t">
-            <a:spAutoFit/>
-          </a:bodyPr>
-          <a:lstStyle/>
-          <a:p>
-            <a:pPr algn="l">
-              <a:lnSpc>
-                <a:spcPct val="112000"/>
-              </a:lnSpc>
-              <a:spcAft>
-                <a:spcPts val="0"/>
-              </a:spcAft>
-            </a:pPr>
-            <a:r>
-              <a:rPr sz="850" b="0" i="0">
-                <a:solidFill>
-                  <a:srgbClr val="15323A"/>
-                </a:solidFill>
-                <a:latin typeface="Calibri"/>
-              </a:rPr>
-              <a:t>margin 1 mm</a:t>
-            </a:r>
-          </a:p>
-          <a:p>
-            <a:pPr algn="l">
-              <a:lnSpc>
-                <a:spcPct val="112000"/>
-              </a:lnSpc>
-              <a:spcAft>
-                <a:spcPts val="0"/>
-              </a:spcAft>
-            </a:pPr>
-            <a:r>
-              <a:rPr sz="850" b="0" i="0">
-                <a:solidFill>
-                  <a:srgbClr val="15323A"/>
-                </a:solidFill>
-                <a:latin typeface="Calibri"/>
-              </a:rPr>
-              <a:t>subgingiva</a:t>
-            </a:r>
-          </a:p>
-        </p:txBody>
-      </p:sp>
-      <p:sp>
-        <p:nvSpPr>
-          <p:cNvPr id="27" name="TextBox 26"/>
-          <p:cNvSpPr txBox="1"/>
-          <p:nvPr/>
-        </p:nvSpPr>
-        <p:spPr>
-          <a:xfrm>
-            <a:off x="9893808" y="3566160"/>
-            <a:ext cx="1554480" cy="457200"/>
-          </a:xfrm>
-          <a:prstGeom prst="rect">
-            <a:avLst/>
-          </a:prstGeom>
-          <a:noFill/>
-        </p:spPr>
-        <p:txBody>
-          <a:bodyPr wrap="square" lIns="0" rIns="0" tIns="0" bIns="0" anchor="t">
-            <a:spAutoFit/>
-          </a:bodyPr>
-          <a:lstStyle/>
-          <a:p>
-            <a:pPr algn="l">
-              <a:lnSpc>
-                <a:spcPct val="112000"/>
-              </a:lnSpc>
-              <a:spcAft>
-                <a:spcPts val="0"/>
-              </a:spcAft>
-            </a:pPr>
-            <a:r>
-              <a:rPr sz="850" b="0" i="0">
-                <a:solidFill>
-                  <a:srgbClr val="15323A"/>
-                </a:solidFill>
-                <a:latin typeface="Calibri"/>
-              </a:rPr>
-              <a:t>feather edge,</a:t>
-            </a:r>
-          </a:p>
-          <a:p>
-            <a:pPr algn="l">
-              <a:lnSpc>
-                <a:spcPct val="112000"/>
-              </a:lnSpc>
-              <a:spcAft>
-                <a:spcPts val="0"/>
-              </a:spcAft>
-            </a:pPr>
-            <a:r>
-              <a:rPr sz="850" b="0" i="0">
-                <a:solidFill>
-                  <a:srgbClr val="15323A"/>
-                </a:solidFill>
-                <a:latin typeface="Calibri"/>
-              </a:rPr>
-              <a:t>tanpa ledge</a:t>
-            </a:r>
-          </a:p>
-        </p:txBody>
-      </p:sp>
-      <p:sp>
-        <p:nvSpPr>
-          <p:cNvPr id="28" name="TextBox 27"/>
-          <p:cNvSpPr txBox="1"/>
-          <p:nvPr/>
-        </p:nvSpPr>
-        <p:spPr>
-          <a:xfrm>
-            <a:off x="6382512" y="5394960"/>
-            <a:ext cx="4572000" cy="274320"/>
-          </a:xfrm>
-          <a:prstGeom prst="rect">
-            <a:avLst/>
-          </a:prstGeom>
-          <a:noFill/>
-        </p:spPr>
-        <p:txBody>
-          <a:bodyPr wrap="square" lIns="0" rIns="0" tIns="0" bIns="0" anchor="t">
-            <a:spAutoFit/>
-          </a:bodyPr>
-          <a:lstStyle/>
-          <a:p>
-            <a:pPr algn="l">
-              <a:lnSpc>
-                <a:spcPct val="112000"/>
-              </a:lnSpc>
-              <a:spcAft>
-                <a:spcPts val="0"/>
-              </a:spcAft>
-            </a:pPr>
-            <a:r>
-              <a:rPr sz="800" b="0" i="0">
-                <a:solidFill>
                   <a:srgbClr val="7D8F93"/>
                 </a:solidFill>
                 <a:latin typeface="Calibri"/>
               </a:rPr>
-              <a:t>Skema: garis putus-putus adalah permukaan setelah preparasi.</a:t>
-            </a:r>
-          </a:p>
-        </p:txBody>
-      </p:sp>
-      <p:sp>
-        <p:nvSpPr>
-          <p:cNvPr id="29" name="Rectangle 28"/>
+              <a:t>Garis dan angka untuk orientasi, bukan skala.</a:t>
+            </a:r>
+          </a:p>
+        </p:txBody>
+      </p:sp>
+      <p:sp>
+        <p:nvSpPr>
+          <p:cNvPr id="22" name="Rectangle 21"/>
           <p:cNvSpPr/>
           <p:nvPr/>
         </p:nvSpPr>
@@ -25890,7 +25067,7 @@
       </p:sp>
       <p:sp>
         <p:nvSpPr>
-          <p:cNvPr id="30" name="TextBox 29"/>
+          <p:cNvPr id="23" name="TextBox 22"/>
           <p:cNvSpPr txBox="1"/>
           <p:nvPr/>
         </p:nvSpPr>
@@ -25932,7 +25109,7 @@
       </p:sp>
       <p:sp>
         <p:nvSpPr>
-          <p:cNvPr id="31" name="TextBox 30"/>
+          <p:cNvPr id="24" name="TextBox 23"/>
           <p:cNvSpPr txBox="1"/>
           <p:nvPr/>
         </p:nvSpPr>
@@ -27986,7 +27163,7 @@
       <p:sp>
         <p:nvSpPr>
           <p:cNvPr id="7" name="Rounded Rectangle 6">
-            <a:hlinkClick action="ppaction://hlinksldjump" r:id="rId3"/>
+            <a:hlinkClick action="ppaction://hlinksldjump" r:id="rId4"/>
           </p:cNvPr>
           <p:cNvSpPr/>
           <p:nvPr/>
@@ -28980,208 +28157,40 @@
           </a:p>
         </p:txBody>
       </p:sp>
-      <p:sp>
-        <p:nvSpPr>
-          <p:cNvPr id="30" name="Rounded Rectangle 29"/>
-          <p:cNvSpPr/>
-          <p:nvPr/>
-        </p:nvSpPr>
-        <p:spPr>
-          <a:xfrm>
-            <a:off x="6355080" y="1737360"/>
-            <a:ext cx="5257800" cy="3840480"/>
-          </a:xfrm>
-          <a:prstGeom prst="roundRect">
-            <a:avLst>
-              <a:gd name="adj" fmla="val 9000"/>
-            </a:avLst>
-          </a:prstGeom>
-          <a:solidFill>
-            <a:srgbClr val="FDFAF4"/>
-          </a:solidFill>
-          <a:ln w="12700">
-            <a:solidFill>
-              <a:srgbClr val="E3D9C8"/>
-            </a:solidFill>
-          </a:ln>
-          <a:effectLst/>
-        </p:spPr>
-        <p:style>
-          <a:lnRef idx="1">
-            <a:schemeClr val="accent1"/>
-          </a:lnRef>
-          <a:fillRef idx="3">
-            <a:schemeClr val="accent1"/>
-          </a:fillRef>
-          <a:effectRef idx="2">
-            <a:schemeClr val="accent1"/>
-          </a:effectRef>
-          <a:fontRef idx="minor">
-            <a:schemeClr val="lt1"/>
-          </a:fontRef>
-        </p:style>
-        <p:txBody>
-          <a:bodyPr rtlCol="0" anchor="ctr"/>
-          <a:lstStyle/>
-          <a:p>
-            <a:pPr algn="ctr"/>
-          </a:p>
-        </p:txBody>
-      </p:sp>
-      <p:sp>
-        <p:nvSpPr>
-          <p:cNvPr id="31" name="Rounded Rectangle 30"/>
-          <p:cNvSpPr/>
-          <p:nvPr/>
-        </p:nvSpPr>
-        <p:spPr>
-          <a:xfrm>
-            <a:off x="6949440" y="2743200"/>
-            <a:ext cx="1143000" cy="1920240"/>
-          </a:xfrm>
-          <a:prstGeom prst="roundRect">
-            <a:avLst>
-              <a:gd name="adj" fmla="val 18000"/>
-            </a:avLst>
-          </a:prstGeom>
-          <a:solidFill>
-            <a:srgbClr val="FAF1DE"/>
-          </a:solidFill>
-          <a:ln w="12700">
-            <a:solidFill>
-              <a:srgbClr val="D8C6A8"/>
-            </a:solidFill>
-          </a:ln>
-          <a:effectLst/>
-        </p:spPr>
-        <p:style>
-          <a:lnRef idx="1">
-            <a:schemeClr val="accent1"/>
-          </a:lnRef>
-          <a:fillRef idx="3">
-            <a:schemeClr val="accent1"/>
-          </a:fillRef>
-          <a:effectRef idx="2">
-            <a:schemeClr val="accent1"/>
-          </a:effectRef>
-          <a:fontRef idx="minor">
-            <a:schemeClr val="lt1"/>
-          </a:fontRef>
-        </p:style>
-        <p:txBody>
-          <a:bodyPr rtlCol="0" anchor="ctr"/>
-          <a:lstStyle/>
-          <a:p>
-            <a:pPr algn="ctr"/>
-          </a:p>
-        </p:txBody>
-      </p:sp>
-      <p:sp>
-        <p:nvSpPr>
-          <p:cNvPr id="32" name="Rounded Rectangle 31"/>
-          <p:cNvSpPr/>
-          <p:nvPr/>
-        </p:nvSpPr>
-        <p:spPr>
-          <a:xfrm>
-            <a:off x="8412480" y="2743200"/>
-            <a:ext cx="1143000" cy="1920240"/>
-          </a:xfrm>
-          <a:prstGeom prst="roundRect">
-            <a:avLst>
-              <a:gd name="adj" fmla="val 18000"/>
-            </a:avLst>
-          </a:prstGeom>
-          <a:solidFill>
-            <a:srgbClr val="FAF1DE"/>
-          </a:solidFill>
-          <a:ln w="12700">
-            <a:solidFill>
-              <a:srgbClr val="D8C6A8"/>
-            </a:solidFill>
-          </a:ln>
-          <a:effectLst/>
-        </p:spPr>
-        <p:style>
-          <a:lnRef idx="1">
-            <a:schemeClr val="accent1"/>
-          </a:lnRef>
-          <a:fillRef idx="3">
-            <a:schemeClr val="accent1"/>
-          </a:fillRef>
-          <a:effectRef idx="2">
-            <a:schemeClr val="accent1"/>
-          </a:effectRef>
-          <a:fontRef idx="minor">
-            <a:schemeClr val="lt1"/>
-          </a:fontRef>
-        </p:style>
-        <p:txBody>
-          <a:bodyPr rtlCol="0" anchor="ctr"/>
-          <a:lstStyle/>
-          <a:p>
-            <a:pPr algn="ctr"/>
-          </a:p>
-        </p:txBody>
-      </p:sp>
-      <p:sp>
-        <p:nvSpPr>
-          <p:cNvPr id="33" name="Rounded Rectangle 32"/>
-          <p:cNvSpPr/>
-          <p:nvPr/>
-        </p:nvSpPr>
-        <p:spPr>
-          <a:xfrm>
-            <a:off x="6812280" y="2331720"/>
-            <a:ext cx="1417320" cy="914400"/>
-          </a:xfrm>
-          <a:prstGeom prst="roundRect">
-            <a:avLst>
-              <a:gd name="adj" fmla="val 12000"/>
-            </a:avLst>
-          </a:prstGeom>
-          <a:solidFill>
-            <a:srgbClr val="F6DFD7"/>
-          </a:solidFill>
-          <a:ln w="20320">
-            <a:solidFill>
-              <a:srgbClr val="15323A"/>
-            </a:solidFill>
-          </a:ln>
-          <a:effectLst/>
-        </p:spPr>
-        <p:style>
-          <a:lnRef idx="1">
-            <a:schemeClr val="accent1"/>
-          </a:lnRef>
-          <a:fillRef idx="3">
-            <a:schemeClr val="accent1"/>
-          </a:fillRef>
-          <a:effectRef idx="2">
-            <a:schemeClr val="accent1"/>
-          </a:effectRef>
-          <a:fontRef idx="minor">
-            <a:schemeClr val="lt1"/>
-          </a:fontRef>
-        </p:style>
-        <p:txBody>
-          <a:bodyPr rtlCol="0" anchor="ctr"/>
-          <a:lstStyle/>
-          <a:p>
-            <a:pPr algn="ctr"/>
-          </a:p>
-        </p:txBody>
-      </p:sp>
-      <p:sp>
-        <p:nvSpPr>
-          <p:cNvPr id="34" name="TextBox 33"/>
-          <p:cNvSpPr txBox="1"/>
-          <p:nvPr/>
-        </p:nvSpPr>
-        <p:spPr>
-          <a:xfrm>
-            <a:off x="6903720" y="2542032"/>
-            <a:ext cx="1234440" cy="365760"/>
+      <p:pic>
+        <p:nvPicPr>
+          <p:cNvPr id="30" name="Picture 29" descr="fig-hall.jpg"/>
+          <p:cNvPicPr>
+            <a:picLocks noChangeAspect="1"/>
+          </p:cNvPicPr>
+          <p:nvPr/>
+        </p:nvPicPr>
+        <p:blipFill>
+          <a:blip r:embed="rId2"/>
+          <a:stretch>
+            <a:fillRect/>
+          </a:stretch>
+        </p:blipFill>
+        <p:spPr>
+          <a:xfrm>
+            <a:off x="5989320" y="1828800"/>
+            <a:ext cx="5577840" cy="3546934"/>
+          </a:xfrm>
+          <a:prstGeom prst="rect">
+            <a:avLst/>
+          </a:prstGeom>
+        </p:spPr>
+      </p:pic>
+      <p:sp>
+        <p:nvSpPr>
+          <p:cNvPr id="31" name="TextBox 30"/>
+          <p:cNvSpPr txBox="1"/>
+          <p:nvPr/>
+        </p:nvSpPr>
+        <p:spPr>
+          <a:xfrm>
+            <a:off x="5989320" y="5448886"/>
+            <a:ext cx="5577840" cy="274320"/>
           </a:xfrm>
           <a:prstGeom prst="rect">
             <a:avLst/>
@@ -29203,104 +28212,20 @@
               </a:spcAft>
             </a:pPr>
             <a:r>
-              <a:rPr sz="900" b="0" i="0">
-                <a:solidFill>
-                  <a:srgbClr val="15323A"/>
-                </a:solidFill>
-                <a:latin typeface="Calibri"/>
-              </a:rPr>
-              <a:t>crown</a:t>
-            </a:r>
-          </a:p>
-        </p:txBody>
-      </p:sp>
-      <p:sp>
-        <p:nvSpPr>
-          <p:cNvPr id="35" name="TextBox 34"/>
-          <p:cNvSpPr txBox="1"/>
-          <p:nvPr/>
-        </p:nvSpPr>
-        <p:spPr>
-          <a:xfrm>
-            <a:off x="8183879" y="3200400"/>
-            <a:ext cx="1188720" cy="365760"/>
-          </a:xfrm>
-          <a:prstGeom prst="rect">
-            <a:avLst/>
-          </a:prstGeom>
-          <a:noFill/>
-        </p:spPr>
-        <p:txBody>
-          <a:bodyPr wrap="square" lIns="0" rIns="0" tIns="0" bIns="0" anchor="t">
-            <a:spAutoFit/>
-          </a:bodyPr>
-          <a:lstStyle/>
-          <a:p>
-            <a:pPr algn="ctr">
-              <a:lnSpc>
-                <a:spcPct val="112000"/>
-              </a:lnSpc>
-              <a:spcAft>
-                <a:spcPts val="0"/>
-              </a:spcAft>
-            </a:pPr>
-            <a:r>
-              <a:rPr sz="750" b="0" i="0">
-                <a:solidFill>
-                  <a:srgbClr val="6F5B3F"/>
-                </a:solidFill>
-                <a:latin typeface="Calibri"/>
-              </a:rPr>
-              <a:t>separator</a:t>
-            </a:r>
-          </a:p>
-        </p:txBody>
-      </p:sp>
-      <p:sp>
-        <p:nvSpPr>
-          <p:cNvPr id="36" name="TextBox 35"/>
-          <p:cNvSpPr txBox="1"/>
-          <p:nvPr/>
-        </p:nvSpPr>
-        <p:spPr>
-          <a:xfrm>
-            <a:off x="6583680" y="4846320"/>
-            <a:ext cx="4754880" cy="502920"/>
-          </a:xfrm>
-          <a:prstGeom prst="rect">
-            <a:avLst/>
-          </a:prstGeom>
-          <a:noFill/>
-        </p:spPr>
-        <p:txBody>
-          <a:bodyPr wrap="square" lIns="0" rIns="0" tIns="0" bIns="0" anchor="t">
-            <a:spAutoFit/>
-          </a:bodyPr>
-          <a:lstStyle/>
-          <a:p>
-            <a:pPr algn="ctr">
-              <a:lnSpc>
-                <a:spcPct val="112000"/>
-              </a:lnSpc>
-              <a:spcAft>
-                <a:spcPts val="0"/>
-              </a:spcAft>
-            </a:pPr>
-            <a:r>
-              <a:rPr sz="950" b="0" i="0">
-                <a:solidFill>
-                  <a:srgbClr val="47646C"/>
-                </a:solidFill>
-                <a:latin typeface="Calibri"/>
-              </a:rPr>
-              <a:t>Karies tetap di tempatnya dan tertutup dari substrat oral.</a:t>
-            </a:r>
-          </a:p>
-        </p:txBody>
-      </p:sp>
-      <p:sp>
-        <p:nvSpPr>
-          <p:cNvPr id="37" name="Rectangle 36"/>
+              <a:rPr sz="850" b="0" i="0">
+                <a:solidFill>
+                  <a:srgbClr val="7D8F93"/>
+                </a:solidFill>
+                <a:latin typeface="Calibri"/>
+              </a:rPr>
+              <a:t>Karies tetap di tempatnya, tertutup dari substrat oral.</a:t>
+            </a:r>
+          </a:p>
+        </p:txBody>
+      </p:sp>
+      <p:sp>
+        <p:nvSpPr>
+          <p:cNvPr id="32" name="Rectangle 31"/>
           <p:cNvSpPr/>
           <p:nvPr/>
         </p:nvSpPr>
@@ -29344,7 +28269,7 @@
       </p:sp>
       <p:sp>
         <p:nvSpPr>
-          <p:cNvPr id="38" name="TextBox 37"/>
+          <p:cNvPr id="33" name="TextBox 32"/>
           <p:cNvSpPr txBox="1"/>
           <p:nvPr/>
         </p:nvSpPr>
@@ -29386,7 +28311,7 @@
       </p:sp>
       <p:sp>
         <p:nvSpPr>
-          <p:cNvPr id="39" name="TextBox 38"/>
+          <p:cNvPr id="34" name="TextBox 33"/>
           <p:cNvSpPr txBox="1"/>
           <p:nvPr/>
         </p:nvSpPr>

</xml_diff>

<commit_message>
Tulis ulang teks deck: label jadi kalimat utuh, istilah klinis masuk kalimat, desimal koma konsisten, tabel perbandingan menggantikan panel
Co-authored-by: arena-agent <297053741+arena-agent@users.noreply.github.com>
</commit_message>
<xml_diff>
--- a/deliverables/ssc-pedodonsia/ssc-pedodonsia.pptx
+++ b/deliverables/ssc-pedodonsia/ssc-pedodonsia.pptx
@@ -659,7 +659,7 @@
           <a:lstStyle/>
           <a:p>
             <a:r>
-              <a:t>Dua grafik ini sengaja dipisah. Kiri, RCT lima tahun: Hall 92 persen, kontrol 52 persen. Kanan, meta-analisis 2025 tentang retensi lima tahun: SSC tertinggi, 97,88 persen. Perhatikan sumbu kanan dipotong pada 80 persen, jadi perbedaan tiga sampai empat persen terlihat besar. Dan retensi bukan success. Sebuah crown bisa masih terpasang tetapi sudah gagal secara klinis karena pulpanya nekrotik.</a:t>
+              <a:t>Dua grafik ini sengaja dipisah. Kiri, RCT lima tahun: Hall 92 persen, kontrol 52 persen. Kanan, meta-analisis 2025 tentang crown yang masih terpasang setelah lima tahun: SSC tertinggi, 97,88 persen. Perhatikan sumbu kanan dipotong pada 80 persen, jadi perbedaan tiga sampai empat persen terlihat besar. Dan retensi bukan success. Sebuah crown bisa masih terpasang tetapi sudah gagal secara klinis karena pulpanya nekrotik.</a:t>
             </a:r>
           </a:p>
         </p:txBody>
@@ -939,7 +939,7 @@
           <a:lstStyle/>
           <a:p>
             <a:r>
-              <a:t>Tiga hal. Satu, SSC adalah restorasi coverage penuh, dan retensinya ditentukan margin serta undercut, bukan semen. Dua, Hall hanya untuk gigi vital dengan dentine bridge jelas. Tiga, angka success, survival, dan retention tidak boleh dicampur. Kalau tiga hal ini terbawa pulang, presentasi ini berhasil. Protokol lengkap ada di dokumen pendamping. Terima kasih, saya buka sesi tanya jawab.</a:t>
+              <a:t>Tiga hal. Satu, SSC adalah restorasi yang menutup seluruh permukaan gigi, dan retensinya ditentukan margin serta undercut servikal, bukan oleh semen. Dua, Hall hanya dipakai pada gigi vital dengan dentine bridge yang jelas. Tiga, angka keberhasilan, angka gigi yang masih bertahan, dan angka crown yang masih terpasang tidak boleh dicampur karena definisinya berbeda. Kalau tiga hal ini terbawa pulang, presentasi ini berhasil. Protokol lengkap ada di dokumen pendamping. Terima kasih, saya buka sesi tanya jawab.</a:t>
             </a:r>
           </a:p>
         </p:txBody>
@@ -1219,7 +1219,7 @@
           <a:lstStyle/>
           <a:p>
             <a:r>
-              <a:t>Alurnya dari masalah ke solusi, lalu ke teknik dan bukti. Bagian lima adalah inti keterampilan: sepuluh langkah konvensional yang bisa dibuka satu per satu. Bagian enam membahas Hall Technique, bagian tujuh penyulit yang paling sering muncul. Saya akan berhenti di bagian kasus untuk keputusan bersama, jadi sisakan waktu di sana.</a:t>
+              <a:t>Alurnya dari masalah ke solusi, lalu ke teknik dan bukti. Bagian lima adalah inti keterampilan: sepuluh langkah konvensional yang bisa dibuka satu per satu. Bagian enam membahas Hall Technique, dan bagian tujuh membandingkannya dengan SSC konvensional. Saya akan berhenti di bagian kasus untuk keputusan bersama, jadi sisakan waktu di sana.</a:t>
             </a:r>
           </a:p>
         </p:txBody>
@@ -1359,7 +1359,7 @@
           <a:lstStyle/>
           <a:p>
             <a:r>
-              <a:t>Tiga angka ini cukup untuk membawa pesan utama. Chisini melaporkan success 96,1 persen dari 31 studi, dengan lama follow-up yang berbeda-beda. Cochrane 2015 memberi angka yang lebih kuat: risiko kegagalan mayor 0,18 dibanding tambalan, artinya sekitar seperlima. Dan pada RCT lima tahun, Hall mencapai 92 persen dibanding 52 persen pada restorasi rutin. Perhatikan, angka-angka ini memakai definisi berbeda, jadi jangan disatukan.</a:t>
+              <a:t>Tiga angka ini cukup untuk membawa pesan utama. Chisini melaporkan angka keberhasilan 96,1 persen dari 31 studi, dengan lama follow-up yang berbeda-beda. Cochrane 2015 memberi angka yang lebih kuat: risiko kegagalan mayor 0,18 dibanding tambalan, artinya sekitar seperlima. Dan pada RCT lima tahun, Hall mencapai 92 persen dibanding 52 persen pada restorasi rutin. Perhatikan, angka-angka ini memakai definisi berbeda, jadi jangan disatukan.</a:t>
             </a:r>
           </a:p>
         </p:txBody>
@@ -1709,7 +1709,7 @@
           <a:lstStyle/>
           <a:p>
             <a:r>
-              <a:t>Perbandingan ini jangan dibaca sebagai siapa yang menang. Hall menang di waktu dan penerimaan: tujuh koma satu menit dibanding tujuh belas koma empat menit. Konvensional menang di kontrol: kita bisa melihat dan mengobati pulpa, serta membentuk margin sendiri. Yang penting, sampai sekarang belum ada RCT yang membandingkan Hall dengan SSC konvensional. Jadi pilihan ditentukan oleh kondisi gigi, perilaku anak, dan kemampuan operator.</a:t>
+              <a:t>Tabel ini bukan pertandingan yang harus dimenangkan salah satu. Hall unggul di waktu dan penerimaan anak: tujuh koma satu menit, dibanding tujuh belas koma empat menit pada konvensional. Konvensional unggul di kendali: kita bisa melihat dan mengobati pulpa, lalu membentuk margin serta kontak sendiri. Sampai sekarang belum ada RCT yang membandingkan kedua teknik ini secara langsung, jadi pilihan ditentukan oleh kondisi gigi, perilaku anak, dan kemampuan operator.</a:t>
             </a:r>
           </a:p>
         </p:txBody>
@@ -5280,7 +5280,7 @@
                 </a:solidFill>
                 <a:latin typeface="Calibri"/>
               </a:rPr>
-              <a:t>Materi edukasi. Bukan pengganti pertimbangan klinis pada pasien tertentu.</a:t>
+              <a:t>Materi edukasi, jadi tidak menggantikan pertimbangan klinis pada pasien tertentu.</a:t>
             </a:r>
           </a:p>
         </p:txBody>
@@ -5811,7 +5811,7 @@
                 </a:solidFill>
                 <a:latin typeface="Calibri"/>
               </a:rPr>
-              <a:t>Crown longgar</a:t>
+              <a:t>Crown terasa longgar</a:t>
             </a:r>
           </a:p>
         </p:txBody>
@@ -5853,7 +5853,7 @@
                 </a:solidFill>
                 <a:latin typeface="Calibri"/>
               </a:rPr>
-              <a:t>Ukuran terlalu besar atau crimping kurang.</a:t>
+              <a:t>Biasanya ukuran terlalu besar atau crimping margin kurang rapat.</a:t>
             </a:r>
           </a:p>
         </p:txBody>
@@ -5985,7 +5985,7 @@
                 </a:solidFill>
                 <a:latin typeface="Calibri"/>
               </a:rPr>
-              <a:t>Ledge atau kontak belum putus.</a:t>
+              <a:t>Ada ledge, atau kontak proksimal belum putus.</a:t>
             </a:r>
           </a:p>
         </p:txBody>
@@ -6117,7 +6117,7 @@
                 </a:solidFill>
                 <a:latin typeface="Calibri"/>
               </a:rPr>
-              <a:t>Margin terlalu panjang atau tepi tajam.</a:t>
+              <a:t>Margin crown terlalu panjang, atau tepinya tajam.</a:t>
             </a:r>
           </a:p>
         </p:txBody>
@@ -6249,7 +6249,7 @@
                 </a:solidFill>
                 <a:latin typeface="Calibri"/>
               </a:rPr>
-              <a:t>Trimming berlebihan atau wear oklusal.</a:t>
+              <a:t>Trimming terlalu banyak, atau logam aus di oklusal.</a:t>
             </a:r>
           </a:p>
         </p:txBody>
@@ -6381,7 +6381,7 @@
                 </a:solidFill>
                 <a:latin typeface="Calibri"/>
               </a:rPr>
-              <a:t>Retensi buruk atau karies sekunder.</a:t>
+              <a:t>Retensi kurang, atau ada karies sekunder di bawah margin.</a:t>
             </a:r>
           </a:p>
         </p:txBody>
@@ -6513,7 +6513,7 @@
                 </a:solidFill>
                 <a:latin typeface="Calibri"/>
               </a:rPr>
-              <a:t>Cemas atau pengalaman buruk.</a:t>
+              <a:t>Cemas, atau pernah punya pengalaman perawatan buruk.</a:t>
             </a:r>
           </a:p>
         </p:txBody>
@@ -6645,7 +6645,7 @@
                 </a:solidFill>
                 <a:latin typeface="Calibri"/>
               </a:rPr>
-              <a:t>Sensitisasi 8–10% pada anak Eropa, reaksi klinis jarang. Kontraindikasi bila ada riwayat reaksi.</a:t>
+              <a:t>Sensitisasi 8–10% pada anak di Eropa, reaksi klinis jarang. Jangan dipakai bila ada riwayat reaksi.</a:t>
             </a:r>
           </a:p>
         </p:txBody>
@@ -6777,7 +6777,7 @@
                 </a:solidFill>
                 <a:latin typeface="Calibri"/>
               </a:rPr>
-              <a:t>Survival 94,4% vs komposit 49,2% pada 24 bulan.</a:t>
+              <a:t>SSC bertahan pada 94,4% gigi, komposit 49,2%, setelah 24 bulan.</a:t>
             </a:r>
           </a:p>
         </p:txBody>
@@ -6867,7 +6867,7 @@
                 </a:solidFill>
                 <a:latin typeface="Calibri"/>
               </a:rPr>
-              <a:t>Berkebutuhan khusus</a:t>
+              <a:t>Anak berkebutuhan khusus</a:t>
             </a:r>
           </a:p>
         </p:txBody>
@@ -6909,7 +6909,7 @@
                 </a:solidFill>
                 <a:latin typeface="Calibri"/>
               </a:rPr>
-              <a:t>Lebih sedikit kunjungan.</a:t>
+              <a:t>Perawatan selesai dalam lebih sedikit kunjungan.</a:t>
             </a:r>
           </a:p>
         </p:txBody>
@@ -7227,7 +7227,7 @@
                 </a:solidFill>
                 <a:latin typeface="Georgia"/>
               </a:rPr>
-              <a:t>Angka retensi dan angka kegagalan tidak bisa dibandingkan langsung</a:t>
+              <a:t>Angka retensi dan angka keberhasilan mengukur hal yang berbeda</a:t>
             </a:r>
           </a:p>
         </p:txBody>
@@ -7416,7 +7416,7 @@
                 </a:solidFill>
                 <a:latin typeface="Calibri"/>
               </a:rPr>
-              <a:t>Hall vs restorasi rutin, 60 bulan</a:t>
+              <a:t>Hall dibanding restorasi rutin pada 60 bulan</a:t>
             </a:r>
           </a:p>
         </p:txBody>
@@ -7852,7 +7852,7 @@
                 </a:solidFill>
                 <a:latin typeface="Calibri"/>
               </a:rPr>
-              <a:t>Kegagalan mayor 3% vs 16,5%. NNT 8.</a:t>
+              <a:t>Kegagalan mayor: 3% pada Hall, 16,5% pada kontrol. NNT 8.</a:t>
             </a:r>
           </a:p>
         </p:txBody>
@@ -8160,7 +8160,7 @@
                 </a:solidFill>
                 <a:latin typeface="Calibri"/>
               </a:rPr>
-              <a:t>97.88%</a:t>
+              <a:t>97,88%</a:t>
             </a:r>
           </a:p>
         </p:txBody>
@@ -8336,7 +8336,7 @@
                 </a:solidFill>
                 <a:latin typeface="Calibri"/>
               </a:rPr>
-              <a:t>97.09%</a:t>
+              <a:t>97,09%</a:t>
             </a:r>
           </a:p>
         </p:txBody>
@@ -8512,7 +8512,7 @@
                 </a:solidFill>
                 <a:latin typeface="Calibri"/>
               </a:rPr>
-              <a:t>92.18%</a:t>
+              <a:t>92,18%</a:t>
             </a:r>
           </a:p>
         </p:txBody>
@@ -8688,7 +8688,7 @@
                 </a:solidFill>
                 <a:latin typeface="Calibri"/>
               </a:rPr>
-              <a:t>90.3%</a:t>
+              <a:t>90,30%</a:t>
             </a:r>
           </a:p>
         </p:txBody>
@@ -8864,7 +8864,7 @@
                 </a:solidFill>
                 <a:latin typeface="Calibri"/>
               </a:rPr>
-              <a:t>88.9%</a:t>
+              <a:t>88,90%</a:t>
             </a:r>
           </a:p>
         </p:txBody>
@@ -9040,7 +9040,7 @@
                 </a:solidFill>
                 <a:latin typeface="Calibri"/>
               </a:rPr>
-              <a:t>83.48%</a:t>
+              <a:t>83,48%</a:t>
             </a:r>
           </a:p>
         </p:txBody>
@@ -9082,7 +9082,7 @@
                 </a:solidFill>
                 <a:latin typeface="Calibri"/>
               </a:rPr>
-              <a:t>Angka retensi dan success tidak boleh dibandingkan langsung. Definisi kegagalan berbeda antar studi.</a:t>
+              <a:t>Angka retensi dan angka keberhasilan tidak bisa dibandingkan langsung karena definisi kegagalan berbeda antar studi.</a:t>
             </a:r>
           </a:p>
         </p:txBody>
@@ -9400,7 +9400,7 @@
                 </a:solidFill>
                 <a:latin typeface="Georgia"/>
               </a:rPr>
-              <a:t>Zirkonia lebih baik pada gingiva, belum pada retensi jangka panjang</a:t>
+              <a:t>Zirkonia lebih baik untuk gingiva, tetapi retensinya belum terbukti lebih unggul</a:t>
             </a:r>
           </a:p>
         </p:txBody>
@@ -9631,7 +9631,7 @@
                 </a:solidFill>
                 <a:latin typeface="Calibri"/>
               </a:rPr>
-              <a:t>Kegagalan: RR 0,48 (0,15–1,52). Gingiva: MD −0,32 (−0,42 sampai −0,23). Biaya, wear antagonis, sulit direparasi.</a:t>
+              <a:t>Kegagalan klinis tidak berbeda bermakna dari SSC (RR 0,48; 95% CI 0,15–1,52), tetapi gingiva lebih sehat (MD −0,32). Biayanya lebih tinggi, menimbulkan keausan antagonis, dan sulit direparasi.</a:t>
             </a:r>
           </a:p>
         </p:txBody>
@@ -9763,7 +9763,7 @@
                 </a:solidFill>
                 <a:latin typeface="Calibri"/>
               </a:rPr>
-              <a:t>Retensi 6 bulan 95% (Walia 2014). Veneer bisa fraktur. Bukti belum cukup menggantikan SSC.</a:t>
+              <a:t>Crown masih terpasang pada 95% gigi setelah 6 bulan (Walia 2014). Veneernya bisa fraktur, dan buktinya belum cukup untuk menggantikan SSC.</a:t>
             </a:r>
           </a:p>
         </p:txBody>
@@ -9895,7 +9895,7 @@
                 </a:solidFill>
                 <a:latin typeface="Calibri"/>
               </a:rPr>
-              <a:t>Retensi 6 bulan 78% (Walia 2014). Sensitif kelembapan. Bukan pilihan utama molar posterior.</a:t>
+              <a:t>Crown masih terpasang pada 78% gigi setelah 6 bulan (Walia 2014). Tekniknya sensitif kelembapan, dan bukan pilihan pertama untuk molar posterior.</a:t>
             </a:r>
           </a:p>
         </p:txBody>
@@ -10051,7 +10051,7 @@
                 </a:solidFill>
                 <a:latin typeface="Calibri"/>
               </a:rPr>
-              <a:t>Retensi 6 bulan</a:t>
+              <a:t>Crown yang masih terpasang setelah 6 bulan</a:t>
             </a:r>
           </a:p>
         </p:txBody>
@@ -12689,7 +12689,7 @@
                 </a:solidFill>
                 <a:latin typeface="Calibri"/>
               </a:rPr>
-              <a:t>1. Nyeri spontan malam, molar desidui. Hall atau konvensional?</a:t>
+              <a:t>1. Molar desidui dengan nyeri spontan malam: Hall atau SSC konvensional?</a:t>
             </a:r>
           </a:p>
         </p:txBody>
@@ -12779,7 +12779,7 @@
                 </a:solidFill>
                 <a:latin typeface="Calibri"/>
               </a:rPr>
-              <a:t>2. Berapa reduksi oklusal yang paling banyak dipakai?</a:t>
+              <a:t>2. Pada molar desidui, berapa reduksi oklusal yang dianjurkan UK guideline?</a:t>
             </a:r>
           </a:p>
         </p:txBody>
@@ -13091,7 +13091,7 @@
                 </a:solidFill>
                 <a:latin typeface="Calibri"/>
               </a:rPr>
-              <a:t>Jawaban: 1 konvensional, 2 1,0–1,5 mm, 3 periksa ledge, 4 kontur dan crimping, 5 SSC.</a:t>
+              <a:t>Kunci jawaban: 1 SSC konvensional setelah pulpektomi, 2 reduksi 1,0–1,5 mm, 3 periksa ledge dan sisa kontak, 4 kontur dan crimping margin, 5 SSC.</a:t>
             </a:r>
           </a:p>
         </p:txBody>
@@ -13640,7 +13640,7 @@
                 </a:solidFill>
                 <a:latin typeface="Georgia"/>
               </a:rPr>
-              <a:t>SSC menutup seluruh mahkota</a:t>
+              <a:t>SSC menutup seluruh permukaan gigi</a:t>
             </a:r>
           </a:p>
         </p:txBody>
@@ -13682,7 +13682,7 @@
                 </a:solidFill>
                 <a:latin typeface="Calibri"/>
               </a:rPr>
-              <a:t>Retensi dari margin dan undercut servikal. Crimping lebih menentukan daripada semen.</a:t>
+              <a:t>Retensinya berasal dari margin dan undercut servikal, dan crimping margin lebih menentukan daripada jenis semen.</a:t>
             </a:r>
           </a:p>
         </p:txBody>
@@ -13814,7 +13814,7 @@
                 </a:solidFill>
                 <a:latin typeface="Georgia"/>
               </a:rPr>
-              <a:t>Hall hanya untuk gigi vital dengan dentine bridge jelas</a:t>
+              <a:t>Hall hanya untuk gigi vital dengan dentine bridge yang jelas</a:t>
             </a:r>
           </a:p>
         </p:txBody>
@@ -13856,7 +13856,7 @@
                 </a:solidFill>
                 <a:latin typeface="Calibri"/>
               </a:rPr>
-              <a:t>Nyeri spontan atau abses mengubah rencana. Pilih konvensional setelah pulp therapy.</a:t>
+              <a:t>Nyeri spontan atau abses mengubah rencana, sehingga SSC konvensional dipasang setelah perawatan pulpa.</a:t>
             </a:r>
           </a:p>
         </p:txBody>
@@ -14030,7 +14030,7 @@
                 </a:solidFill>
                 <a:latin typeface="Calibri"/>
               </a:rPr>
-              <a:t>Success, survival, dan retention bukan hal yang sama.</a:t>
+              <a:t>Angka keberhasilan, angka gigi yang masih bertahan, dan angka crown yang masih terpasang mengukur hal berbeda.</a:t>
             </a:r>
           </a:p>
         </p:txBody>
@@ -16149,7 +16149,7 @@
                 </a:solidFill>
                 <a:latin typeface="Calibri"/>
               </a:rPr>
-              <a:t>□  Riwayat nyeri, swelling, fistula</a:t>
+              <a:t>□  Riwayat nyeri dan fistula</a:t>
             </a:r>
           </a:p>
         </p:txBody>
@@ -16989,7 +16989,7 @@
                 </a:solidFill>
                 <a:latin typeface="Calibri"/>
               </a:rPr>
-              <a:t>□  Vital, dentine bridge jelas</a:t>
+              <a:t>□  Gigi vital, dentine bridge jelas</a:t>
             </a:r>
           </a:p>
         </p:txBody>
@@ -17199,7 +17199,7 @@
                 </a:solidFill>
                 <a:latin typeface="Calibri"/>
               </a:rPr>
-              <a:t>□  Sukses, gagal minor, gagal mayor</a:t>
+              <a:t>□  Berhasil, gagal minor, gagal mayor</a:t>
             </a:r>
           </a:p>
         </p:txBody>
@@ -17331,7 +17331,7 @@
                 </a:solidFill>
                 <a:latin typeface="Calibri"/>
               </a:rPr>
-              <a:t>•  Success SSC 96,1% (Chisini 2018)</a:t>
+              <a:t>•  Keberhasilan SSC 96,1% (Chisini 2018)</a:t>
             </a:r>
           </a:p>
         </p:txBody>
@@ -17373,7 +17373,7 @@
                 </a:solidFill>
                 <a:latin typeface="Calibri"/>
               </a:rPr>
-              <a:t>•  Gagal mayor RR 0,18 (Cochrane 2015)</a:t>
+              <a:t>•  Gagal mayor: RR 0,18 (Cochrane 2015)</a:t>
             </a:r>
           </a:p>
         </p:txBody>
@@ -17589,7 +17589,7 @@
                 </a:solidFill>
                 <a:latin typeface="Calibri"/>
               </a:rPr>
-              <a:t>•  Longgar: ukuran lebih kecil, crimp ulang</a:t>
+              <a:t>•  Longgar: pilih ukuran lebih kecil, crimp ulang</a:t>
             </a:r>
           </a:p>
         </p:txBody>
@@ -17631,7 +17631,7 @@
                 </a:solidFill>
                 <a:latin typeface="Calibri"/>
               </a:rPr>
-              <a:t>•  Tidak duduk: periksa ledge dan kontak</a:t>
+              <a:t>•  Tidak duduk: periksa ledge dan sisa kontak</a:t>
             </a:r>
           </a:p>
         </p:txBody>
@@ -17715,7 +17715,7 @@
                 </a:solidFill>
                 <a:latin typeface="Calibri"/>
               </a:rPr>
-              <a:t>•  Lepas: recement bila crown intak</a:t>
+              <a:t>•  Lepas: sementasi ulang bila crown intak</a:t>
             </a:r>
           </a:p>
         </p:txBody>
@@ -18301,7 +18301,7 @@
                 </a:solidFill>
                 <a:latin typeface="Calibri"/>
               </a:rPr>
-              <a:t>Restorasi yang gagal berulang</a:t>
+              <a:t>Tambalan yang gagal berulang</a:t>
             </a:r>
           </a:p>
         </p:txBody>
@@ -18940,7 +18940,7 @@
                 </a:solidFill>
                 <a:latin typeface="Calibri"/>
               </a:rPr>
-              <a:t>Gigi desidui dan preparasi</a:t>
+              <a:t>Anatomi dan preparasi</a:t>
             </a:r>
           </a:p>
         </p:txBody>
@@ -19579,7 +19579,7 @@
                 </a:solidFill>
                 <a:latin typeface="Calibri"/>
               </a:rPr>
-              <a:t>Perbandingan dan penyulit</a:t>
+              <a:t>Konvensional dan Hall dibandingkan</a:t>
             </a:r>
           </a:p>
         </p:txBody>
@@ -20451,7 +20451,7 @@
                 </a:solidFill>
                 <a:latin typeface="Georgia"/>
               </a:rPr>
-              <a:t>Tambalan berulang gagal pada gigi yang sama</a:t>
+              <a:t>Tambalan yang gagal berulang pada gigi yang sama</a:t>
             </a:r>
           </a:p>
         </p:txBody>
@@ -20726,7 +20726,7 @@
                 </a:solidFill>
                 <a:latin typeface="Calibri"/>
               </a:rPr>
-              <a:t>Tepi terbuka, karies kembali</a:t>
+              <a:t>Tepi tambalan terbuka dan karies muncul lagi</a:t>
             </a:r>
           </a:p>
         </p:txBody>
@@ -20902,7 +20902,7 @@
                 </a:solidFill>
                 <a:latin typeface="Calibri"/>
               </a:rPr>
-              <a:t>Karies sekunder</a:t>
+              <a:t>Karies sekunder terbentuk di bawah tambalan</a:t>
             </a:r>
           </a:p>
         </p:txBody>
@@ -21078,7 +21078,7 @@
                 </a:solidFill>
                 <a:latin typeface="Calibri"/>
               </a:rPr>
-              <a:t>Nyeri, pulpa terlibat</a:t>
+              <a:t>Nyeri muncul karena pulpa sudah terlibat</a:t>
             </a:r>
           </a:p>
         </p:txBody>
@@ -21204,7 +21204,7 @@
                 </a:solidFill>
                 <a:latin typeface="Calibri"/>
               </a:rPr>
-              <a:t>Enamel gigi desidui sekitar 1 mm, dentin tipis, tanduk pulpa tinggi. Kapan berhenti menambal dan menutup seluruh gigi?</a:t>
+              <a:t>Enamel gigi desidui hanya sekitar 1 mm, dentinnya tipis, dan tanduk pulpanya tinggi. Kapan kita berhenti menambal dan mulai menutup seluruh gigi?</a:t>
             </a:r>
           </a:p>
         </p:txBody>
@@ -21843,7 +21843,7 @@
                 </a:solidFill>
                 <a:latin typeface="Calibri"/>
               </a:rPr>
-              <a:t>success SSC pada 12 bulan, 31 studi</a:t>
+              <a:t>angka keberhasilan SSC, 31 studi</a:t>
             </a:r>
           </a:p>
         </p:txBody>
@@ -22017,7 +22017,7 @@
                 </a:solidFill>
                 <a:latin typeface="Calibri"/>
               </a:rPr>
-              <a:t>RR kegagalan mayor vs tambalan (95% CI 0,06–0,56)</a:t>
+              <a:t>risiko kegagalan mayor crown dibanding tambalan (95% CI 0,06–0,56)</a:t>
             </a:r>
           </a:p>
         </p:txBody>
@@ -22191,7 +22191,7 @@
                 </a:solidFill>
                 <a:latin typeface="Calibri"/>
               </a:rPr>
-              <a:t>success Hall vs 52% kontrol pada 60 bulan</a:t>
+              <a:t>Hall 92%, kontrol 52%, pada 60 bulan</a:t>
             </a:r>
           </a:p>
         </p:txBody>
@@ -22431,7 +22431,7 @@
                 </a:solidFill>
                 <a:latin typeface="Calibri"/>
               </a:rPr>
-              <a:t>Undercut di bawah bulbositas menahan crown, bukan semen.</a:t>
+              <a:t>Undercut di bawah bulbositas servikal menahan crown; semen hanya menutup margin.</a:t>
             </a:r>
           </a:p>
         </p:txBody>
@@ -22563,7 +22563,7 @@
                 </a:solidFill>
                 <a:latin typeface="Calibri"/>
               </a:rPr>
-              <a:t>Logam menahan gaya oklusal pada dinding tipis.</a:t>
+              <a:t>Logam menahan gaya oklusal pada dinding gigi yang tipis.</a:t>
             </a:r>
           </a:p>
         </p:txBody>
@@ -22695,7 +22695,7 @@
                 </a:solidFill>
                 <a:latin typeface="Calibri"/>
               </a:rPr>
-              <a:t>Biaya awal lebih tinggi, retreatment lebih rendah.</a:t>
+              <a:t>Biaya awalnya lebih tinggi, tetapi perawatan ulang lebih jarang.</a:t>
             </a:r>
           </a:p>
         </p:txBody>
@@ -23244,7 +23244,7 @@
                 </a:solidFill>
                 <a:latin typeface="Calibri"/>
               </a:rPr>
-              <a:t>•  Lebih dari 2 permukaan, atau melewati line angle</a:t>
+              <a:t>•  Karies lebih dari 2 permukaan, atau melewati line angle</a:t>
             </a:r>
           </a:p>
           <a:p>
@@ -23263,7 +23263,7 @@
                 </a:solidFill>
                 <a:latin typeface="Calibri"/>
               </a:rPr>
-              <a:t>•  Setelah pulpotomi atau pulpektomi</a:t>
+              <a:t>•  Gigi setelah pulpotomi atau pulpektomi</a:t>
             </a:r>
           </a:p>
           <a:p>
@@ -23282,7 +23282,7 @@
                 </a:solidFill>
                 <a:latin typeface="Calibri"/>
               </a:rPr>
-              <a:t>•  Hipoplasia, MIH, fraktur, atrisi</a:t>
+              <a:t>•  Hipoplasia, MIH, fraktur, atau atrisi</a:t>
             </a:r>
           </a:p>
           <a:p>
@@ -23301,7 +23301,7 @@
                 </a:solidFill>
                 <a:latin typeface="Calibri"/>
               </a:rPr>
-              <a:t>•  Abutment space maintainer, risiko karies tinggi</a:t>
+              <a:t>•  Abutment space maintainer atau risiko karies tinggi</a:t>
             </a:r>
           </a:p>
         </p:txBody>
@@ -23433,7 +23433,7 @@
                 </a:solidFill>
                 <a:latin typeface="Calibri"/>
               </a:rPr>
-              <a:t>•  Lebih dari setengah akar teresorpsi, alergi nikel</a:t>
+              <a:t>•  Resorpsi akar lebih dari setengah, atau alergi nikel</a:t>
             </a:r>
           </a:p>
           <a:p>
@@ -23452,7 +23452,7 @@
                 </a:solidFill>
                 <a:latin typeface="Calibri"/>
               </a:rPr>
-              <a:t>•  Gigi tidak restorable</a:t>
+              <a:t>•  Gigi tidak dapat direstorasi</a:t>
             </a:r>
           </a:p>
           <a:p>
@@ -23471,7 +23471,7 @@
                 </a:solidFill>
                 <a:latin typeface="Calibri"/>
               </a:rPr>
-              <a:t>•  Hall: nyeri spontan, abses, fistula, tanpa dentine bridge</a:t>
+              <a:t>•  Hall tidak dipakai bila ada nyeri spontan, abses, fistula, atau dentine bridge tidak terlihat</a:t>
             </a:r>
           </a:p>
         </p:txBody>
@@ -23737,7 +23737,7 @@
                 </a:solidFill>
                 <a:latin typeface="Calibri"/>
               </a:rPr>
-              <a:t>Tanda pulpa ireversibel?  Ya: pulpektomi atau ekstraksi, lalu SSC bila gigi dipertahankan.</a:t>
+              <a:t>Tanda pulpa ireversibel? Ya: pulpektomi atau ekstraksi, lalu SSC bila gigi dipertahankan.</a:t>
             </a:r>
           </a:p>
         </p:txBody>
@@ -24005,7 +24005,7 @@
                 </a:solidFill>
                 <a:latin typeface="Calibri"/>
               </a:rPr>
-              <a:t>Bukan kandidat SSC: gigi tidak restorable, akar teresorpsi, alergi nikel.</a:t>
+              <a:t>Tidak memenuhi syarat SSC: gigi tidak dapat direstorasi, akar teresorpsi, atau alergi nikel.</a:t>
             </a:r>
           </a:p>
         </p:txBody>
@@ -24554,7 +24554,7 @@
                 </a:solidFill>
                 <a:latin typeface="Calibri"/>
               </a:rPr>
-              <a:t>Undercut di bawah bulbositas menahan crown.</a:t>
+              <a:t>Crown ditahan oleh undercut di bawah bulbositas servikal.</a:t>
             </a:r>
           </a:p>
         </p:txBody>
@@ -24686,7 +24686,7 @@
                 </a:solidFill>
                 <a:latin typeface="Calibri"/>
               </a:rPr>
-              <a:t>Hanya bila kontur menghalangi seating.</a:t>
+              <a:t>Dikurangi hanya bila konturnya menghalangi crown duduk.</a:t>
             </a:r>
           </a:p>
         </p:txBody>
@@ -24776,7 +24776,7 @@
                 </a:solidFill>
                 <a:latin typeface="Calibri"/>
               </a:rPr>
-              <a:t>Enamel 1 mm</a:t>
+              <a:t>Enamel hanya 1 mm</a:t>
             </a:r>
           </a:p>
         </p:txBody>
@@ -24818,7 +24818,7 @@
                 </a:solidFill>
                 <a:latin typeface="Calibri"/>
               </a:rPr>
-              <a:t>Reduksi oklusal 1,0–1,5 mm, atau 1,5–2,0 mm menurut sumber lain.</a:t>
+              <a:t>Reduksi oklusal 1,0–1,5 mm; sumber lain menyebut 1,5–2,0 mm untuk molar permanen.</a:t>
             </a:r>
           </a:p>
         </p:txBody>
@@ -24950,7 +24950,7 @@
                 </a:solidFill>
                 <a:latin typeface="Calibri"/>
               </a:rPr>
-              <a:t>Probe melewati kontak mesial dan distal.</a:t>
+              <a:t>Probe harus bisa melewati kontak mesial dan distal.</a:t>
             </a:r>
           </a:p>
         </p:txBody>
@@ -27296,7 +27296,7 @@
                 </a:solidFill>
                 <a:latin typeface="Calibri"/>
               </a:rPr>
-              <a:t>Nilai dan radiograf</a:t>
+              <a:t>Nilai kondisi gigi dan radiograf</a:t>
             </a:r>
           </a:p>
         </p:txBody>
@@ -27338,7 +27338,7 @@
                 </a:solidFill>
                 <a:latin typeface="Calibri"/>
               </a:rPr>
-              <a:t>Vital, dentine bridge jelas. Karies tidak dibuang.</a:t>
+              <a:t>Pastikan gigi vital dan dentine bridge terlihat; karies tidak dibuang.</a:t>
             </a:r>
           </a:p>
         </p:txBody>
@@ -27466,7 +27466,7 @@
                 </a:solidFill>
                 <a:latin typeface="Calibri"/>
               </a:rPr>
-              <a:t>Separator bila kontak ketat</a:t>
+              <a:t>Pasang separator bila kontak ketat</a:t>
             </a:r>
           </a:p>
         </p:txBody>
@@ -27508,7 +27508,7 @@
                 </a:solidFill>
                 <a:latin typeface="Calibri"/>
               </a:rPr>
-              <a:t>Mesial dan distal, 3–5 hari.</a:t>
+              <a:t>Pasang di mesial dan distal, lalu biarkan 3–5 hari.</a:t>
             </a:r>
           </a:p>
         </p:txBody>
@@ -27678,7 +27678,7 @@
                 </a:solidFill>
                 <a:latin typeface="Calibri"/>
               </a:rPr>
-              <a:t>Terkecil, menutup seluruh gigi, spring-back.</a:t>
+              <a:t>Pilih ukuran terkecil yang menutup seluruh gigi dan masih memberi spring-back.</a:t>
             </a:r>
           </a:p>
         </p:txBody>
@@ -27806,7 +27806,7 @@
                 </a:solidFill>
                 <a:latin typeface="Calibri"/>
               </a:rPr>
-              <a:t>Isi semen dua pertiga</a:t>
+              <a:t>Isi dua pertiga crown dengan semen</a:t>
             </a:r>
           </a:p>
         </p:txBody>
@@ -27848,7 +27848,7 @@
                 </a:solidFill>
                 <a:latin typeface="Calibri"/>
               </a:rPr>
-              <a:t>GIC atau RMGIC, semua dinding terlapisi.</a:t>
+              <a:t>Pakai GIC atau RMGIC, dan lapisi semua dinding crown.</a:t>
             </a:r>
           </a:p>
         </p:txBody>
@@ -27976,7 +27976,7 @@
                 </a:solidFill>
                 <a:latin typeface="Calibri"/>
               </a:rPr>
-              <a:t>Seating dan bite</a:t>
+              <a:t>Penempatan dan gigitan</a:t>
             </a:r>
           </a:p>
         </p:txBody>
@@ -28018,7 +28018,7 @@
                 </a:solidFill>
                 <a:latin typeface="Calibri"/>
               </a:rPr>
-              <a:t>Lindungi airway, gigit 2–3 menit.</a:t>
+              <a:t>Jaga airway tetap bebas, lalu anak menggigit 2–3 menit.</a:t>
             </a:r>
           </a:p>
         </p:txBody>
@@ -28152,7 +28152,7 @@
                 </a:solidFill>
                 <a:latin typeface="Calibri"/>
               </a:rPr>
-              <a:t>Batas Hall: bukan untuk pulpitis ireversibel, abses, fistula, atau tanpa dentine bridge.</a:t>
+              <a:t>Batas Hall: tidak dipakai pada pulpitis ireversibel, abses, fistula, atau gigi yang dentine bridge-nya tidak terlihat.</a:t>
             </a:r>
           </a:p>
         </p:txBody>

</xml_diff>

<commit_message>
Ganti istilah penyulit menjadi komplikasi di deck, catatan, protokol, dan README
Co-authored-by: arena-agent <297053741+arena-agent@users.noreply.github.com>
</commit_message>
<xml_diff>
--- a/deliverables/ssc-pedodonsia/ssc-pedodonsia.pptx
+++ b/deliverables/ssc-pedodonsia/ssc-pedodonsia.pptx
@@ -1007,7 +1007,7 @@
           <a:lstStyle/>
           <a:p>
             <a:r>
-              <a:t>Halaman ini bisa dicetak dan dibawa ke klinik. Semua langkah, kontraindikasi, penyulit, dan kriteria kontrol ada di satu halaman. Versi lengkap dengan tujuan, cara, instrumen, kesalahan, dan tanda benar ada di protokol_klinis.md.</a:t>
+              <a:t>Halaman ini bisa dicetak dan dibawa ke klinik. Semua langkah, kontraindikasi, komplikasi, dan kriteria kontrol ada di satu halaman. Versi lengkap dengan tujuan, cara, instrumen, kesalahan, dan tanda benar ada di protokol_klinis.md.</a:t>
             </a:r>
           </a:p>
         </p:txBody>
@@ -1077,7 +1077,7 @@
           <a:lstStyle/>
           <a:p>
             <a:r>
-              <a:t>Alurnya dari masalah ke solusi, lalu ke teknik dan bukti. Bagian lima adalah inti keterampilan: sepuluh langkah konvensional yang bisa dibuka satu per satu. Bagian enam membahas penyulit dan cara mencegahnya, bagian tujuh bukti dan alternatif estetik. Saya akan berhenti di bagian kasus untuk keputusan bersama, jadi sisakan waktu di sana.</a:t>
+              <a:t>Alurnya dari masalah ke solusi, lalu ke teknik dan bukti. Bagian lima adalah inti keterampilan: sepuluh langkah konvensional yang bisa dibuka satu per satu. Bagian enam membahas komplikasi dan cara mencegahnya, bagian tujuh bukti dan alternatif estetik. Saya akan berhenti di bagian kasus untuk keputusan bersama, jadi sisakan waktu di sana.</a:t>
             </a:r>
           </a:p>
         </p:txBody>
@@ -1497,7 +1497,7 @@
           <a:lstStyle/>
           <a:p>
             <a:r>
-              <a:t>Enam penyulit ini hampir semuanya bisa dilacak ke preparasi atau pemilihan ukuran. Crown longgar berarti crimping kurang, bukan semen kurang. Crown tidak duduk hampir selalu karena ledge atau kontak yang belum putus. Perdarahan saat try-in berarti margin terlalu panjang. Soal alergi nikel, angkanya sering ditakutkan berlebihan: sensitisasi pada anak Eropa sekitar delapan sampai sepuluh persen, tetapi reaksi klinis terhadap SSC jarang. Yang perlu diingat: jangan menambal masalah adaptasi dengan semen lebih banyak, dan jangan recement gigi yang sudah tidak restorable. Pencegahan paling murah ada di preparasi: putuskan kontak sepenuhnya, haluskan ledge, dan verifikasi dengan probe sebelum crown dicoba. Pada tiap kontrol, periksa margin, oklusi, kontak, gingiva, mobilitas, dan tanda perforasi oklusal.</a:t>
+              <a:t>Enam komplikasi ini hampir semuanya bisa dilacak ke preparasi atau pemilihan ukuran. Crown longgar berarti crimping kurang, bukan semen kurang. Crown tidak duduk hampir selalu karena ledge atau kontak yang belum putus. Perdarahan saat try-in berarti margin terlalu panjang. Soal alergi nikel, angkanya sering ditakutkan berlebihan: sensitisasi pada anak Eropa sekitar delapan sampai sepuluh persen, tetapi reaksi klinis terhadap SSC jarang. Yang perlu diingat: jangan menambal masalah adaptasi dengan semen lebih banyak, dan jangan recement gigi yang sudah tidak restorable. Pencegahan paling murah ada di preparasi: putuskan kontak sepenuhnya, haluskan ledge, dan verifikasi dengan probe sebelum crown dicoba. Pada tiap kontrol, periksa margin, oklusi, kontak, gingiva, mobilitas, dan tanda perforasi oklusal.</a:t>
             </a:r>
           </a:p>
         </p:txBody>
@@ -8580,7 +8580,7 @@
                 </a:solidFill>
                 <a:latin typeface="Georgia"/>
               </a:rPr>
-              <a:t>Lima soal menguji keputusan pada penyulit umum</a:t>
+              <a:t>Lima soal menguji keputusan saat komplikasi muncul</a:t>
             </a:r>
           </a:p>
         </p:txBody>
@@ -13533,7 +13533,7 @@
                 </a:solidFill>
                 <a:latin typeface="Calibri"/>
               </a:rPr>
-              <a:t>PENYULIT DAN TINDAKAN</a:t>
+              <a:t>KOMPLIKASI DAN TINDAKAN</a:t>
             </a:r>
           </a:p>
         </p:txBody>
@@ -15352,7 +15352,7 @@
                 </a:solidFill>
                 <a:latin typeface="Calibri"/>
               </a:rPr>
-              <a:t>Penyulit dan pencegahan</a:t>
+              <a:t>Komplikasi dan pencegahan</a:t>
             </a:r>
           </a:p>
         </p:txBody>
@@ -22844,7 +22844,7 @@
                 </a:solidFill>
                 <a:latin typeface="Calibri"/>
               </a:rPr>
-              <a:t>PENYULIT</a:t>
+              <a:t>KOMPLIKASI</a:t>
             </a:r>
           </a:p>
         </p:txBody>
@@ -22886,7 +22886,7 @@
                 </a:solidFill>
                 <a:latin typeface="Georgia"/>
               </a:rPr>
-              <a:t>Penyulit SSC bisa dicegah di langkah preparasi</a:t>
+              <a:t>Komplikasi SSC bisa dicegah di langkah preparasi</a:t>
             </a:r>
           </a:p>
         </p:txBody>

</xml_diff>

<commit_message>
Sebut MIH secara panjang pada kemunculan pertama dan jelaskan artinya di deck, kuis, dan protokol
Co-authored-by: arena-agent <297053741+arena-agent@users.noreply.github.com>
</commit_message>
<xml_diff>
--- a/deliverables/ssc-pedodonsia/ssc-pedodonsia.pptx
+++ b/deliverables/ssc-pedodonsia/ssc-pedodonsia.pptx
@@ -1497,7 +1497,7 @@
           <a:lstStyle/>
           <a:p>
             <a:r>
-              <a:t>Enam komplikasi ini hampir semuanya bisa dilacak ke preparasi atau pemilihan ukuran. Crown longgar berarti crimping kurang, bukan semen kurang. Crown tidak duduk hampir selalu karena ledge atau kontak yang belum putus. Perdarahan saat try-in berarti margin terlalu panjang. Soal alergi nikel, angkanya sering ditakutkan berlebihan: sensitisasi pada anak Eropa sekitar delapan sampai sepuluh persen, tetapi reaksi klinis terhadap SSC jarang. Yang perlu diingat: jangan menambal masalah adaptasi dengan semen lebih banyak, dan jangan recement gigi yang sudah tidak restorable. Pencegahan paling murah ada di preparasi: putuskan kontak sepenuhnya, haluskan ledge, dan verifikasi dengan probe sebelum crown dicoba. Pada tiap kontrol, periksa margin, oklusi, kontak, gingiva, mobilitas, dan tanda perforasi oklusal.</a:t>
+              <a:t>Enam komplikasi ini hampir semuanya bisa dilacak ke preparasi atau pemilihan ukuran. Crown longgar berarti crimping kurang, bukan semen kurang. Crown tidak duduk hampir selalu karena ledge atau kontak yang belum putus. Perdarahan saat try-in berarti margin terlalu panjang. Soal MIH, singkat saja: itu kelainan enamel sejak masa perkembangan, molar pertama permanen rapuh dan hipersensitif, dan crown menutup seluruh permukaan gigi. Soal alergi nikel, angkanya sering ditakutkan berlebihan: sensitisasi pada anak Eropa sekitar delapan sampai sepuluh persen, tetapi reaksi klinis terhadap SSC jarang. Yang perlu diingat: jangan menambal masalah adaptasi dengan semen lebih banyak, dan jangan recement gigi yang sudah tidak restorable. Pencegahan paling murah ada di preparasi: putuskan kontak sepenuhnya, haluskan ledge, dan verifikasi dengan probe sebelum crown dicoba. Pada tiap kontrol, periksa margin, oklusi, kontak, gingiva, mobilitas, dan tanda perforasi oklusal.</a:t>
             </a:r>
           </a:p>
         </p:txBody>
@@ -9129,7 +9129,7 @@
                 </a:solidFill>
                 <a:latin typeface="Calibri"/>
               </a:rPr>
-              <a:t>5. MIH berat pada molar permanen. Pilihan dengan bukti terkuat?</a:t>
+              <a:t>5. Anak dengan MIH berat pada molar pertama permanen: perawatan dengan bukti terkuat?</a:t>
             </a:r>
           </a:p>
         </p:txBody>
@@ -13443,7 +13443,7 @@
                 </a:solidFill>
                 <a:latin typeface="Calibri"/>
               </a:rPr>
-              <a:t>•  MIH: SSC 94,4% vs 49,2% (Farias 2022)</a:t>
+              <a:t>•  MIH: SSC 94,4% dan 49,2% (Farias 2022)</a:t>
             </a:r>
           </a:p>
         </p:txBody>
@@ -19055,7 +19055,7 @@
                 </a:solidFill>
                 <a:latin typeface="Calibri"/>
               </a:rPr>
-              <a:t>•  Hipoplasia, MIH, fraktur, atau atrisi</a:t>
+              <a:t>•  Hipoplasia, hipomineralisasi molar-insisivus (MIH), fraktur, atau atrisi</a:t>
             </a:r>
           </a:p>
           <a:p>
@@ -23999,7 +23999,7 @@
                 </a:solidFill>
                 <a:latin typeface="Calibri"/>
               </a:rPr>
-              <a:t>MIH</a:t>
+              <a:t>Hipomineralisasi molar-insisivus (MIH)</a:t>
             </a:r>
           </a:p>
         </p:txBody>
@@ -24041,7 +24041,7 @@
                 </a:solidFill>
                 <a:latin typeface="Calibri"/>
               </a:rPr>
-              <a:t>SSC bertahan pada 94,4% gigi, komposit 49,2%, setelah 24 bulan.</a:t>
+              <a:t>Enamel molar pertama permanen rapuh sejak erupsi, sehingga SSC bertahan pada 94,4% gigi, komposit 49,2%, setelah 24 bulan.</a:t>
             </a:r>
           </a:p>
         </p:txBody>
@@ -26334,7 +26334,7 @@
                 </a:solidFill>
                 <a:latin typeface="Calibri"/>
               </a:rPr>
-              <a:t>SSC bertahan pada MIH, komposit 49,2%, 24 bulan</a:t>
+              <a:t>SSC bertahan pada gigi dengan MIH, komposit 49,2%, 24 bulan</a:t>
             </a:r>
           </a:p>
         </p:txBody>

</xml_diff>

<commit_message>
Tambah ilustrasi skematik kasus dan perjelas panel indikasi serta kontraindikasi
Co-authored-by: arena-agent <297053741+arena-agent@users.noreply.github.com>
</commit_message>
<xml_diff>
--- a/deliverables/ssc-pedodonsia/ssc-pedodonsia.pptx
+++ b/deliverables/ssc-pedodonsia/ssc-pedodonsia.pptx
@@ -7069,7 +7069,7 @@
       <p:sp>
         <p:nvSpPr>
           <p:cNvPr id="7" name="Rounded Rectangle 6">
-            <a:hlinkClick action="ppaction://hlinksldjump" r:id="rId3"/>
+            <a:hlinkClick action="ppaction://hlinksldjump" r:id="rId5"/>
           </p:cNvPr>
           <p:cNvSpPr/>
           <p:nvPr/>
@@ -7251,55 +7251,30 @@
           </a:p>
         </p:txBody>
       </p:sp>
-      <p:sp>
-        <p:nvSpPr>
-          <p:cNvPr id="10" name="Rounded Rectangle 9"/>
-          <p:cNvSpPr/>
-          <p:nvPr/>
-        </p:nvSpPr>
-        <p:spPr>
-          <a:xfrm>
-            <a:off x="566928" y="3639312"/>
-            <a:ext cx="2651760" cy="1325880"/>
-          </a:xfrm>
-          <a:prstGeom prst="roundRect">
-            <a:avLst>
-              <a:gd name="adj" fmla="val 8000"/>
-            </a:avLst>
-          </a:prstGeom>
-          <a:solidFill>
-            <a:srgbClr val="F6EFE2"/>
-          </a:solidFill>
-          <a:ln w="12700">
-            <a:solidFill>
-              <a:srgbClr val="C9B9A1"/>
-            </a:solidFill>
-            <a:prstDash val="dash"/>
-          </a:ln>
-          <a:effectLst/>
-        </p:spPr>
-        <p:style>
-          <a:lnRef idx="1">
-            <a:schemeClr val="accent1"/>
-          </a:lnRef>
-          <a:fillRef idx="3">
-            <a:schemeClr val="accent1"/>
-          </a:fillRef>
-          <a:effectRef idx="2">
-            <a:schemeClr val="accent1"/>
-          </a:effectRef>
-          <a:fontRef idx="minor">
-            <a:schemeClr val="lt1"/>
-          </a:fontRef>
-        </p:style>
-        <p:txBody>
-          <a:bodyPr rtlCol="0" anchor="ctr"/>
-          <a:lstStyle/>
-          <a:p>
-            <a:pPr algn="ctr"/>
-          </a:p>
-        </p:txBody>
-      </p:sp>
+      <p:pic>
+        <p:nvPicPr>
+          <p:cNvPr id="10" name="Picture 9" descr="fig-case-oklusal.jpg"/>
+          <p:cNvPicPr>
+            <a:picLocks noChangeAspect="1"/>
+          </p:cNvPicPr>
+          <p:nvPr/>
+        </p:nvPicPr>
+        <p:blipFill>
+          <a:blip r:embed="rId2"/>
+          <a:stretch>
+            <a:fillRect/>
+          </a:stretch>
+        </p:blipFill>
+        <p:spPr>
+          <a:xfrm>
+            <a:off x="566928" y="3584448"/>
+            <a:ext cx="1896237" cy="1444752"/>
+          </a:xfrm>
+          <a:prstGeom prst="rect">
+            <a:avLst/>
+          </a:prstGeom>
+        </p:spPr>
+      </p:pic>
       <p:sp>
         <p:nvSpPr>
           <p:cNvPr id="11" name="TextBox 10"/>
@@ -7308,21 +7283,129 @@
         </p:nvSpPr>
         <p:spPr>
           <a:xfrm>
-            <a:off x="658368" y="4009644"/>
-            <a:ext cx="2468879" cy="256032"/>
-          </a:xfrm>
-          <a:prstGeom prst="rect">
-            <a:avLst/>
-          </a:prstGeom>
-          <a:noFill/>
-        </p:spPr>
-        <p:txBody>
-          <a:bodyPr wrap="square" lIns="0" rIns="0" tIns="0" bIns="0" anchor="t">
-            <a:spAutoFit/>
-          </a:bodyPr>
-          <a:lstStyle/>
-          <a:p>
-            <a:pPr algn="ctr">
+            <a:off x="566928" y="5084064"/>
+            <a:ext cx="2304288" cy="402336"/>
+          </a:xfrm>
+          <a:prstGeom prst="rect">
+            <a:avLst/>
+          </a:prstGeom>
+          <a:noFill/>
+        </p:spPr>
+        <p:txBody>
+          <a:bodyPr wrap="square" lIns="0" rIns="0" tIns="0" bIns="0" anchor="t">
+            <a:spAutoFit/>
+          </a:bodyPr>
+          <a:lstStyle/>
+          <a:p>
+            <a:pPr algn="l">
+              <a:lnSpc>
+                <a:spcPct val="105000"/>
+              </a:lnSpc>
+              <a:spcAft>
+                <a:spcPts val="0"/>
+              </a:spcAft>
+            </a:pPr>
+            <a:r>
+              <a:rPr sz="760" b="0" i="0">
+                <a:solidFill>
+                  <a:srgbClr val="47646C"/>
+                </a:solidFill>
+                <a:latin typeface="Calibri"/>
+              </a:rPr>
+              <a:t>Pandangan oklusal: karies oklusal-distal, dinding mesial utuh.</a:t>
+            </a:r>
+          </a:p>
+        </p:txBody>
+      </p:sp>
+      <p:pic>
+        <p:nvPicPr>
+          <p:cNvPr id="12" name="Picture 11" descr="fig-case-bitewing.jpg"/>
+          <p:cNvPicPr>
+            <a:picLocks noChangeAspect="1"/>
+          </p:cNvPicPr>
+          <p:nvPr/>
+        </p:nvPicPr>
+        <p:blipFill>
+          <a:blip r:embed="rId3"/>
+          <a:stretch>
+            <a:fillRect/>
+          </a:stretch>
+        </p:blipFill>
+        <p:spPr>
+          <a:xfrm>
+            <a:off x="2962656" y="3584448"/>
+            <a:ext cx="1896237" cy="1444752"/>
+          </a:xfrm>
+          <a:prstGeom prst="rect">
+            <a:avLst/>
+          </a:prstGeom>
+        </p:spPr>
+      </p:pic>
+      <p:sp>
+        <p:nvSpPr>
+          <p:cNvPr id="13" name="TextBox 12"/>
+          <p:cNvSpPr txBox="1"/>
+          <p:nvPr/>
+        </p:nvSpPr>
+        <p:spPr>
+          <a:xfrm>
+            <a:off x="2962656" y="5084064"/>
+            <a:ext cx="2304288" cy="402336"/>
+          </a:xfrm>
+          <a:prstGeom prst="rect">
+            <a:avLst/>
+          </a:prstGeom>
+          <a:noFill/>
+        </p:spPr>
+        <p:txBody>
+          <a:bodyPr wrap="square" lIns="0" rIns="0" tIns="0" bIns="0" anchor="t">
+            <a:spAutoFit/>
+          </a:bodyPr>
+          <a:lstStyle/>
+          <a:p>
+            <a:pPr algn="l">
+              <a:lnSpc>
+                <a:spcPct val="105000"/>
+              </a:lnSpc>
+              <a:spcAft>
+                <a:spcPts val="0"/>
+              </a:spcAft>
+            </a:pPr>
+            <a:r>
+              <a:rPr sz="760" b="0" i="0">
+                <a:solidFill>
+                  <a:srgbClr val="47646C"/>
+                </a:solidFill>
+                <a:latin typeface="Calibri"/>
+              </a:rPr>
+              <a:t>Skema bitewing: lesi mendekati pulpa, dentine bridge terlihat.</a:t>
+            </a:r>
+          </a:p>
+        </p:txBody>
+      </p:sp>
+      <p:sp>
+        <p:nvSpPr>
+          <p:cNvPr id="14" name="TextBox 13"/>
+          <p:cNvSpPr txBox="1"/>
+          <p:nvPr/>
+        </p:nvSpPr>
+        <p:spPr>
+          <a:xfrm>
+            <a:off x="566928" y="5541264"/>
+            <a:ext cx="5394960" cy="274320"/>
+          </a:xfrm>
+          <a:prstGeom prst="rect">
+            <a:avLst/>
+          </a:prstGeom>
+          <a:noFill/>
+        </p:spPr>
+        <p:txBody>
+          <a:bodyPr wrap="square" lIns="0" rIns="0" tIns="0" bIns="0" anchor="t">
+            <a:spAutoFit/>
+          </a:bodyPr>
+          <a:lstStyle/>
+          <a:p>
+            <a:pPr algn="l">
               <a:lnSpc>
                 <a:spcPct val="112000"/>
               </a:lnSpc>
@@ -7331,146 +7414,13 @@
               </a:spcAft>
             </a:pPr>
             <a:r>
-              <a:rPr sz="1050" b="1" i="0">
-                <a:solidFill>
-                  <a:srgbClr val="6F624E"/>
-                </a:solidFill>
-                <a:latin typeface="Calibri"/>
-              </a:rPr>
-              <a:t>Foto klinis</a:t>
-            </a:r>
-          </a:p>
-        </p:txBody>
-      </p:sp>
-      <p:sp>
-        <p:nvSpPr>
-          <p:cNvPr id="12" name="TextBox 11"/>
-          <p:cNvSpPr txBox="1"/>
-          <p:nvPr/>
-        </p:nvSpPr>
-        <p:spPr>
-          <a:xfrm>
-            <a:off x="676656" y="4283964"/>
-            <a:ext cx="2432304" cy="457200"/>
-          </a:xfrm>
-          <a:prstGeom prst="rect">
-            <a:avLst/>
-          </a:prstGeom>
-          <a:noFill/>
-        </p:spPr>
-        <p:txBody>
-          <a:bodyPr wrap="square" lIns="0" rIns="0" tIns="0" bIns="0" anchor="t">
-            <a:spAutoFit/>
-          </a:bodyPr>
-          <a:lstStyle/>
-          <a:p>
-            <a:pPr algn="ctr">
-              <a:lnSpc>
-                <a:spcPct val="112000"/>
-              </a:lnSpc>
-              <a:spcAft>
-                <a:spcPts val="0"/>
-              </a:spcAft>
-            </a:pPr>
-            <a:r>
-              <a:rPr sz="850" b="0" i="0">
-                <a:solidFill>
-                  <a:srgbClr val="8A7A62"/>
-                </a:solidFill>
-                <a:latin typeface="Calibri"/>
-              </a:rPr>
-              <a:t>Okusal gigi 85. Ganti dengan foto Anda.</a:t>
-            </a:r>
-          </a:p>
-        </p:txBody>
-      </p:sp>
-      <p:sp>
-        <p:nvSpPr>
-          <p:cNvPr id="13" name="Rounded Rectangle 12"/>
-          <p:cNvSpPr/>
-          <p:nvPr/>
-        </p:nvSpPr>
-        <p:spPr>
-          <a:xfrm>
-            <a:off x="3401568" y="3639312"/>
-            <a:ext cx="2651760" cy="1325880"/>
-          </a:xfrm>
-          <a:prstGeom prst="roundRect">
-            <a:avLst>
-              <a:gd name="adj" fmla="val 8000"/>
-            </a:avLst>
-          </a:prstGeom>
-          <a:solidFill>
-            <a:srgbClr val="F6EFE2"/>
-          </a:solidFill>
-          <a:ln w="12700">
-            <a:solidFill>
-              <a:srgbClr val="C9B9A1"/>
-            </a:solidFill>
-            <a:prstDash val="dash"/>
-          </a:ln>
-          <a:effectLst/>
-        </p:spPr>
-        <p:style>
-          <a:lnRef idx="1">
-            <a:schemeClr val="accent1"/>
-          </a:lnRef>
-          <a:fillRef idx="3">
-            <a:schemeClr val="accent1"/>
-          </a:fillRef>
-          <a:effectRef idx="2">
-            <a:schemeClr val="accent1"/>
-          </a:effectRef>
-          <a:fontRef idx="minor">
-            <a:schemeClr val="lt1"/>
-          </a:fontRef>
-        </p:style>
-        <p:txBody>
-          <a:bodyPr rtlCol="0" anchor="ctr"/>
-          <a:lstStyle/>
-          <a:p>
-            <a:pPr algn="ctr"/>
-          </a:p>
-        </p:txBody>
-      </p:sp>
-      <p:sp>
-        <p:nvSpPr>
-          <p:cNvPr id="14" name="TextBox 13"/>
-          <p:cNvSpPr txBox="1"/>
-          <p:nvPr/>
-        </p:nvSpPr>
-        <p:spPr>
-          <a:xfrm>
-            <a:off x="3493008" y="4009644"/>
-            <a:ext cx="2468879" cy="256032"/>
-          </a:xfrm>
-          <a:prstGeom prst="rect">
-            <a:avLst/>
-          </a:prstGeom>
-          <a:noFill/>
-        </p:spPr>
-        <p:txBody>
-          <a:bodyPr wrap="square" lIns="0" rIns="0" tIns="0" bIns="0" anchor="t">
-            <a:spAutoFit/>
-          </a:bodyPr>
-          <a:lstStyle/>
-          <a:p>
-            <a:pPr algn="ctr">
-              <a:lnSpc>
-                <a:spcPct val="112000"/>
-              </a:lnSpc>
-              <a:spcAft>
-                <a:spcPts val="0"/>
-              </a:spcAft>
-            </a:pPr>
-            <a:r>
-              <a:rPr sz="1050" b="1" i="0">
-                <a:solidFill>
-                  <a:srgbClr val="6F624E"/>
-                </a:solidFill>
-                <a:latin typeface="Calibri"/>
-              </a:rPr>
-              <a:t>Radiograf</a:t>
+              <a:rPr sz="760" b="0" i="0">
+                <a:solidFill>
+                  <a:srgbClr val="7D8F93"/>
+                </a:solidFill>
+                <a:latin typeface="Calibri"/>
+              </a:rPr>
+              <a:t>Data fiktif. Gambar ini ilustrasi skematik, bukan foto atau radiograf pasien.</a:t>
             </a:r>
           </a:p>
         </p:txBody>
@@ -7478,90 +7428,6 @@
       <p:sp>
         <p:nvSpPr>
           <p:cNvPr id="15" name="TextBox 14"/>
-          <p:cNvSpPr txBox="1"/>
-          <p:nvPr/>
-        </p:nvSpPr>
-        <p:spPr>
-          <a:xfrm>
-            <a:off x="3511296" y="4283964"/>
-            <a:ext cx="2432304" cy="457200"/>
-          </a:xfrm>
-          <a:prstGeom prst="rect">
-            <a:avLst/>
-          </a:prstGeom>
-          <a:noFill/>
-        </p:spPr>
-        <p:txBody>
-          <a:bodyPr wrap="square" lIns="0" rIns="0" tIns="0" bIns="0" anchor="t">
-            <a:spAutoFit/>
-          </a:bodyPr>
-          <a:lstStyle/>
-          <a:p>
-            <a:pPr algn="ctr">
-              <a:lnSpc>
-                <a:spcPct val="112000"/>
-              </a:lnSpc>
-              <a:spcAft>
-                <a:spcPts val="0"/>
-              </a:spcAft>
-            </a:pPr>
-            <a:r>
-              <a:rPr sz="850" b="0" i="0">
-                <a:solidFill>
-                  <a:srgbClr val="8A7A62"/>
-                </a:solidFill>
-                <a:latin typeface="Calibri"/>
-              </a:rPr>
-              <a:t>Bitewing gigi 85. Ganti dengan radiograf Anda.</a:t>
-            </a:r>
-          </a:p>
-        </p:txBody>
-      </p:sp>
-      <p:sp>
-        <p:nvSpPr>
-          <p:cNvPr id="16" name="TextBox 15"/>
-          <p:cNvSpPr txBox="1"/>
-          <p:nvPr/>
-        </p:nvSpPr>
-        <p:spPr>
-          <a:xfrm>
-            <a:off x="566928" y="5074920"/>
-            <a:ext cx="5394960" cy="274320"/>
-          </a:xfrm>
-          <a:prstGeom prst="rect">
-            <a:avLst/>
-          </a:prstGeom>
-          <a:noFill/>
-        </p:spPr>
-        <p:txBody>
-          <a:bodyPr wrap="square" lIns="0" rIns="0" tIns="0" bIns="0" anchor="t">
-            <a:spAutoFit/>
-          </a:bodyPr>
-          <a:lstStyle/>
-          <a:p>
-            <a:pPr algn="l">
-              <a:lnSpc>
-                <a:spcPct val="112000"/>
-              </a:lnSpc>
-              <a:spcAft>
-                <a:spcPts val="0"/>
-              </a:spcAft>
-            </a:pPr>
-            <a:r>
-              <a:rPr sz="800" b="0" i="0">
-                <a:solidFill>
-                  <a:srgbClr val="7D8F93"/>
-                </a:solidFill>
-                <a:latin typeface="Calibri"/>
-              </a:rPr>
-              <a:t>Data fiktif untuk latihan keputusan.</a:t>
-            </a:r>
-          </a:p>
-        </p:txBody>
-      </p:sp>
-      <p:sp>
-        <p:nvSpPr>
-          <p:cNvPr id="17" name="TextBox 16"/>
           <p:cNvSpPr txBox="1"/>
           <p:nvPr/>
         </p:nvSpPr>
@@ -7603,7 +7469,7 @@
       </p:sp>
       <p:sp>
         <p:nvSpPr>
-          <p:cNvPr id="18" name="Rounded Rectangle 17"/>
+          <p:cNvPr id="16" name="Rounded Rectangle 15"/>
           <p:cNvSpPr/>
           <p:nvPr/>
         </p:nvSpPr>
@@ -7651,7 +7517,7 @@
       </p:sp>
       <p:sp>
         <p:nvSpPr>
-          <p:cNvPr id="19" name="TextBox 18"/>
+          <p:cNvPr id="17" name="TextBox 16"/>
           <p:cNvSpPr txBox="1"/>
           <p:nvPr/>
         </p:nvSpPr>
@@ -7693,7 +7559,7 @@
       </p:sp>
       <p:sp>
         <p:nvSpPr>
-          <p:cNvPr id="20" name="Rounded Rectangle 19"/>
+          <p:cNvPr id="18" name="Rounded Rectangle 17"/>
           <p:cNvSpPr/>
           <p:nvPr/>
         </p:nvSpPr>
@@ -7741,7 +7607,7 @@
       </p:sp>
       <p:sp>
         <p:nvSpPr>
-          <p:cNvPr id="21" name="TextBox 20"/>
+          <p:cNvPr id="19" name="TextBox 18"/>
           <p:cNvSpPr txBox="1"/>
           <p:nvPr/>
         </p:nvSpPr>
@@ -7783,7 +7649,7 @@
       </p:sp>
       <p:sp>
         <p:nvSpPr>
-          <p:cNvPr id="22" name="Rounded Rectangle 21"/>
+          <p:cNvPr id="20" name="Rounded Rectangle 19"/>
           <p:cNvSpPr/>
           <p:nvPr/>
         </p:nvSpPr>
@@ -7831,7 +7697,7 @@
       </p:sp>
       <p:sp>
         <p:nvSpPr>
-          <p:cNvPr id="23" name="TextBox 22"/>
+          <p:cNvPr id="21" name="TextBox 20"/>
           <p:cNvSpPr txBox="1"/>
           <p:nvPr/>
         </p:nvSpPr>
@@ -7873,7 +7739,7 @@
       </p:sp>
       <p:sp>
         <p:nvSpPr>
-          <p:cNvPr id="24" name="TextBox 23"/>
+          <p:cNvPr id="22" name="TextBox 21"/>
           <p:cNvSpPr txBox="1"/>
           <p:nvPr/>
         </p:nvSpPr>
@@ -7915,7 +7781,7 @@
       </p:sp>
       <p:sp>
         <p:nvSpPr>
-          <p:cNvPr id="25" name="TextBox 24"/>
+          <p:cNvPr id="23" name="TextBox 22"/>
           <p:cNvSpPr txBox="1"/>
           <p:nvPr/>
         </p:nvSpPr>
@@ -7957,7 +7823,7 @@
       </p:sp>
       <p:sp>
         <p:nvSpPr>
-          <p:cNvPr id="26" name="Rounded Rectangle 25"/>
+          <p:cNvPr id="24" name="Rounded Rectangle 23"/>
           <p:cNvSpPr/>
           <p:nvPr/>
         </p:nvSpPr>
@@ -8005,7 +7871,7 @@
       </p:sp>
       <p:sp>
         <p:nvSpPr>
-          <p:cNvPr id="27" name="TextBox 26"/>
+          <p:cNvPr id="25" name="TextBox 24"/>
           <p:cNvSpPr txBox="1"/>
           <p:nvPr/>
         </p:nvSpPr>
@@ -8047,7 +7913,7 @@
       </p:sp>
       <p:sp>
         <p:nvSpPr>
-          <p:cNvPr id="28" name="Rounded Rectangle 27"/>
+          <p:cNvPr id="26" name="Rounded Rectangle 25"/>
           <p:cNvSpPr/>
           <p:nvPr/>
         </p:nvSpPr>
@@ -8095,7 +7961,7 @@
       </p:sp>
       <p:sp>
         <p:nvSpPr>
-          <p:cNvPr id="29" name="TextBox 28"/>
+          <p:cNvPr id="27" name="TextBox 26"/>
           <p:cNvSpPr txBox="1"/>
           <p:nvPr/>
         </p:nvSpPr>
@@ -8137,7 +8003,7 @@
       </p:sp>
       <p:sp>
         <p:nvSpPr>
-          <p:cNvPr id="30" name="Rounded Rectangle 29"/>
+          <p:cNvPr id="28" name="Rounded Rectangle 27"/>
           <p:cNvSpPr/>
           <p:nvPr/>
         </p:nvSpPr>
@@ -8185,7 +8051,7 @@
       </p:sp>
       <p:sp>
         <p:nvSpPr>
-          <p:cNvPr id="31" name="TextBox 30"/>
+          <p:cNvPr id="29" name="TextBox 28"/>
           <p:cNvSpPr txBox="1"/>
           <p:nvPr/>
         </p:nvSpPr>
@@ -8227,7 +8093,7 @@
       </p:sp>
       <p:sp>
         <p:nvSpPr>
-          <p:cNvPr id="32" name="TextBox 31"/>
+          <p:cNvPr id="30" name="TextBox 29"/>
           <p:cNvSpPr txBox="1"/>
           <p:nvPr/>
         </p:nvSpPr>
@@ -8269,7 +8135,7 @@
       </p:sp>
       <p:sp>
         <p:nvSpPr>
-          <p:cNvPr id="33" name="Rectangle 32"/>
+          <p:cNvPr id="31" name="Rectangle 30"/>
           <p:cNvSpPr/>
           <p:nvPr/>
         </p:nvSpPr>
@@ -8313,7 +8179,7 @@
       </p:sp>
       <p:sp>
         <p:nvSpPr>
-          <p:cNvPr id="34" name="TextBox 33"/>
+          <p:cNvPr id="32" name="TextBox 31"/>
           <p:cNvSpPr txBox="1"/>
           <p:nvPr/>
         </p:nvSpPr>
@@ -8355,7 +8221,7 @@
       </p:sp>
       <p:sp>
         <p:nvSpPr>
-          <p:cNvPr id="35" name="TextBox 34"/>
+          <p:cNvPr id="33" name="TextBox 32"/>
           <p:cNvSpPr txBox="1"/>
           <p:nvPr/>
         </p:nvSpPr>
@@ -18969,13 +18835,13 @@
               </a:spcAft>
             </a:pPr>
             <a:r>
-              <a:rPr sz="1200" b="1" i="0">
-                <a:solidFill>
-                  <a:srgbClr val="C65B45"/>
-                </a:solidFill>
-                <a:latin typeface="Calibri"/>
-              </a:rPr>
-              <a:t>Pilih SSC</a:t>
+              <a:rPr sz="1000" b="1" i="0" spc="120">
+                <a:solidFill>
+                  <a:srgbClr val="22605C"/>
+                </a:solidFill>
+                <a:latin typeface="Calibri"/>
+              </a:rPr>
+              <a:t>INDIKASI</a:t>
             </a:r>
           </a:p>
         </p:txBody>
@@ -19004,77 +18870,96 @@
           <a:p>
             <a:pPr algn="l">
               <a:lnSpc>
-                <a:spcPct val="120000"/>
-              </a:lnSpc>
-              <a:spcAft>
-                <a:spcPts val="0"/>
-              </a:spcAft>
-            </a:pPr>
-            <a:r>
-              <a:rPr sz="1050" b="0" i="0">
+                <a:spcPct val="122000"/>
+              </a:lnSpc>
+              <a:spcAft>
+                <a:spcPts val="0"/>
+              </a:spcAft>
+            </a:pPr>
+            <a:r>
+              <a:rPr sz="1000" b="0" i="0">
                 <a:solidFill>
                   <a:srgbClr val="47646C"/>
                 </a:solidFill>
                 <a:latin typeface="Calibri"/>
               </a:rPr>
-              <a:t>•  Karies lebih dari 2 permukaan, atau melewati line angle</a:t>
+              <a:t>1.  Karies melewati line angle atau lebih dari 2 permukaan</a:t>
             </a:r>
           </a:p>
           <a:p>
             <a:pPr algn="l">
               <a:lnSpc>
-                <a:spcPct val="120000"/>
-              </a:lnSpc>
-              <a:spcAft>
-                <a:spcPts val="0"/>
-              </a:spcAft>
-            </a:pPr>
-            <a:r>
-              <a:rPr sz="1050" b="0" i="0">
+                <a:spcPct val="122000"/>
+              </a:lnSpc>
+              <a:spcAft>
+                <a:spcPts val="0"/>
+              </a:spcAft>
+            </a:pPr>
+            <a:r>
+              <a:rPr sz="1000" b="0" i="0">
                 <a:solidFill>
                   <a:srgbClr val="47646C"/>
                 </a:solidFill>
                 <a:latin typeface="Calibri"/>
               </a:rPr>
-              <a:t>•  Gigi setelah pulpotomi atau pulpektomi</a:t>
+              <a:t>2.  Gigi setelah pulpotomi atau pulpektomi</a:t>
             </a:r>
           </a:p>
           <a:p>
             <a:pPr algn="l">
               <a:lnSpc>
-                <a:spcPct val="120000"/>
-              </a:lnSpc>
-              <a:spcAft>
-                <a:spcPts val="0"/>
-              </a:spcAft>
-            </a:pPr>
-            <a:r>
-              <a:rPr sz="1050" b="0" i="0">
+                <a:spcPct val="122000"/>
+              </a:lnSpc>
+              <a:spcAft>
+                <a:spcPts val="0"/>
+              </a:spcAft>
+            </a:pPr>
+            <a:r>
+              <a:rPr sz="1000" b="0" i="0">
                 <a:solidFill>
                   <a:srgbClr val="47646C"/>
                 </a:solidFill>
                 <a:latin typeface="Calibri"/>
               </a:rPr>
-              <a:t>•  Hipoplasia, hipomineralisasi molar-insisivus (MIH), fraktur, atau atrisi</a:t>
+              <a:t>3.  Hipoplasia, hipomineralisasi molar-insisivus (MIH), fraktur, atrisi</a:t>
             </a:r>
           </a:p>
           <a:p>
             <a:pPr algn="l">
               <a:lnSpc>
-                <a:spcPct val="120000"/>
-              </a:lnSpc>
-              <a:spcAft>
-                <a:spcPts val="0"/>
-              </a:spcAft>
-            </a:pPr>
-            <a:r>
-              <a:rPr sz="1050" b="0" i="0">
+                <a:spcPct val="122000"/>
+              </a:lnSpc>
+              <a:spcAft>
+                <a:spcPts val="0"/>
+              </a:spcAft>
+            </a:pPr>
+            <a:r>
+              <a:rPr sz="1000" b="0" i="0">
                 <a:solidFill>
                   <a:srgbClr val="47646C"/>
                 </a:solidFill>
                 <a:latin typeface="Calibri"/>
               </a:rPr>
-              <a:t>•  Abutment space maintainer atau risiko karies tinggi</a:t>
+              <a:t>4.  Abutment space maintainer</a:t>
+            </a:r>
+          </a:p>
+          <a:p>
+            <a:pPr algn="l">
+              <a:lnSpc>
+                <a:spcPct val="122000"/>
+              </a:lnSpc>
+              <a:spcAft>
+                <a:spcPts val="0"/>
+              </a:spcAft>
+            </a:pPr>
+            <a:r>
+              <a:rPr sz="1000" b="0" i="0">
+                <a:solidFill>
+                  <a:srgbClr val="47646C"/>
+                </a:solidFill>
+                <a:latin typeface="Calibri"/>
+              </a:rPr>
+              <a:t>5.  Risiko karies tinggi atau perawatan dengan sedasi</a:t>
             </a:r>
           </a:p>
         </p:txBody>
@@ -19158,13 +19043,13 @@
               </a:spcAft>
             </a:pPr>
             <a:r>
-              <a:rPr sz="1200" b="1" i="0">
-                <a:solidFill>
-                  <a:srgbClr val="2C6E6A"/>
-                </a:solidFill>
-                <a:latin typeface="Calibri"/>
-              </a:rPr>
-              <a:t>Batas dan kontraindikasi</a:t>
+              <a:rPr sz="1000" b="1" i="0" spc="120">
+                <a:solidFill>
+                  <a:srgbClr val="A3462F"/>
+                </a:solidFill>
+                <a:latin typeface="Calibri"/>
+              </a:rPr>
+              <a:t>KONTRAINDIKASI</a:t>
             </a:r>
           </a:p>
         </p:txBody>
@@ -19193,58 +19078,77 @@
           <a:p>
             <a:pPr algn="l">
               <a:lnSpc>
-                <a:spcPct val="120000"/>
-              </a:lnSpc>
-              <a:spcAft>
-                <a:spcPts val="0"/>
-              </a:spcAft>
-            </a:pPr>
-            <a:r>
-              <a:rPr sz="1050" b="0" i="0">
+                <a:spcPct val="124000"/>
+              </a:lnSpc>
+              <a:spcAft>
+                <a:spcPts val="0"/>
+              </a:spcAft>
+            </a:pPr>
+            <a:r>
+              <a:rPr sz="1000" b="0" i="0">
                 <a:solidFill>
                   <a:srgbClr val="47646C"/>
                 </a:solidFill>
                 <a:latin typeface="Calibri"/>
               </a:rPr>
-              <a:t>•  Resorpsi akar lebih dari setengah, atau alergi nikel</a:t>
+              <a:t>1.  Resorpsi akar lebih dari setengah</a:t>
             </a:r>
           </a:p>
           <a:p>
             <a:pPr algn="l">
               <a:lnSpc>
-                <a:spcPct val="120000"/>
-              </a:lnSpc>
-              <a:spcAft>
-                <a:spcPts val="0"/>
-              </a:spcAft>
-            </a:pPr>
-            <a:r>
-              <a:rPr sz="1050" b="0" i="0">
+                <a:spcPct val="124000"/>
+              </a:lnSpc>
+              <a:spcAft>
+                <a:spcPts val="0"/>
+              </a:spcAft>
+            </a:pPr>
+            <a:r>
+              <a:rPr sz="1000" b="0" i="0">
                 <a:solidFill>
                   <a:srgbClr val="47646C"/>
                 </a:solidFill>
                 <a:latin typeface="Calibri"/>
               </a:rPr>
-              <a:t>•  Gigi tidak dapat direstorasi</a:t>
+              <a:t>2.  Alergi nikel yang diketahui</a:t>
             </a:r>
           </a:p>
           <a:p>
             <a:pPr algn="l">
               <a:lnSpc>
-                <a:spcPct val="120000"/>
-              </a:lnSpc>
-              <a:spcAft>
-                <a:spcPts val="0"/>
-              </a:spcAft>
-            </a:pPr>
-            <a:r>
-              <a:rPr sz="1050" b="0" i="0">
+                <a:spcPct val="124000"/>
+              </a:lnSpc>
+              <a:spcAft>
+                <a:spcPts val="0"/>
+              </a:spcAft>
+            </a:pPr>
+            <a:r>
+              <a:rPr sz="1000" b="0" i="0">
                 <a:solidFill>
                   <a:srgbClr val="47646C"/>
                 </a:solidFill>
                 <a:latin typeface="Calibri"/>
               </a:rPr>
-              <a:t>•  Pulpa ireversibel: terapi pulpa lebih dulu, SSC dipasang setelahnya</a:t>
+              <a:t>3.  Gigi tidak dapat direstorasi</a:t>
+            </a:r>
+          </a:p>
+          <a:p>
+            <a:pPr algn="l">
+              <a:lnSpc>
+                <a:spcPct val="124000"/>
+              </a:lnSpc>
+              <a:spcAft>
+                <a:spcPts val="0"/>
+              </a:spcAft>
+            </a:pPr>
+            <a:r>
+              <a:rPr sz="1000" b="0" i="0">
+                <a:solidFill>
+                  <a:srgbClr val="47646C"/>
+                </a:solidFill>
+                <a:latin typeface="Calibri"/>
+              </a:rPr>
+              <a:t>4.  Pulpa ireversibel belum diterapi</a:t>
             </a:r>
           </a:p>
         </p:txBody>

</xml_diff>

<commit_message>
Isi nama pemateri dan tanggal pada slide pembuka
Co-authored-by: arena-agent <297053741+arena-agent@users.noreply.github.com>
</commit_message>
<xml_diff>
--- a/deliverables/ssc-pedodonsia/ssc-pedodonsia.pptx
+++ b/deliverables/ssc-pedodonsia/ssc-pedodonsia.pptx
@@ -4930,7 +4930,7 @@
         <p:spPr>
           <a:xfrm>
             <a:off x="1636776" y="4224528"/>
-            <a:ext cx="1600200" cy="310896"/>
+            <a:ext cx="1901952" cy="310896"/>
           </a:xfrm>
           <a:prstGeom prst="roundRect">
             <a:avLst>
@@ -4978,7 +4978,7 @@
         <p:spPr>
           <a:xfrm>
             <a:off x="1636776" y="4261104"/>
-            <a:ext cx="1600200" cy="237744"/>
+            <a:ext cx="1901952" cy="237744"/>
           </a:xfrm>
           <a:prstGeom prst="rect">
             <a:avLst/>
@@ -5006,7 +5006,7 @@
                 </a:solidFill>
                 <a:latin typeface="Calibri"/>
               </a:rPr>
-              <a:t>Pemateri: [nama]</a:t>
+              <a:t>Pemateri: Galeka Ali Prasetya</a:t>
             </a:r>
           </a:p>
         </p:txBody>
@@ -5019,8 +5019,8 @@
         </p:nvSpPr>
         <p:spPr>
           <a:xfrm>
-            <a:off x="3346704" y="4224528"/>
-            <a:ext cx="1005840" cy="310896"/>
+            <a:off x="3648456" y="4224528"/>
+            <a:ext cx="1234440" cy="310896"/>
           </a:xfrm>
           <a:prstGeom prst="roundRect">
             <a:avLst>
@@ -5067,8 +5067,8 @@
         </p:nvSpPr>
         <p:spPr>
           <a:xfrm>
-            <a:off x="3346704" y="4261104"/>
-            <a:ext cx="1005840" cy="237744"/>
+            <a:off x="3648456" y="4261104"/>
+            <a:ext cx="1234440" cy="237744"/>
           </a:xfrm>
           <a:prstGeom prst="rect">
             <a:avLst/>
@@ -5096,7 +5096,7 @@
                 </a:solidFill>
                 <a:latin typeface="Calibri"/>
               </a:rPr>
-              <a:t>[tanggal]</a:t>
+              <a:t>20 Oktober 2026</a:t>
             </a:r>
           </a:p>
         </p:txBody>

</xml_diff>

<commit_message>
Tulis ulang kartu preparasi dengan kalimat yang bisa dibaca
Co-authored-by: arena-agent <297053741+arena-agent@users.noreply.github.com>
</commit_message>
<xml_diff>
--- a/deliverables/ssc-pedodonsia/ssc-pedodonsia.pptx
+++ b/deliverables/ssc-pedodonsia/ssc-pedodonsia.pptx
@@ -1287,7 +1287,7 @@
           <a:lstStyle/>
           <a:p>
             <a:r>
-              <a:t>Alur ini dipakai untuk memilih restorasi. Kalau karies sudah lebih dari dua permukaan atau melewati line angle, restorasi langsung sulit dipertahankan, jadi arahnya ke SSC. Sebelum menyiapkan gigi, periksa tanda pulpitis ireversibel: nyeri spontan, absen, atau fistula. Bila ada, pulpanya diterapi lebih dulu, baru SSC dipasang bila gigi masih layak dipertahankan. Kalau karies hanya satu permukaan dan risiko kariesnya rendah, restorasi langsung masih wajar. Tiga hal yang harus siap sebelum preparasi: anestesi adekuat, isolasi, dan crown dengan beberapa ukuran.</a:t>
+              <a:t>Alur ini dipakai untuk memilih restorasi. Line angle itu garis tempat dua bidang gigi bertemu; begitu karies melewatinya, tambalan langsung kehilangan dinding untuk berpegangan. Jadi kalau karies sudah lebih dari dua permukaan atau melewati garis itu, arahnya ke SSC. Sebelum menyiapkan gigi, periksa tanda pulpitis ireversibel: nyeri spontan, absen, atau fistula. Bila ada, pulpanya diterapi lebih dulu, baru SSC dipasang bila gigi masih layak dipertahankan. Kalau karies hanya satu permukaan dan risiko kariesnya rendah, restorasi langsung masih wajar. Tiga hal yang harus siap sebelum preparasi: anestesi adekuat, isolasi, dan crown dengan beberapa ukuran.</a:t>
             </a:r>
           </a:p>
         </p:txBody>
@@ -1357,7 +1357,7 @@
           <a:lstStyle/>
           <a:p>
             <a:r>
-              <a:t>Ini yang sering salah pada preparasi. Kita cenderung mengurangi bukal dan lingual karena ingin crown mudah masuk, padahal retensi SSC justru berasal dari undercut servikal. Jadi pertahankan bulbositas, potong proksimal sampai kontak putus, dan berhenti dengan feather edge. Perhatikan juga angka reduksi oklusal: sumber UK memakai satu sampai satu setengah milimeter, sedangkan StatPearls dan Randall untuk molar permanen memakai satu setengah sampai dua milimeter.</a:t>
+              <a:t>Ini yang sering salah pada preparasi. Kita cenderung mengurangi bukal dan lingual karena ingin crown mudah masuk, padahal retensi SSC justru berasal dari undercut servikal. Jadi tonjolan servikalnya dipertahankan, proksimal dipotong sampai kontak dengan gigi sebelah terbuka, dan preparasinya berhenti dengan tepi tipis tanpa undakan. Perhatikan juga angka reduksi oklusal: sumber UK memakai satu sampai satu setengah milimeter, sedangkan StatPearls dan Randall untuk molar permanen memakai satu setengah sampai dua milimeter.</a:t>
             </a:r>
           </a:p>
         </p:txBody>
@@ -9802,7 +9802,7 @@
                 </a:solidFill>
                 <a:latin typeface="Calibri"/>
               </a:rPr>
-              <a:t>Kontak proksimal harus putus, line angle dihaluskan, dan margin berada 1 mm di bawah gingiva.</a:t>
+              <a:t>Kontak dengan gigi tetangga harus terbuka, sudut pertemuan dua bidang dibulatkan, dan margin berada 1 mm di bawah gingiva.</a:t>
             </a:r>
           </a:p>
         </p:txBody>
@@ -18070,7 +18070,7 @@
                 </a:solidFill>
                 <a:latin typeface="Calibri"/>
               </a:rPr>
-              <a:t>Undercut di bawah bulbositas servikal menahan crown; semen hanya menutup margin.</a:t>
+              <a:t>Cekungan di bawah tonjolan servikal (undercut) menahan crown; semen hanya menutup margin.</a:t>
             </a:r>
           </a:p>
         </p:txBody>
@@ -20189,7 +20189,7 @@
                 </a:solidFill>
                 <a:latin typeface="Calibri"/>
               </a:rPr>
-              <a:t>Retensi ada di servikal</a:t>
+              <a:t>Permukaan bukal dan lingual dibiarkan utuh</a:t>
             </a:r>
           </a:p>
         </p:txBody>
@@ -20231,7 +20231,7 @@
                 </a:solidFill>
                 <a:latin typeface="Calibri"/>
               </a:rPr>
-              <a:t>Crown ditahan oleh undercut di bawah bulbositas servikal.</a:t>
+              <a:t>Sisi luar yang menghadap pipi dan sisi dalam yang menghadap lidah tidak dikurangi. Pengurangan hanya dilakukan bila ada tonjolan yang menahan crown.</a:t>
             </a:r>
           </a:p>
         </p:txBody>
@@ -20321,7 +20321,7 @@
                 </a:solidFill>
                 <a:latin typeface="Calibri"/>
               </a:rPr>
-              <a:t>Bukal dan lingual tidak rutin</a:t>
+              <a:t>Oklusal dikurangi 1,0–1,5 mm</a:t>
             </a:r>
           </a:p>
         </p:txBody>
@@ -20363,7 +20363,7 @@
                 </a:solidFill>
                 <a:latin typeface="Calibri"/>
               </a:rPr>
-              <a:t>Dikurangi hanya bila konturnya menghalangi crown duduk.</a:t>
+              <a:t>Sebagian sumber memakai 1,5–2,0 mm untuk molar permanen, sedangkan enamel desidui hanya sekitar 1 mm, jadi reduksi berlebih cepat mencapai dentin.</a:t>
             </a:r>
           </a:p>
         </p:txBody>
@@ -20453,7 +20453,7 @@
                 </a:solidFill>
                 <a:latin typeface="Calibri"/>
               </a:rPr>
-              <a:t>Enamel hanya 1 mm</a:t>
+              <a:t>Sudut pertemuan dua bidang dibulatkan</a:t>
             </a:r>
           </a:p>
         </p:txBody>
@@ -20495,7 +20495,7 @@
                 </a:solidFill>
                 <a:latin typeface="Calibri"/>
               </a:rPr>
-              <a:t>Reduksi oklusal 1,0–1,5 mm; sumber lain menyebut 1,5–2,0 mm untuk molar permanen.</a:t>
+              <a:t>Line angle adalah garis tempat dua bidang gigi bertemu. Sudut tajam di sana menahan crown saat try-in.</a:t>
             </a:r>
           </a:p>
         </p:txBody>
@@ -20585,7 +20585,7 @@
                 </a:solidFill>
                 <a:latin typeface="Calibri"/>
               </a:rPr>
-              <a:t>Kontak harus putus</a:t>
+              <a:t>Kontak dengan gigi tetangga harus terbuka</a:t>
             </a:r>
           </a:p>
         </p:txBody>
@@ -20627,7 +20627,7 @@
                 </a:solidFill>
                 <a:latin typeface="Calibri"/>
               </a:rPr>
-              <a:t>Probe harus bisa melewati kontak mesial dan distal.</a:t>
+              <a:t>Probe harus bisa melewati celah mesial dan distal sebelum crown dicoba.</a:t>
             </a:r>
           </a:p>
         </p:txBody>

</xml_diff>